<commit_message>
Embed exact deck slide images
</commit_message>
<xml_diff>
--- a/CareerCloset_Pitch_2_Exact.pptx
+++ b/CareerCloset_Pitch_2_Exact.pptx
@@ -138,7 +138,7 @@
           <p:cNvPr id="2" name="Title 1">
             <a:extLst>
               <a:ext uri="{FF2B5EF4-FFF2-40B4-BE49-F238E27FC236}">
-                <a16:creationId xmlns:a16="http://schemas.microsoft.com/office/drawing/2014/main" id="{A94B57D5-5A49-F01C-3431-B2EA71A6A09D}"/>
+                <a16:creationId xmlns:a16="http://schemas.microsoft.com/office/drawing/2014/main" id="{019B52D7-7753-F114-9ADF-8942CF97C907}"/>
               </a:ext>
             </a:extLst>
           </p:cNvPr>
@@ -175,7 +175,7 @@
           <p:cNvPr id="3" name="Subtitle 2">
             <a:extLst>
               <a:ext uri="{FF2B5EF4-FFF2-40B4-BE49-F238E27FC236}">
-                <a16:creationId xmlns:a16="http://schemas.microsoft.com/office/drawing/2014/main" id="{48339F7B-C39B-CE2F-8CA1-0CE3AE80696F}"/>
+                <a16:creationId xmlns:a16="http://schemas.microsoft.com/office/drawing/2014/main" id="{BBA07F09-5BCB-437B-097C-19F4EE6605CE}"/>
               </a:ext>
             </a:extLst>
           </p:cNvPr>
@@ -245,7 +245,7 @@
           <p:cNvPr id="4" name="Date Placeholder 3">
             <a:extLst>
               <a:ext uri="{FF2B5EF4-FFF2-40B4-BE49-F238E27FC236}">
-                <a16:creationId xmlns:a16="http://schemas.microsoft.com/office/drawing/2014/main" id="{E056CA2F-EAED-26DF-27BA-CDCC3E28B0A3}"/>
+                <a16:creationId xmlns:a16="http://schemas.microsoft.com/office/drawing/2014/main" id="{699C782B-4273-7C93-6CA6-C9CB83AC3025}"/>
               </a:ext>
             </a:extLst>
           </p:cNvPr>
@@ -261,9 +261,9 @@
           <a:bodyPr/>
           <a:lstStyle/>
           <a:p>
-            <a:fld id="{A29D6AED-A3F2-4DDB-AB29-5BDBB7B2D1EC}" type="datetimeFigureOut">
+            <a:fld id="{12B4DC5E-5CE6-4800-B105-948B020CE4D7}" type="datetimeFigureOut">
               <a:rPr lang="en-US" smtClean="0"/>
-              <a:t>9/22/2026</a:t>
+              <a:t>9/23/2026</a:t>
             </a:fld>
             <a:endParaRPr lang="en-US"/>
           </a:p>
@@ -274,7 +274,7 @@
           <p:cNvPr id="5" name="Footer Placeholder 4">
             <a:extLst>
               <a:ext uri="{FF2B5EF4-FFF2-40B4-BE49-F238E27FC236}">
-                <a16:creationId xmlns:a16="http://schemas.microsoft.com/office/drawing/2014/main" id="{9F6BCBC6-EDAA-D619-7DB0-BFB0B8A39F1D}"/>
+                <a16:creationId xmlns:a16="http://schemas.microsoft.com/office/drawing/2014/main" id="{8F49E5EE-8CD5-EDC0-9E02-8FED98C3D53F}"/>
               </a:ext>
             </a:extLst>
           </p:cNvPr>
@@ -299,7 +299,7 @@
           <p:cNvPr id="6" name="Slide Number Placeholder 5">
             <a:extLst>
               <a:ext uri="{FF2B5EF4-FFF2-40B4-BE49-F238E27FC236}">
-                <a16:creationId xmlns:a16="http://schemas.microsoft.com/office/drawing/2014/main" id="{7137538A-A834-AC30-7664-EF085F268206}"/>
+                <a16:creationId xmlns:a16="http://schemas.microsoft.com/office/drawing/2014/main" id="{38717E14-F18B-5AF3-255E-4E41603BAE86}"/>
               </a:ext>
             </a:extLst>
           </p:cNvPr>
@@ -315,7 +315,7 @@
           <a:bodyPr/>
           <a:lstStyle/>
           <a:p>
-            <a:fld id="{22F4D96E-BE4E-4860-A9F5-F55433232C3A}" type="slidenum">
+            <a:fld id="{9CC4AB40-24CE-403C-8D90-29F002F94F66}" type="slidenum">
               <a:rPr lang="en-US" smtClean="0"/>
               <a:t>‹#›</a:t>
             </a:fld>
@@ -326,7 +326,7 @@
     </p:spTree>
     <p:extLst>
       <p:ext uri="{BB962C8B-B14F-4D97-AF65-F5344CB8AC3E}">
-        <p14:creationId xmlns:p14="http://schemas.microsoft.com/office/powerpoint/2010/main" val="1474140295"/>
+        <p14:creationId xmlns:p14="http://schemas.microsoft.com/office/powerpoint/2010/main" val="1829127715"/>
       </p:ext>
     </p:extLst>
   </p:cSld>
@@ -358,7 +358,7 @@
           <p:cNvPr id="2" name="Title 1">
             <a:extLst>
               <a:ext uri="{FF2B5EF4-FFF2-40B4-BE49-F238E27FC236}">
-                <a16:creationId xmlns:a16="http://schemas.microsoft.com/office/drawing/2014/main" id="{49186864-E59E-1FCF-7F3F-4947C6B8275A}"/>
+                <a16:creationId xmlns:a16="http://schemas.microsoft.com/office/drawing/2014/main" id="{D8EDA3C7-A0D8-E730-9E8F-C1764A871D6C}"/>
               </a:ext>
             </a:extLst>
           </p:cNvPr>
@@ -386,7 +386,7 @@
           <p:cNvPr id="3" name="Vertical Text Placeholder 2">
             <a:extLst>
               <a:ext uri="{FF2B5EF4-FFF2-40B4-BE49-F238E27FC236}">
-                <a16:creationId xmlns:a16="http://schemas.microsoft.com/office/drawing/2014/main" id="{1D4E8A39-E96B-EFB9-1FCD-F9D5ADA2BDF8}"/>
+                <a16:creationId xmlns:a16="http://schemas.microsoft.com/office/drawing/2014/main" id="{10ED9D83-161F-979C-9343-94D1402A9A00}"/>
               </a:ext>
             </a:extLst>
           </p:cNvPr>
@@ -443,7 +443,7 @@
           <p:cNvPr id="4" name="Date Placeholder 3">
             <a:extLst>
               <a:ext uri="{FF2B5EF4-FFF2-40B4-BE49-F238E27FC236}">
-                <a16:creationId xmlns:a16="http://schemas.microsoft.com/office/drawing/2014/main" id="{18DA2F85-46A9-ABAC-D1A2-8AA7FF93288D}"/>
+                <a16:creationId xmlns:a16="http://schemas.microsoft.com/office/drawing/2014/main" id="{6DE3163C-23B9-63E8-9BD1-A45C0E7179CA}"/>
               </a:ext>
             </a:extLst>
           </p:cNvPr>
@@ -459,9 +459,9 @@
           <a:bodyPr/>
           <a:lstStyle/>
           <a:p>
-            <a:fld id="{A29D6AED-A3F2-4DDB-AB29-5BDBB7B2D1EC}" type="datetimeFigureOut">
+            <a:fld id="{12B4DC5E-5CE6-4800-B105-948B020CE4D7}" type="datetimeFigureOut">
               <a:rPr lang="en-US" smtClean="0"/>
-              <a:t>9/22/2026</a:t>
+              <a:t>9/23/2026</a:t>
             </a:fld>
             <a:endParaRPr lang="en-US"/>
           </a:p>
@@ -472,7 +472,7 @@
           <p:cNvPr id="5" name="Footer Placeholder 4">
             <a:extLst>
               <a:ext uri="{FF2B5EF4-FFF2-40B4-BE49-F238E27FC236}">
-                <a16:creationId xmlns:a16="http://schemas.microsoft.com/office/drawing/2014/main" id="{64A4946A-61A4-F571-0B96-4FE4C5F8E2FC}"/>
+                <a16:creationId xmlns:a16="http://schemas.microsoft.com/office/drawing/2014/main" id="{2B8196C3-FF30-55DC-8334-0C9300796AD7}"/>
               </a:ext>
             </a:extLst>
           </p:cNvPr>
@@ -497,7 +497,7 @@
           <p:cNvPr id="6" name="Slide Number Placeholder 5">
             <a:extLst>
               <a:ext uri="{FF2B5EF4-FFF2-40B4-BE49-F238E27FC236}">
-                <a16:creationId xmlns:a16="http://schemas.microsoft.com/office/drawing/2014/main" id="{5F56F2EC-54A8-1EAB-A905-1770F6F5B250}"/>
+                <a16:creationId xmlns:a16="http://schemas.microsoft.com/office/drawing/2014/main" id="{7A3FF470-4C0D-C73E-28F2-8E797BE3E781}"/>
               </a:ext>
             </a:extLst>
           </p:cNvPr>
@@ -513,7 +513,7 @@
           <a:bodyPr/>
           <a:lstStyle/>
           <a:p>
-            <a:fld id="{22F4D96E-BE4E-4860-A9F5-F55433232C3A}" type="slidenum">
+            <a:fld id="{9CC4AB40-24CE-403C-8D90-29F002F94F66}" type="slidenum">
               <a:rPr lang="en-US" smtClean="0"/>
               <a:t>‹#›</a:t>
             </a:fld>
@@ -524,7 +524,7 @@
     </p:spTree>
     <p:extLst>
       <p:ext uri="{BB962C8B-B14F-4D97-AF65-F5344CB8AC3E}">
-        <p14:creationId xmlns:p14="http://schemas.microsoft.com/office/powerpoint/2010/main" val="3747577287"/>
+        <p14:creationId xmlns:p14="http://schemas.microsoft.com/office/powerpoint/2010/main" val="781541696"/>
       </p:ext>
     </p:extLst>
   </p:cSld>
@@ -556,7 +556,7 @@
           <p:cNvPr id="2" name="Vertical Title 1">
             <a:extLst>
               <a:ext uri="{FF2B5EF4-FFF2-40B4-BE49-F238E27FC236}">
-                <a16:creationId xmlns:a16="http://schemas.microsoft.com/office/drawing/2014/main" id="{4B42E290-4698-5E8C-1843-7F36F30DBDE9}"/>
+                <a16:creationId xmlns:a16="http://schemas.microsoft.com/office/drawing/2014/main" id="{80119E77-5BA2-0816-30F7-28EFCFFF914C}"/>
               </a:ext>
             </a:extLst>
           </p:cNvPr>
@@ -589,7 +589,7 @@
           <p:cNvPr id="3" name="Vertical Text Placeholder 2">
             <a:extLst>
               <a:ext uri="{FF2B5EF4-FFF2-40B4-BE49-F238E27FC236}">
-                <a16:creationId xmlns:a16="http://schemas.microsoft.com/office/drawing/2014/main" id="{847741A7-1F96-E86A-BFD2-3A44113871F4}"/>
+                <a16:creationId xmlns:a16="http://schemas.microsoft.com/office/drawing/2014/main" id="{E17E956E-6BA0-5A67-9E20-44AF18871E4D}"/>
               </a:ext>
             </a:extLst>
           </p:cNvPr>
@@ -651,7 +651,7 @@
           <p:cNvPr id="4" name="Date Placeholder 3">
             <a:extLst>
               <a:ext uri="{FF2B5EF4-FFF2-40B4-BE49-F238E27FC236}">
-                <a16:creationId xmlns:a16="http://schemas.microsoft.com/office/drawing/2014/main" id="{8BF84F9C-B5E0-26A7-4CEF-F2C07BE464C4}"/>
+                <a16:creationId xmlns:a16="http://schemas.microsoft.com/office/drawing/2014/main" id="{2E88699B-3376-6E74-7EF1-4A15751F5C65}"/>
               </a:ext>
             </a:extLst>
           </p:cNvPr>
@@ -667,9 +667,9 @@
           <a:bodyPr/>
           <a:lstStyle/>
           <a:p>
-            <a:fld id="{A29D6AED-A3F2-4DDB-AB29-5BDBB7B2D1EC}" type="datetimeFigureOut">
+            <a:fld id="{12B4DC5E-5CE6-4800-B105-948B020CE4D7}" type="datetimeFigureOut">
               <a:rPr lang="en-US" smtClean="0"/>
-              <a:t>9/22/2026</a:t>
+              <a:t>9/23/2026</a:t>
             </a:fld>
             <a:endParaRPr lang="en-US"/>
           </a:p>
@@ -680,7 +680,7 @@
           <p:cNvPr id="5" name="Footer Placeholder 4">
             <a:extLst>
               <a:ext uri="{FF2B5EF4-FFF2-40B4-BE49-F238E27FC236}">
-                <a16:creationId xmlns:a16="http://schemas.microsoft.com/office/drawing/2014/main" id="{68071497-06A4-3EC1-ACEA-7DD0D995055A}"/>
+                <a16:creationId xmlns:a16="http://schemas.microsoft.com/office/drawing/2014/main" id="{DF0C42D8-E15B-491F-B3B2-A88514E700F0}"/>
               </a:ext>
             </a:extLst>
           </p:cNvPr>
@@ -705,7 +705,7 @@
           <p:cNvPr id="6" name="Slide Number Placeholder 5">
             <a:extLst>
               <a:ext uri="{FF2B5EF4-FFF2-40B4-BE49-F238E27FC236}">
-                <a16:creationId xmlns:a16="http://schemas.microsoft.com/office/drawing/2014/main" id="{7BA666FB-EF91-A732-4714-9EE35B6CB6F0}"/>
+                <a16:creationId xmlns:a16="http://schemas.microsoft.com/office/drawing/2014/main" id="{EB9A6CC9-6325-1B27-E119-9D07B8425989}"/>
               </a:ext>
             </a:extLst>
           </p:cNvPr>
@@ -721,7 +721,7 @@
           <a:bodyPr/>
           <a:lstStyle/>
           <a:p>
-            <a:fld id="{22F4D96E-BE4E-4860-A9F5-F55433232C3A}" type="slidenum">
+            <a:fld id="{9CC4AB40-24CE-403C-8D90-29F002F94F66}" type="slidenum">
               <a:rPr lang="en-US" smtClean="0"/>
               <a:t>‹#›</a:t>
             </a:fld>
@@ -732,7 +732,7 @@
     </p:spTree>
     <p:extLst>
       <p:ext uri="{BB962C8B-B14F-4D97-AF65-F5344CB8AC3E}">
-        <p14:creationId xmlns:p14="http://schemas.microsoft.com/office/powerpoint/2010/main" val="1495380206"/>
+        <p14:creationId xmlns:p14="http://schemas.microsoft.com/office/powerpoint/2010/main" val="440877757"/>
       </p:ext>
     </p:extLst>
   </p:cSld>
@@ -764,7 +764,7 @@
           <p:cNvPr id="2" name="Title 1">
             <a:extLst>
               <a:ext uri="{FF2B5EF4-FFF2-40B4-BE49-F238E27FC236}">
-                <a16:creationId xmlns:a16="http://schemas.microsoft.com/office/drawing/2014/main" id="{529C6C02-48DA-E181-ED47-FC44AB23AB7B}"/>
+                <a16:creationId xmlns:a16="http://schemas.microsoft.com/office/drawing/2014/main" id="{A241F7C5-0F01-19F9-3789-776B493CB948}"/>
               </a:ext>
             </a:extLst>
           </p:cNvPr>
@@ -792,7 +792,7 @@
           <p:cNvPr id="3" name="Content Placeholder 2">
             <a:extLst>
               <a:ext uri="{FF2B5EF4-FFF2-40B4-BE49-F238E27FC236}">
-                <a16:creationId xmlns:a16="http://schemas.microsoft.com/office/drawing/2014/main" id="{B5C61F8B-CEDF-B575-0703-763E48582941}"/>
+                <a16:creationId xmlns:a16="http://schemas.microsoft.com/office/drawing/2014/main" id="{DB1D17BB-F0A2-169C-431D-7259F798D2D5}"/>
               </a:ext>
             </a:extLst>
           </p:cNvPr>
@@ -849,7 +849,7 @@
           <p:cNvPr id="4" name="Date Placeholder 3">
             <a:extLst>
               <a:ext uri="{FF2B5EF4-FFF2-40B4-BE49-F238E27FC236}">
-                <a16:creationId xmlns:a16="http://schemas.microsoft.com/office/drawing/2014/main" id="{8E7703C8-2729-8886-5F0B-9AD35D3E407F}"/>
+                <a16:creationId xmlns:a16="http://schemas.microsoft.com/office/drawing/2014/main" id="{412AED36-293E-D182-EFEB-47ED031FA9CB}"/>
               </a:ext>
             </a:extLst>
           </p:cNvPr>
@@ -865,9 +865,9 @@
           <a:bodyPr/>
           <a:lstStyle/>
           <a:p>
-            <a:fld id="{A29D6AED-A3F2-4DDB-AB29-5BDBB7B2D1EC}" type="datetimeFigureOut">
+            <a:fld id="{12B4DC5E-5CE6-4800-B105-948B020CE4D7}" type="datetimeFigureOut">
               <a:rPr lang="en-US" smtClean="0"/>
-              <a:t>9/22/2026</a:t>
+              <a:t>9/23/2026</a:t>
             </a:fld>
             <a:endParaRPr lang="en-US"/>
           </a:p>
@@ -878,7 +878,7 @@
           <p:cNvPr id="5" name="Footer Placeholder 4">
             <a:extLst>
               <a:ext uri="{FF2B5EF4-FFF2-40B4-BE49-F238E27FC236}">
-                <a16:creationId xmlns:a16="http://schemas.microsoft.com/office/drawing/2014/main" id="{A5F4DF05-C118-A2F5-CCD5-DCB2DC6C0A31}"/>
+                <a16:creationId xmlns:a16="http://schemas.microsoft.com/office/drawing/2014/main" id="{3CF9AC71-155D-F0C4-47C1-FD7050398069}"/>
               </a:ext>
             </a:extLst>
           </p:cNvPr>
@@ -903,7 +903,7 @@
           <p:cNvPr id="6" name="Slide Number Placeholder 5">
             <a:extLst>
               <a:ext uri="{FF2B5EF4-FFF2-40B4-BE49-F238E27FC236}">
-                <a16:creationId xmlns:a16="http://schemas.microsoft.com/office/drawing/2014/main" id="{6585F3E7-4CF2-1229-B096-A20503C26320}"/>
+                <a16:creationId xmlns:a16="http://schemas.microsoft.com/office/drawing/2014/main" id="{FF729E13-2070-E475-6E01-409815D03307}"/>
               </a:ext>
             </a:extLst>
           </p:cNvPr>
@@ -919,7 +919,7 @@
           <a:bodyPr/>
           <a:lstStyle/>
           <a:p>
-            <a:fld id="{22F4D96E-BE4E-4860-A9F5-F55433232C3A}" type="slidenum">
+            <a:fld id="{9CC4AB40-24CE-403C-8D90-29F002F94F66}" type="slidenum">
               <a:rPr lang="en-US" smtClean="0"/>
               <a:t>‹#›</a:t>
             </a:fld>
@@ -930,7 +930,7 @@
     </p:spTree>
     <p:extLst>
       <p:ext uri="{BB962C8B-B14F-4D97-AF65-F5344CB8AC3E}">
-        <p14:creationId xmlns:p14="http://schemas.microsoft.com/office/powerpoint/2010/main" val="56968242"/>
+        <p14:creationId xmlns:p14="http://schemas.microsoft.com/office/powerpoint/2010/main" val="4090977967"/>
       </p:ext>
     </p:extLst>
   </p:cSld>
@@ -962,7 +962,7 @@
           <p:cNvPr id="2" name="Title 1">
             <a:extLst>
               <a:ext uri="{FF2B5EF4-FFF2-40B4-BE49-F238E27FC236}">
-                <a16:creationId xmlns:a16="http://schemas.microsoft.com/office/drawing/2014/main" id="{264678CA-DE29-48A7-9CB9-C78DD765DBA0}"/>
+                <a16:creationId xmlns:a16="http://schemas.microsoft.com/office/drawing/2014/main" id="{F8213880-AF9A-47BA-8040-C5B3F94E19C8}"/>
               </a:ext>
             </a:extLst>
           </p:cNvPr>
@@ -999,7 +999,7 @@
           <p:cNvPr id="3" name="Text Placeholder 2">
             <a:extLst>
               <a:ext uri="{FF2B5EF4-FFF2-40B4-BE49-F238E27FC236}">
-                <a16:creationId xmlns:a16="http://schemas.microsoft.com/office/drawing/2014/main" id="{0FE7AA0E-3738-FC2C-9305-287BF46AA585}"/>
+                <a16:creationId xmlns:a16="http://schemas.microsoft.com/office/drawing/2014/main" id="{FE161C6C-2382-B8ED-2137-C42B9C24212E}"/>
               </a:ext>
             </a:extLst>
           </p:cNvPr>
@@ -1124,7 +1124,7 @@
           <p:cNvPr id="4" name="Date Placeholder 3">
             <a:extLst>
               <a:ext uri="{FF2B5EF4-FFF2-40B4-BE49-F238E27FC236}">
-                <a16:creationId xmlns:a16="http://schemas.microsoft.com/office/drawing/2014/main" id="{07363363-7DB7-9C5F-7FA6-EEE7E737E851}"/>
+                <a16:creationId xmlns:a16="http://schemas.microsoft.com/office/drawing/2014/main" id="{B37D9672-EB94-D0D6-A161-9E3812F0CB68}"/>
               </a:ext>
             </a:extLst>
           </p:cNvPr>
@@ -1140,9 +1140,9 @@
           <a:bodyPr/>
           <a:lstStyle/>
           <a:p>
-            <a:fld id="{A29D6AED-A3F2-4DDB-AB29-5BDBB7B2D1EC}" type="datetimeFigureOut">
+            <a:fld id="{12B4DC5E-5CE6-4800-B105-948B020CE4D7}" type="datetimeFigureOut">
               <a:rPr lang="en-US" smtClean="0"/>
-              <a:t>9/22/2026</a:t>
+              <a:t>9/23/2026</a:t>
             </a:fld>
             <a:endParaRPr lang="en-US"/>
           </a:p>
@@ -1153,7 +1153,7 @@
           <p:cNvPr id="5" name="Footer Placeholder 4">
             <a:extLst>
               <a:ext uri="{FF2B5EF4-FFF2-40B4-BE49-F238E27FC236}">
-                <a16:creationId xmlns:a16="http://schemas.microsoft.com/office/drawing/2014/main" id="{A9E256D1-D0FE-FC30-D421-588D5378FB16}"/>
+                <a16:creationId xmlns:a16="http://schemas.microsoft.com/office/drawing/2014/main" id="{FE4BC55D-5CE1-D7FA-BBE9-79C067A0F6C8}"/>
               </a:ext>
             </a:extLst>
           </p:cNvPr>
@@ -1178,7 +1178,7 @@
           <p:cNvPr id="6" name="Slide Number Placeholder 5">
             <a:extLst>
               <a:ext uri="{FF2B5EF4-FFF2-40B4-BE49-F238E27FC236}">
-                <a16:creationId xmlns:a16="http://schemas.microsoft.com/office/drawing/2014/main" id="{5BF9644D-9E35-55DE-CE51-01E816E1D9C7}"/>
+                <a16:creationId xmlns:a16="http://schemas.microsoft.com/office/drawing/2014/main" id="{858553CB-EA1E-F5F8-D5D4-45F0494E6C69}"/>
               </a:ext>
             </a:extLst>
           </p:cNvPr>
@@ -1194,7 +1194,7 @@
           <a:bodyPr/>
           <a:lstStyle/>
           <a:p>
-            <a:fld id="{22F4D96E-BE4E-4860-A9F5-F55433232C3A}" type="slidenum">
+            <a:fld id="{9CC4AB40-24CE-403C-8D90-29F002F94F66}" type="slidenum">
               <a:rPr lang="en-US" smtClean="0"/>
               <a:t>‹#›</a:t>
             </a:fld>
@@ -1205,7 +1205,7 @@
     </p:spTree>
     <p:extLst>
       <p:ext uri="{BB962C8B-B14F-4D97-AF65-F5344CB8AC3E}">
-        <p14:creationId xmlns:p14="http://schemas.microsoft.com/office/powerpoint/2010/main" val="4103965867"/>
+        <p14:creationId xmlns:p14="http://schemas.microsoft.com/office/powerpoint/2010/main" val="1000704955"/>
       </p:ext>
     </p:extLst>
   </p:cSld>
@@ -1237,7 +1237,7 @@
           <p:cNvPr id="2" name="Title 1">
             <a:extLst>
               <a:ext uri="{FF2B5EF4-FFF2-40B4-BE49-F238E27FC236}">
-                <a16:creationId xmlns:a16="http://schemas.microsoft.com/office/drawing/2014/main" id="{DAE72C10-4A32-3B28-2148-E36609451909}"/>
+                <a16:creationId xmlns:a16="http://schemas.microsoft.com/office/drawing/2014/main" id="{71957049-FECA-3D5F-703A-688C9F7874D0}"/>
               </a:ext>
             </a:extLst>
           </p:cNvPr>
@@ -1265,7 +1265,7 @@
           <p:cNvPr id="3" name="Content Placeholder 2">
             <a:extLst>
               <a:ext uri="{FF2B5EF4-FFF2-40B4-BE49-F238E27FC236}">
-                <a16:creationId xmlns:a16="http://schemas.microsoft.com/office/drawing/2014/main" id="{6D4EDBBC-30ED-DC54-5D9C-CDE83AE6F0CD}"/>
+                <a16:creationId xmlns:a16="http://schemas.microsoft.com/office/drawing/2014/main" id="{77BB2E2A-EA87-D1DB-2A60-71CA575FB255}"/>
               </a:ext>
             </a:extLst>
           </p:cNvPr>
@@ -1327,7 +1327,7 @@
           <p:cNvPr id="4" name="Content Placeholder 3">
             <a:extLst>
               <a:ext uri="{FF2B5EF4-FFF2-40B4-BE49-F238E27FC236}">
-                <a16:creationId xmlns:a16="http://schemas.microsoft.com/office/drawing/2014/main" id="{0AC050F6-2F1F-4583-586D-D3EE9481F1B7}"/>
+                <a16:creationId xmlns:a16="http://schemas.microsoft.com/office/drawing/2014/main" id="{8779F318-7872-80CD-FD8B-A736D010171F}"/>
               </a:ext>
             </a:extLst>
           </p:cNvPr>
@@ -1389,7 +1389,7 @@
           <p:cNvPr id="5" name="Date Placeholder 4">
             <a:extLst>
               <a:ext uri="{FF2B5EF4-FFF2-40B4-BE49-F238E27FC236}">
-                <a16:creationId xmlns:a16="http://schemas.microsoft.com/office/drawing/2014/main" id="{6C7BAB1B-F0C8-5EA9-BDB0-1423171EB1D5}"/>
+                <a16:creationId xmlns:a16="http://schemas.microsoft.com/office/drawing/2014/main" id="{3FF527F7-4D1D-04DC-A913-DC5EED8D266C}"/>
               </a:ext>
             </a:extLst>
           </p:cNvPr>
@@ -1405,9 +1405,9 @@
           <a:bodyPr/>
           <a:lstStyle/>
           <a:p>
-            <a:fld id="{A29D6AED-A3F2-4DDB-AB29-5BDBB7B2D1EC}" type="datetimeFigureOut">
+            <a:fld id="{12B4DC5E-5CE6-4800-B105-948B020CE4D7}" type="datetimeFigureOut">
               <a:rPr lang="en-US" smtClean="0"/>
-              <a:t>9/22/2026</a:t>
+              <a:t>9/23/2026</a:t>
             </a:fld>
             <a:endParaRPr lang="en-US"/>
           </a:p>
@@ -1418,7 +1418,7 @@
           <p:cNvPr id="6" name="Footer Placeholder 5">
             <a:extLst>
               <a:ext uri="{FF2B5EF4-FFF2-40B4-BE49-F238E27FC236}">
-                <a16:creationId xmlns:a16="http://schemas.microsoft.com/office/drawing/2014/main" id="{DA942766-60E1-A6C6-2158-BFD04EBFFF3A}"/>
+                <a16:creationId xmlns:a16="http://schemas.microsoft.com/office/drawing/2014/main" id="{50AC79E3-1681-491A-52CF-007661EDDF15}"/>
               </a:ext>
             </a:extLst>
           </p:cNvPr>
@@ -1443,7 +1443,7 @@
           <p:cNvPr id="7" name="Slide Number Placeholder 6">
             <a:extLst>
               <a:ext uri="{FF2B5EF4-FFF2-40B4-BE49-F238E27FC236}">
-                <a16:creationId xmlns:a16="http://schemas.microsoft.com/office/drawing/2014/main" id="{4FB79CCB-2FB0-6FF7-AEB6-DD6F119F2051}"/>
+                <a16:creationId xmlns:a16="http://schemas.microsoft.com/office/drawing/2014/main" id="{42ADEBC1-59E3-36D2-35E1-6450D0083751}"/>
               </a:ext>
             </a:extLst>
           </p:cNvPr>
@@ -1459,7 +1459,7 @@
           <a:bodyPr/>
           <a:lstStyle/>
           <a:p>
-            <a:fld id="{22F4D96E-BE4E-4860-A9F5-F55433232C3A}" type="slidenum">
+            <a:fld id="{9CC4AB40-24CE-403C-8D90-29F002F94F66}" type="slidenum">
               <a:rPr lang="en-US" smtClean="0"/>
               <a:t>‹#›</a:t>
             </a:fld>
@@ -1470,7 +1470,7 @@
     </p:spTree>
     <p:extLst>
       <p:ext uri="{BB962C8B-B14F-4D97-AF65-F5344CB8AC3E}">
-        <p14:creationId xmlns:p14="http://schemas.microsoft.com/office/powerpoint/2010/main" val="2657095707"/>
+        <p14:creationId xmlns:p14="http://schemas.microsoft.com/office/powerpoint/2010/main" val="1292154299"/>
       </p:ext>
     </p:extLst>
   </p:cSld>
@@ -1502,7 +1502,7 @@
           <p:cNvPr id="2" name="Title 1">
             <a:extLst>
               <a:ext uri="{FF2B5EF4-FFF2-40B4-BE49-F238E27FC236}">
-                <a16:creationId xmlns:a16="http://schemas.microsoft.com/office/drawing/2014/main" id="{0693FCB5-033D-269A-5FB5-E76992813824}"/>
+                <a16:creationId xmlns:a16="http://schemas.microsoft.com/office/drawing/2014/main" id="{ABA8F5A4-0F55-E868-7297-2452B0A9D5C8}"/>
               </a:ext>
             </a:extLst>
           </p:cNvPr>
@@ -1535,7 +1535,7 @@
           <p:cNvPr id="3" name="Text Placeholder 2">
             <a:extLst>
               <a:ext uri="{FF2B5EF4-FFF2-40B4-BE49-F238E27FC236}">
-                <a16:creationId xmlns:a16="http://schemas.microsoft.com/office/drawing/2014/main" id="{92C845C3-4C90-6480-3F66-42F92D9E7A98}"/>
+                <a16:creationId xmlns:a16="http://schemas.microsoft.com/office/drawing/2014/main" id="{1046BD37-B716-439B-9170-9938E26AB4A4}"/>
               </a:ext>
             </a:extLst>
           </p:cNvPr>
@@ -1606,7 +1606,7 @@
           <p:cNvPr id="4" name="Content Placeholder 3">
             <a:extLst>
               <a:ext uri="{FF2B5EF4-FFF2-40B4-BE49-F238E27FC236}">
-                <a16:creationId xmlns:a16="http://schemas.microsoft.com/office/drawing/2014/main" id="{64979EE2-7B1D-4669-B977-CE59B67B42AE}"/>
+                <a16:creationId xmlns:a16="http://schemas.microsoft.com/office/drawing/2014/main" id="{E8D8C83F-C98B-7718-1B07-4A6958A78114}"/>
               </a:ext>
             </a:extLst>
           </p:cNvPr>
@@ -1668,7 +1668,7 @@
           <p:cNvPr id="5" name="Text Placeholder 4">
             <a:extLst>
               <a:ext uri="{FF2B5EF4-FFF2-40B4-BE49-F238E27FC236}">
-                <a16:creationId xmlns:a16="http://schemas.microsoft.com/office/drawing/2014/main" id="{A3717A33-BCBE-7AFE-C100-A9E2E5CFDC81}"/>
+                <a16:creationId xmlns:a16="http://schemas.microsoft.com/office/drawing/2014/main" id="{9398472F-3C6D-2D28-582E-93C3A234CFFB}"/>
               </a:ext>
             </a:extLst>
           </p:cNvPr>
@@ -1739,7 +1739,7 @@
           <p:cNvPr id="6" name="Content Placeholder 5">
             <a:extLst>
               <a:ext uri="{FF2B5EF4-FFF2-40B4-BE49-F238E27FC236}">
-                <a16:creationId xmlns:a16="http://schemas.microsoft.com/office/drawing/2014/main" id="{A7A19FED-4CD1-9F6D-4D52-AAA0A10F26B2}"/>
+                <a16:creationId xmlns:a16="http://schemas.microsoft.com/office/drawing/2014/main" id="{0066C38F-974D-4224-9EBC-5A2A35E80FF8}"/>
               </a:ext>
             </a:extLst>
           </p:cNvPr>
@@ -1801,7 +1801,7 @@
           <p:cNvPr id="7" name="Date Placeholder 6">
             <a:extLst>
               <a:ext uri="{FF2B5EF4-FFF2-40B4-BE49-F238E27FC236}">
-                <a16:creationId xmlns:a16="http://schemas.microsoft.com/office/drawing/2014/main" id="{D9EB0D5E-06FA-0602-8FDA-62C670A4A69A}"/>
+                <a16:creationId xmlns:a16="http://schemas.microsoft.com/office/drawing/2014/main" id="{B6A13591-8614-DBC5-5DF3-A04AB4CBC014}"/>
               </a:ext>
             </a:extLst>
           </p:cNvPr>
@@ -1817,9 +1817,9 @@
           <a:bodyPr/>
           <a:lstStyle/>
           <a:p>
-            <a:fld id="{A29D6AED-A3F2-4DDB-AB29-5BDBB7B2D1EC}" type="datetimeFigureOut">
+            <a:fld id="{12B4DC5E-5CE6-4800-B105-948B020CE4D7}" type="datetimeFigureOut">
               <a:rPr lang="en-US" smtClean="0"/>
-              <a:t>9/22/2026</a:t>
+              <a:t>9/23/2026</a:t>
             </a:fld>
             <a:endParaRPr lang="en-US"/>
           </a:p>
@@ -1830,7 +1830,7 @@
           <p:cNvPr id="8" name="Footer Placeholder 7">
             <a:extLst>
               <a:ext uri="{FF2B5EF4-FFF2-40B4-BE49-F238E27FC236}">
-                <a16:creationId xmlns:a16="http://schemas.microsoft.com/office/drawing/2014/main" id="{D8E62A81-6606-2F2A-33E2-242A2F3C6EC5}"/>
+                <a16:creationId xmlns:a16="http://schemas.microsoft.com/office/drawing/2014/main" id="{2ED98E24-9EDE-8E2C-4D3C-7108F58336A7}"/>
               </a:ext>
             </a:extLst>
           </p:cNvPr>
@@ -1855,7 +1855,7 @@
           <p:cNvPr id="9" name="Slide Number Placeholder 8">
             <a:extLst>
               <a:ext uri="{FF2B5EF4-FFF2-40B4-BE49-F238E27FC236}">
-                <a16:creationId xmlns:a16="http://schemas.microsoft.com/office/drawing/2014/main" id="{B0507062-043D-B85A-AB73-D825714D5767}"/>
+                <a16:creationId xmlns:a16="http://schemas.microsoft.com/office/drawing/2014/main" id="{8450E2ED-F293-45F1-8932-934743F3C695}"/>
               </a:ext>
             </a:extLst>
           </p:cNvPr>
@@ -1871,7 +1871,7 @@
           <a:bodyPr/>
           <a:lstStyle/>
           <a:p>
-            <a:fld id="{22F4D96E-BE4E-4860-A9F5-F55433232C3A}" type="slidenum">
+            <a:fld id="{9CC4AB40-24CE-403C-8D90-29F002F94F66}" type="slidenum">
               <a:rPr lang="en-US" smtClean="0"/>
               <a:t>‹#›</a:t>
             </a:fld>
@@ -1882,7 +1882,7 @@
     </p:spTree>
     <p:extLst>
       <p:ext uri="{BB962C8B-B14F-4D97-AF65-F5344CB8AC3E}">
-        <p14:creationId xmlns:p14="http://schemas.microsoft.com/office/powerpoint/2010/main" val="1973303576"/>
+        <p14:creationId xmlns:p14="http://schemas.microsoft.com/office/powerpoint/2010/main" val="15757033"/>
       </p:ext>
     </p:extLst>
   </p:cSld>
@@ -1914,7 +1914,7 @@
           <p:cNvPr id="2" name="Title 1">
             <a:extLst>
               <a:ext uri="{FF2B5EF4-FFF2-40B4-BE49-F238E27FC236}">
-                <a16:creationId xmlns:a16="http://schemas.microsoft.com/office/drawing/2014/main" id="{0654B896-3239-7624-EFB1-21335A301C02}"/>
+                <a16:creationId xmlns:a16="http://schemas.microsoft.com/office/drawing/2014/main" id="{D4931840-4C78-BF90-92BA-E6F33FDCCF14}"/>
               </a:ext>
             </a:extLst>
           </p:cNvPr>
@@ -1942,7 +1942,7 @@
           <p:cNvPr id="3" name="Date Placeholder 2">
             <a:extLst>
               <a:ext uri="{FF2B5EF4-FFF2-40B4-BE49-F238E27FC236}">
-                <a16:creationId xmlns:a16="http://schemas.microsoft.com/office/drawing/2014/main" id="{F830C86E-1164-6C27-9233-6BCC3B925B99}"/>
+                <a16:creationId xmlns:a16="http://schemas.microsoft.com/office/drawing/2014/main" id="{F0E58F0F-DB66-304F-0D96-FA2EE7956841}"/>
               </a:ext>
             </a:extLst>
           </p:cNvPr>
@@ -1958,9 +1958,9 @@
           <a:bodyPr/>
           <a:lstStyle/>
           <a:p>
-            <a:fld id="{A29D6AED-A3F2-4DDB-AB29-5BDBB7B2D1EC}" type="datetimeFigureOut">
+            <a:fld id="{12B4DC5E-5CE6-4800-B105-948B020CE4D7}" type="datetimeFigureOut">
               <a:rPr lang="en-US" smtClean="0"/>
-              <a:t>9/22/2026</a:t>
+              <a:t>9/23/2026</a:t>
             </a:fld>
             <a:endParaRPr lang="en-US"/>
           </a:p>
@@ -1971,7 +1971,7 @@
           <p:cNvPr id="4" name="Footer Placeholder 3">
             <a:extLst>
               <a:ext uri="{FF2B5EF4-FFF2-40B4-BE49-F238E27FC236}">
-                <a16:creationId xmlns:a16="http://schemas.microsoft.com/office/drawing/2014/main" id="{F377ECFA-AB1D-3890-E941-D2F2679F7B4D}"/>
+                <a16:creationId xmlns:a16="http://schemas.microsoft.com/office/drawing/2014/main" id="{7D32F7B8-85F3-B58A-E506-180DA83C13CC}"/>
               </a:ext>
             </a:extLst>
           </p:cNvPr>
@@ -1996,7 +1996,7 @@
           <p:cNvPr id="5" name="Slide Number Placeholder 4">
             <a:extLst>
               <a:ext uri="{FF2B5EF4-FFF2-40B4-BE49-F238E27FC236}">
-                <a16:creationId xmlns:a16="http://schemas.microsoft.com/office/drawing/2014/main" id="{086C4CC1-D757-7BF9-F847-4FF0030F5FF4}"/>
+                <a16:creationId xmlns:a16="http://schemas.microsoft.com/office/drawing/2014/main" id="{474C6684-EF50-11D3-19F5-97D1FBFF9E46}"/>
               </a:ext>
             </a:extLst>
           </p:cNvPr>
@@ -2012,7 +2012,7 @@
           <a:bodyPr/>
           <a:lstStyle/>
           <a:p>
-            <a:fld id="{22F4D96E-BE4E-4860-A9F5-F55433232C3A}" type="slidenum">
+            <a:fld id="{9CC4AB40-24CE-403C-8D90-29F002F94F66}" type="slidenum">
               <a:rPr lang="en-US" smtClean="0"/>
               <a:t>‹#›</a:t>
             </a:fld>
@@ -2023,7 +2023,7 @@
     </p:spTree>
     <p:extLst>
       <p:ext uri="{BB962C8B-B14F-4D97-AF65-F5344CB8AC3E}">
-        <p14:creationId xmlns:p14="http://schemas.microsoft.com/office/powerpoint/2010/main" val="3126985555"/>
+        <p14:creationId xmlns:p14="http://schemas.microsoft.com/office/powerpoint/2010/main" val="1359187602"/>
       </p:ext>
     </p:extLst>
   </p:cSld>
@@ -2055,7 +2055,7 @@
           <p:cNvPr id="2" name="Date Placeholder 1">
             <a:extLst>
               <a:ext uri="{FF2B5EF4-FFF2-40B4-BE49-F238E27FC236}">
-                <a16:creationId xmlns:a16="http://schemas.microsoft.com/office/drawing/2014/main" id="{3C1EDA05-1162-7B17-7DFF-A22B73814F4A}"/>
+                <a16:creationId xmlns:a16="http://schemas.microsoft.com/office/drawing/2014/main" id="{98370DCE-3BCA-E3F5-23E1-685F96E35A7E}"/>
               </a:ext>
             </a:extLst>
           </p:cNvPr>
@@ -2071,9 +2071,9 @@
           <a:bodyPr/>
           <a:lstStyle/>
           <a:p>
-            <a:fld id="{A29D6AED-A3F2-4DDB-AB29-5BDBB7B2D1EC}" type="datetimeFigureOut">
+            <a:fld id="{12B4DC5E-5CE6-4800-B105-948B020CE4D7}" type="datetimeFigureOut">
               <a:rPr lang="en-US" smtClean="0"/>
-              <a:t>9/22/2026</a:t>
+              <a:t>9/23/2026</a:t>
             </a:fld>
             <a:endParaRPr lang="en-US"/>
           </a:p>
@@ -2084,7 +2084,7 @@
           <p:cNvPr id="3" name="Footer Placeholder 2">
             <a:extLst>
               <a:ext uri="{FF2B5EF4-FFF2-40B4-BE49-F238E27FC236}">
-                <a16:creationId xmlns:a16="http://schemas.microsoft.com/office/drawing/2014/main" id="{409FE57A-36DE-F068-E925-67D18F8483A8}"/>
+                <a16:creationId xmlns:a16="http://schemas.microsoft.com/office/drawing/2014/main" id="{13996654-84CE-DFEC-70AD-E76785DFB3DC}"/>
               </a:ext>
             </a:extLst>
           </p:cNvPr>
@@ -2109,7 +2109,7 @@
           <p:cNvPr id="4" name="Slide Number Placeholder 3">
             <a:extLst>
               <a:ext uri="{FF2B5EF4-FFF2-40B4-BE49-F238E27FC236}">
-                <a16:creationId xmlns:a16="http://schemas.microsoft.com/office/drawing/2014/main" id="{224183C2-A44E-B767-DA8C-BA2626669A97}"/>
+                <a16:creationId xmlns:a16="http://schemas.microsoft.com/office/drawing/2014/main" id="{88BA6BFA-D78D-719A-1FCD-3D3CAA1907DE}"/>
               </a:ext>
             </a:extLst>
           </p:cNvPr>
@@ -2125,7 +2125,7 @@
           <a:bodyPr/>
           <a:lstStyle/>
           <a:p>
-            <a:fld id="{22F4D96E-BE4E-4860-A9F5-F55433232C3A}" type="slidenum">
+            <a:fld id="{9CC4AB40-24CE-403C-8D90-29F002F94F66}" type="slidenum">
               <a:rPr lang="en-US" smtClean="0"/>
               <a:t>‹#›</a:t>
             </a:fld>
@@ -2136,7 +2136,7 @@
     </p:spTree>
     <p:extLst>
       <p:ext uri="{BB962C8B-B14F-4D97-AF65-F5344CB8AC3E}">
-        <p14:creationId xmlns:p14="http://schemas.microsoft.com/office/powerpoint/2010/main" val="3270992363"/>
+        <p14:creationId xmlns:p14="http://schemas.microsoft.com/office/powerpoint/2010/main" val="353146374"/>
       </p:ext>
     </p:extLst>
   </p:cSld>
@@ -2168,7 +2168,7 @@
           <p:cNvPr id="2" name="Title 1">
             <a:extLst>
               <a:ext uri="{FF2B5EF4-FFF2-40B4-BE49-F238E27FC236}">
-                <a16:creationId xmlns:a16="http://schemas.microsoft.com/office/drawing/2014/main" id="{FE65F0FA-6ED4-C492-C5CB-5D292138F922}"/>
+                <a16:creationId xmlns:a16="http://schemas.microsoft.com/office/drawing/2014/main" id="{A47557B5-6CE4-20B7-2C65-934FB15EC285}"/>
               </a:ext>
             </a:extLst>
           </p:cNvPr>
@@ -2205,7 +2205,7 @@
           <p:cNvPr id="3" name="Content Placeholder 2">
             <a:extLst>
               <a:ext uri="{FF2B5EF4-FFF2-40B4-BE49-F238E27FC236}">
-                <a16:creationId xmlns:a16="http://schemas.microsoft.com/office/drawing/2014/main" id="{90389CC0-B080-029D-287F-A82C14D2EBEA}"/>
+                <a16:creationId xmlns:a16="http://schemas.microsoft.com/office/drawing/2014/main" id="{9E1A78AB-8EF7-3B26-53C8-0A82EC182C7C}"/>
               </a:ext>
             </a:extLst>
           </p:cNvPr>
@@ -2295,7 +2295,7 @@
           <p:cNvPr id="4" name="Text Placeholder 3">
             <a:extLst>
               <a:ext uri="{FF2B5EF4-FFF2-40B4-BE49-F238E27FC236}">
-                <a16:creationId xmlns:a16="http://schemas.microsoft.com/office/drawing/2014/main" id="{8B81EEC3-85E0-6A9B-2BC1-7AE2DDB95596}"/>
+                <a16:creationId xmlns:a16="http://schemas.microsoft.com/office/drawing/2014/main" id="{54E8BF96-D1A4-DA8F-0BCD-E78729CD535D}"/>
               </a:ext>
             </a:extLst>
           </p:cNvPr>
@@ -2366,7 +2366,7 @@
           <p:cNvPr id="5" name="Date Placeholder 4">
             <a:extLst>
               <a:ext uri="{FF2B5EF4-FFF2-40B4-BE49-F238E27FC236}">
-                <a16:creationId xmlns:a16="http://schemas.microsoft.com/office/drawing/2014/main" id="{1B84743F-A8F4-02AC-AB15-372422CE6D43}"/>
+                <a16:creationId xmlns:a16="http://schemas.microsoft.com/office/drawing/2014/main" id="{0EC6C48D-D097-5A81-E130-28B5EFA082BD}"/>
               </a:ext>
             </a:extLst>
           </p:cNvPr>
@@ -2382,9 +2382,9 @@
           <a:bodyPr/>
           <a:lstStyle/>
           <a:p>
-            <a:fld id="{A29D6AED-A3F2-4DDB-AB29-5BDBB7B2D1EC}" type="datetimeFigureOut">
+            <a:fld id="{12B4DC5E-5CE6-4800-B105-948B020CE4D7}" type="datetimeFigureOut">
               <a:rPr lang="en-US" smtClean="0"/>
-              <a:t>9/22/2026</a:t>
+              <a:t>9/23/2026</a:t>
             </a:fld>
             <a:endParaRPr lang="en-US"/>
           </a:p>
@@ -2395,7 +2395,7 @@
           <p:cNvPr id="6" name="Footer Placeholder 5">
             <a:extLst>
               <a:ext uri="{FF2B5EF4-FFF2-40B4-BE49-F238E27FC236}">
-                <a16:creationId xmlns:a16="http://schemas.microsoft.com/office/drawing/2014/main" id="{85DF6380-8E80-572E-7B1B-95FD9F8D3CE7}"/>
+                <a16:creationId xmlns:a16="http://schemas.microsoft.com/office/drawing/2014/main" id="{F2B4EE19-1992-EE41-AE37-5B1748C21015}"/>
               </a:ext>
             </a:extLst>
           </p:cNvPr>
@@ -2420,7 +2420,7 @@
           <p:cNvPr id="7" name="Slide Number Placeholder 6">
             <a:extLst>
               <a:ext uri="{FF2B5EF4-FFF2-40B4-BE49-F238E27FC236}">
-                <a16:creationId xmlns:a16="http://schemas.microsoft.com/office/drawing/2014/main" id="{A193F12A-6130-182F-F0E7-9DE94199D1CB}"/>
+                <a16:creationId xmlns:a16="http://schemas.microsoft.com/office/drawing/2014/main" id="{52C8E0B4-A393-F7B4-EFEB-8BCB0C34DB0E}"/>
               </a:ext>
             </a:extLst>
           </p:cNvPr>
@@ -2436,7 +2436,7 @@
           <a:bodyPr/>
           <a:lstStyle/>
           <a:p>
-            <a:fld id="{22F4D96E-BE4E-4860-A9F5-F55433232C3A}" type="slidenum">
+            <a:fld id="{9CC4AB40-24CE-403C-8D90-29F002F94F66}" type="slidenum">
               <a:rPr lang="en-US" smtClean="0"/>
               <a:t>‹#›</a:t>
             </a:fld>
@@ -2447,7 +2447,7 @@
     </p:spTree>
     <p:extLst>
       <p:ext uri="{BB962C8B-B14F-4D97-AF65-F5344CB8AC3E}">
-        <p14:creationId xmlns:p14="http://schemas.microsoft.com/office/powerpoint/2010/main" val="832244869"/>
+        <p14:creationId xmlns:p14="http://schemas.microsoft.com/office/powerpoint/2010/main" val="876704844"/>
       </p:ext>
     </p:extLst>
   </p:cSld>
@@ -2479,7 +2479,7 @@
           <p:cNvPr id="2" name="Title 1">
             <a:extLst>
               <a:ext uri="{FF2B5EF4-FFF2-40B4-BE49-F238E27FC236}">
-                <a16:creationId xmlns:a16="http://schemas.microsoft.com/office/drawing/2014/main" id="{C548EACF-4A08-C73A-784F-14FCAF32C1B8}"/>
+                <a16:creationId xmlns:a16="http://schemas.microsoft.com/office/drawing/2014/main" id="{187E4EA1-9336-9884-CFF3-BF05820B1FD2}"/>
               </a:ext>
             </a:extLst>
           </p:cNvPr>
@@ -2516,7 +2516,7 @@
           <p:cNvPr id="3" name="Picture Placeholder 2">
             <a:extLst>
               <a:ext uri="{FF2B5EF4-FFF2-40B4-BE49-F238E27FC236}">
-                <a16:creationId xmlns:a16="http://schemas.microsoft.com/office/drawing/2014/main" id="{B6EFACE3-890E-BD87-8DAF-FAA7D179D62D}"/>
+                <a16:creationId xmlns:a16="http://schemas.microsoft.com/office/drawing/2014/main" id="{2FDB39D7-405E-32C5-7CBA-C5BFE4E511A2}"/>
               </a:ext>
             </a:extLst>
           </p:cNvPr>
@@ -2583,7 +2583,7 @@
           <p:cNvPr id="4" name="Text Placeholder 3">
             <a:extLst>
               <a:ext uri="{FF2B5EF4-FFF2-40B4-BE49-F238E27FC236}">
-                <a16:creationId xmlns:a16="http://schemas.microsoft.com/office/drawing/2014/main" id="{88756902-6357-1B25-13AA-0624F3DD9466}"/>
+                <a16:creationId xmlns:a16="http://schemas.microsoft.com/office/drawing/2014/main" id="{2157EFAB-6655-0FAE-3492-6209C002DF27}"/>
               </a:ext>
             </a:extLst>
           </p:cNvPr>
@@ -2654,7 +2654,7 @@
           <p:cNvPr id="5" name="Date Placeholder 4">
             <a:extLst>
               <a:ext uri="{FF2B5EF4-FFF2-40B4-BE49-F238E27FC236}">
-                <a16:creationId xmlns:a16="http://schemas.microsoft.com/office/drawing/2014/main" id="{1E1C99A7-E7F9-89F9-0CD6-0E6330A6F234}"/>
+                <a16:creationId xmlns:a16="http://schemas.microsoft.com/office/drawing/2014/main" id="{69DBB76E-BFB5-C330-C148-7D15C88CACE7}"/>
               </a:ext>
             </a:extLst>
           </p:cNvPr>
@@ -2670,9 +2670,9 @@
           <a:bodyPr/>
           <a:lstStyle/>
           <a:p>
-            <a:fld id="{A29D6AED-A3F2-4DDB-AB29-5BDBB7B2D1EC}" type="datetimeFigureOut">
+            <a:fld id="{12B4DC5E-5CE6-4800-B105-948B020CE4D7}" type="datetimeFigureOut">
               <a:rPr lang="en-US" smtClean="0"/>
-              <a:t>9/22/2026</a:t>
+              <a:t>9/23/2026</a:t>
             </a:fld>
             <a:endParaRPr lang="en-US"/>
           </a:p>
@@ -2683,7 +2683,7 @@
           <p:cNvPr id="6" name="Footer Placeholder 5">
             <a:extLst>
               <a:ext uri="{FF2B5EF4-FFF2-40B4-BE49-F238E27FC236}">
-                <a16:creationId xmlns:a16="http://schemas.microsoft.com/office/drawing/2014/main" id="{5A601198-4C1B-4304-BED8-8A7592E26F10}"/>
+                <a16:creationId xmlns:a16="http://schemas.microsoft.com/office/drawing/2014/main" id="{97D186D4-DAF9-942D-0DEC-DF9F5DACA078}"/>
               </a:ext>
             </a:extLst>
           </p:cNvPr>
@@ -2708,7 +2708,7 @@
           <p:cNvPr id="7" name="Slide Number Placeholder 6">
             <a:extLst>
               <a:ext uri="{FF2B5EF4-FFF2-40B4-BE49-F238E27FC236}">
-                <a16:creationId xmlns:a16="http://schemas.microsoft.com/office/drawing/2014/main" id="{009B1093-6DC3-BCB3-5CB8-902D9B86C7D6}"/>
+                <a16:creationId xmlns:a16="http://schemas.microsoft.com/office/drawing/2014/main" id="{321F2760-13A4-BDB1-2E5F-AE6150EA65FC}"/>
               </a:ext>
             </a:extLst>
           </p:cNvPr>
@@ -2724,7 +2724,7 @@
           <a:bodyPr/>
           <a:lstStyle/>
           <a:p>
-            <a:fld id="{22F4D96E-BE4E-4860-A9F5-F55433232C3A}" type="slidenum">
+            <a:fld id="{9CC4AB40-24CE-403C-8D90-29F002F94F66}" type="slidenum">
               <a:rPr lang="en-US" smtClean="0"/>
               <a:t>‹#›</a:t>
             </a:fld>
@@ -2735,7 +2735,7 @@
     </p:spTree>
     <p:extLst>
       <p:ext uri="{BB962C8B-B14F-4D97-AF65-F5344CB8AC3E}">
-        <p14:creationId xmlns:p14="http://schemas.microsoft.com/office/powerpoint/2010/main" val="3785383288"/>
+        <p14:creationId xmlns:p14="http://schemas.microsoft.com/office/powerpoint/2010/main" val="235145286"/>
       </p:ext>
     </p:extLst>
   </p:cSld>
@@ -2772,7 +2772,7 @@
           <p:cNvPr id="2" name="Title Placeholder 1">
             <a:extLst>
               <a:ext uri="{FF2B5EF4-FFF2-40B4-BE49-F238E27FC236}">
-                <a16:creationId xmlns:a16="http://schemas.microsoft.com/office/drawing/2014/main" id="{8794CB01-89AF-9DA5-896B-5260EFB12EB1}"/>
+                <a16:creationId xmlns:a16="http://schemas.microsoft.com/office/drawing/2014/main" id="{38C79DC6-F5F9-B126-D31D-21E779E8FD29}"/>
               </a:ext>
             </a:extLst>
           </p:cNvPr>
@@ -2810,7 +2810,7 @@
           <p:cNvPr id="3" name="Text Placeholder 2">
             <a:extLst>
               <a:ext uri="{FF2B5EF4-FFF2-40B4-BE49-F238E27FC236}">
-                <a16:creationId xmlns:a16="http://schemas.microsoft.com/office/drawing/2014/main" id="{61B1A872-842F-DBA2-FC9D-D2DF2E0DBDE0}"/>
+                <a16:creationId xmlns:a16="http://schemas.microsoft.com/office/drawing/2014/main" id="{BB94FC3F-9A4F-2ED3-2028-6DB8F9934700}"/>
               </a:ext>
             </a:extLst>
           </p:cNvPr>
@@ -2877,7 +2877,7 @@
           <p:cNvPr id="4" name="Date Placeholder 3">
             <a:extLst>
               <a:ext uri="{FF2B5EF4-FFF2-40B4-BE49-F238E27FC236}">
-                <a16:creationId xmlns:a16="http://schemas.microsoft.com/office/drawing/2014/main" id="{6E580D46-A8DF-4370-50A2-0A8181EA80A8}"/>
+                <a16:creationId xmlns:a16="http://schemas.microsoft.com/office/drawing/2014/main" id="{6C4737ED-1A47-BA84-5402-174E2D9C1223}"/>
               </a:ext>
             </a:extLst>
           </p:cNvPr>
@@ -2911,9 +2911,9 @@
             </a:lvl1pPr>
           </a:lstStyle>
           <a:p>
-            <a:fld id="{A29D6AED-A3F2-4DDB-AB29-5BDBB7B2D1EC}" type="datetimeFigureOut">
+            <a:fld id="{12B4DC5E-5CE6-4800-B105-948B020CE4D7}" type="datetimeFigureOut">
               <a:rPr lang="en-US" smtClean="0"/>
-              <a:t>9/22/2026</a:t>
+              <a:t>9/23/2026</a:t>
             </a:fld>
             <a:endParaRPr lang="en-US"/>
           </a:p>
@@ -2924,7 +2924,7 @@
           <p:cNvPr id="5" name="Footer Placeholder 4">
             <a:extLst>
               <a:ext uri="{FF2B5EF4-FFF2-40B4-BE49-F238E27FC236}">
-                <a16:creationId xmlns:a16="http://schemas.microsoft.com/office/drawing/2014/main" id="{7740F373-1C77-477F-EBE4-60B79B5C25A1}"/>
+                <a16:creationId xmlns:a16="http://schemas.microsoft.com/office/drawing/2014/main" id="{16399068-2B6A-6BDC-E7BC-8DD56581698E}"/>
               </a:ext>
             </a:extLst>
           </p:cNvPr>
@@ -2967,7 +2967,7 @@
           <p:cNvPr id="6" name="Slide Number Placeholder 5">
             <a:extLst>
               <a:ext uri="{FF2B5EF4-FFF2-40B4-BE49-F238E27FC236}">
-                <a16:creationId xmlns:a16="http://schemas.microsoft.com/office/drawing/2014/main" id="{7F7C0239-B0D8-F674-A1B0-69B1590D3EC3}"/>
+                <a16:creationId xmlns:a16="http://schemas.microsoft.com/office/drawing/2014/main" id="{1ECBD50B-2E86-88F4-2FD4-A365A8B2825E}"/>
               </a:ext>
             </a:extLst>
           </p:cNvPr>
@@ -3001,7 +3001,7 @@
             </a:lvl1pPr>
           </a:lstStyle>
           <a:p>
-            <a:fld id="{22F4D96E-BE4E-4860-A9F5-F55433232C3A}" type="slidenum">
+            <a:fld id="{9CC4AB40-24CE-403C-8D90-29F002F94F66}" type="slidenum">
               <a:rPr lang="en-US" smtClean="0"/>
               <a:t>‹#›</a:t>
             </a:fld>
@@ -3012,7 +3012,7 @@
     </p:spTree>
     <p:extLst>
       <p:ext uri="{BB962C8B-B14F-4D97-AF65-F5344CB8AC3E}">
-        <p14:creationId xmlns:p14="http://schemas.microsoft.com/office/powerpoint/2010/main" val="922040701"/>
+        <p14:creationId xmlns:p14="http://schemas.microsoft.com/office/powerpoint/2010/main" val="2642138674"/>
       </p:ext>
     </p:extLst>
   </p:cSld>
@@ -3335,7 +3335,7 @@
           <p:cNvPr id="3" name="Picture 2">
             <a:extLst>
               <a:ext uri="{FF2B5EF4-FFF2-40B4-BE49-F238E27FC236}">
-                <a16:creationId xmlns:a16="http://schemas.microsoft.com/office/drawing/2014/main" id="{40D65F9F-8CE5-8522-CED5-EF5CE2A5BB41}"/>
+                <a16:creationId xmlns:a16="http://schemas.microsoft.com/office/drawing/2014/main" id="{FA6F3CE0-29C8-3B36-277E-E9644F5C8C9E}"/>
               </a:ext>
             </a:extLst>
           </p:cNvPr>
@@ -3345,7 +3345,7 @@
           <p:nvPr/>
         </p:nvPicPr>
         <p:blipFill>
-          <a:blip r:embed="rId2" r:link="rId3">
+          <a:blip r:embed="rId2">
             <a:extLst>
               <a:ext uri="{28A0092B-C50C-407E-A947-70E740481C1C}">
                 <a14:useLocalDpi xmlns:a14="http://schemas.microsoft.com/office/drawing/2010/main" val="0"/>
@@ -3369,7 +3369,7 @@
     </p:spTree>
     <p:extLst>
       <p:ext uri="{BB962C8B-B14F-4D97-AF65-F5344CB8AC3E}">
-        <p14:creationId xmlns:p14="http://schemas.microsoft.com/office/powerpoint/2010/main" val="1372737389"/>
+        <p14:creationId xmlns:p14="http://schemas.microsoft.com/office/powerpoint/2010/main" val="56987129"/>
       </p:ext>
     </p:extLst>
   </p:cSld>
@@ -3401,7 +3401,7 @@
           <p:cNvPr id="3" name="Picture 2">
             <a:extLst>
               <a:ext uri="{FF2B5EF4-FFF2-40B4-BE49-F238E27FC236}">
-                <a16:creationId xmlns:a16="http://schemas.microsoft.com/office/drawing/2014/main" id="{CCE388ED-5294-7247-2EF3-A96B02C7F8CF}"/>
+                <a16:creationId xmlns:a16="http://schemas.microsoft.com/office/drawing/2014/main" id="{4790A3B4-A2F6-9CF9-EC36-B400A1EAB091}"/>
               </a:ext>
             </a:extLst>
           </p:cNvPr>
@@ -3411,7 +3411,7 @@
           <p:nvPr/>
         </p:nvPicPr>
         <p:blipFill>
-          <a:blip r:embed="rId2" r:link="rId3">
+          <a:blip r:embed="rId2">
             <a:extLst>
               <a:ext uri="{28A0092B-C50C-407E-A947-70E740481C1C}">
                 <a14:useLocalDpi xmlns:a14="http://schemas.microsoft.com/office/drawing/2010/main" val="0"/>
@@ -3435,7 +3435,7 @@
     </p:spTree>
     <p:extLst>
       <p:ext uri="{BB962C8B-B14F-4D97-AF65-F5344CB8AC3E}">
-        <p14:creationId xmlns:p14="http://schemas.microsoft.com/office/powerpoint/2010/main" val="2300212093"/>
+        <p14:creationId xmlns:p14="http://schemas.microsoft.com/office/powerpoint/2010/main" val="155128323"/>
       </p:ext>
     </p:extLst>
   </p:cSld>
@@ -3467,7 +3467,7 @@
           <p:cNvPr id="3" name="Picture 2">
             <a:extLst>
               <a:ext uri="{FF2B5EF4-FFF2-40B4-BE49-F238E27FC236}">
-                <a16:creationId xmlns:a16="http://schemas.microsoft.com/office/drawing/2014/main" id="{F4CC8C02-93F8-B4AD-5BD7-A646E747852B}"/>
+                <a16:creationId xmlns:a16="http://schemas.microsoft.com/office/drawing/2014/main" id="{3F989DED-CB76-C1F9-20BE-FDA3FD5D90FF}"/>
               </a:ext>
             </a:extLst>
           </p:cNvPr>
@@ -3477,7 +3477,7 @@
           <p:nvPr/>
         </p:nvPicPr>
         <p:blipFill>
-          <a:blip r:embed="rId2" r:link="rId3">
+          <a:blip r:embed="rId2">
             <a:extLst>
               <a:ext uri="{28A0092B-C50C-407E-A947-70E740481C1C}">
                 <a14:useLocalDpi xmlns:a14="http://schemas.microsoft.com/office/drawing/2010/main" val="0"/>
@@ -3501,7 +3501,7 @@
     </p:spTree>
     <p:extLst>
       <p:ext uri="{BB962C8B-B14F-4D97-AF65-F5344CB8AC3E}">
-        <p14:creationId xmlns:p14="http://schemas.microsoft.com/office/powerpoint/2010/main" val="1203274766"/>
+        <p14:creationId xmlns:p14="http://schemas.microsoft.com/office/powerpoint/2010/main" val="683179582"/>
       </p:ext>
     </p:extLst>
   </p:cSld>
@@ -3533,7 +3533,7 @@
           <p:cNvPr id="3" name="Picture 2">
             <a:extLst>
               <a:ext uri="{FF2B5EF4-FFF2-40B4-BE49-F238E27FC236}">
-                <a16:creationId xmlns:a16="http://schemas.microsoft.com/office/drawing/2014/main" id="{1BB264CA-7104-4692-9460-41C2DFBC6F44}"/>
+                <a16:creationId xmlns:a16="http://schemas.microsoft.com/office/drawing/2014/main" id="{1678F33D-75E8-FAB1-B028-53DF6DAB1404}"/>
               </a:ext>
             </a:extLst>
           </p:cNvPr>
@@ -3543,7 +3543,7 @@
           <p:nvPr/>
         </p:nvPicPr>
         <p:blipFill>
-          <a:blip r:embed="rId2" r:link="rId3">
+          <a:blip r:embed="rId2">
             <a:extLst>
               <a:ext uri="{28A0092B-C50C-407E-A947-70E740481C1C}">
                 <a14:useLocalDpi xmlns:a14="http://schemas.microsoft.com/office/drawing/2010/main" val="0"/>
@@ -3567,7 +3567,7 @@
     </p:spTree>
     <p:extLst>
       <p:ext uri="{BB962C8B-B14F-4D97-AF65-F5344CB8AC3E}">
-        <p14:creationId xmlns:p14="http://schemas.microsoft.com/office/powerpoint/2010/main" val="79712204"/>
+        <p14:creationId xmlns:p14="http://schemas.microsoft.com/office/powerpoint/2010/main" val="1469216661"/>
       </p:ext>
     </p:extLst>
   </p:cSld>
@@ -3599,7 +3599,7 @@
           <p:cNvPr id="3" name="Picture 2">
             <a:extLst>
               <a:ext uri="{FF2B5EF4-FFF2-40B4-BE49-F238E27FC236}">
-                <a16:creationId xmlns:a16="http://schemas.microsoft.com/office/drawing/2014/main" id="{30D04D64-838A-DDD9-DB78-F7E22E21CBB7}"/>
+                <a16:creationId xmlns:a16="http://schemas.microsoft.com/office/drawing/2014/main" id="{4282BBF3-9D11-5149-E82B-16AFF2D3CDD4}"/>
               </a:ext>
             </a:extLst>
           </p:cNvPr>
@@ -3609,7 +3609,7 @@
           <p:nvPr/>
         </p:nvPicPr>
         <p:blipFill>
-          <a:blip r:embed="rId2" r:link="rId3">
+          <a:blip r:embed="rId2">
             <a:extLst>
               <a:ext uri="{28A0092B-C50C-407E-A947-70E740481C1C}">
                 <a14:useLocalDpi xmlns:a14="http://schemas.microsoft.com/office/drawing/2010/main" val="0"/>
@@ -3633,7 +3633,7 @@
     </p:spTree>
     <p:extLst>
       <p:ext uri="{BB962C8B-B14F-4D97-AF65-F5344CB8AC3E}">
-        <p14:creationId xmlns:p14="http://schemas.microsoft.com/office/powerpoint/2010/main" val="2397189096"/>
+        <p14:creationId xmlns:p14="http://schemas.microsoft.com/office/powerpoint/2010/main" val="1327550123"/>
       </p:ext>
     </p:extLst>
   </p:cSld>
@@ -3665,7 +3665,7 @@
           <p:cNvPr id="3" name="Picture 2">
             <a:extLst>
               <a:ext uri="{FF2B5EF4-FFF2-40B4-BE49-F238E27FC236}">
-                <a16:creationId xmlns:a16="http://schemas.microsoft.com/office/drawing/2014/main" id="{C8E347FA-8D02-898E-6092-C0D864921351}"/>
+                <a16:creationId xmlns:a16="http://schemas.microsoft.com/office/drawing/2014/main" id="{42BB5201-B6CE-FD42-2AF6-71963CCB18A4}"/>
               </a:ext>
             </a:extLst>
           </p:cNvPr>
@@ -3675,7 +3675,7 @@
           <p:nvPr/>
         </p:nvPicPr>
         <p:blipFill>
-          <a:blip r:embed="rId2" r:link="rId3">
+          <a:blip r:embed="rId2">
             <a:extLst>
               <a:ext uri="{28A0092B-C50C-407E-A947-70E740481C1C}">
                 <a14:useLocalDpi xmlns:a14="http://schemas.microsoft.com/office/drawing/2010/main" val="0"/>
@@ -3699,7 +3699,7 @@
     </p:spTree>
     <p:extLst>
       <p:ext uri="{BB962C8B-B14F-4D97-AF65-F5344CB8AC3E}">
-        <p14:creationId xmlns:p14="http://schemas.microsoft.com/office/powerpoint/2010/main" val="2257077521"/>
+        <p14:creationId xmlns:p14="http://schemas.microsoft.com/office/powerpoint/2010/main" val="1260412425"/>
       </p:ext>
     </p:extLst>
   </p:cSld>
@@ -3731,7 +3731,7 @@
           <p:cNvPr id="3" name="Picture 2">
             <a:extLst>
               <a:ext uri="{FF2B5EF4-FFF2-40B4-BE49-F238E27FC236}">
-                <a16:creationId xmlns:a16="http://schemas.microsoft.com/office/drawing/2014/main" id="{355AD107-16D5-C875-7A2A-B2E586A26D20}"/>
+                <a16:creationId xmlns:a16="http://schemas.microsoft.com/office/drawing/2014/main" id="{A166576C-8549-7A4F-2619-0C2642575EEE}"/>
               </a:ext>
             </a:extLst>
           </p:cNvPr>
@@ -3741,7 +3741,7 @@
           <p:nvPr/>
         </p:nvPicPr>
         <p:blipFill>
-          <a:blip r:embed="rId2" r:link="rId3">
+          <a:blip r:embed="rId2">
             <a:extLst>
               <a:ext uri="{28A0092B-C50C-407E-A947-70E740481C1C}">
                 <a14:useLocalDpi xmlns:a14="http://schemas.microsoft.com/office/drawing/2010/main" val="0"/>
@@ -3765,7 +3765,7 @@
     </p:spTree>
     <p:extLst>
       <p:ext uri="{BB962C8B-B14F-4D97-AF65-F5344CB8AC3E}">
-        <p14:creationId xmlns:p14="http://schemas.microsoft.com/office/powerpoint/2010/main" val="3173295598"/>
+        <p14:creationId xmlns:p14="http://schemas.microsoft.com/office/powerpoint/2010/main" val="3813632423"/>
       </p:ext>
     </p:extLst>
   </p:cSld>
@@ -3797,7 +3797,7 @@
           <p:cNvPr id="3" name="Picture 2">
             <a:extLst>
               <a:ext uri="{FF2B5EF4-FFF2-40B4-BE49-F238E27FC236}">
-                <a16:creationId xmlns:a16="http://schemas.microsoft.com/office/drawing/2014/main" id="{23E978CA-28EB-6F21-7216-19F9DF9C6585}"/>
+                <a16:creationId xmlns:a16="http://schemas.microsoft.com/office/drawing/2014/main" id="{163CDBE0-917B-36F7-ED6C-891C050D7912}"/>
               </a:ext>
             </a:extLst>
           </p:cNvPr>
@@ -3807,7 +3807,7 @@
           <p:nvPr/>
         </p:nvPicPr>
         <p:blipFill>
-          <a:blip r:embed="rId2" r:link="rId3">
+          <a:blip r:embed="rId2">
             <a:extLst>
               <a:ext uri="{28A0092B-C50C-407E-A947-70E740481C1C}">
                 <a14:useLocalDpi xmlns:a14="http://schemas.microsoft.com/office/drawing/2010/main" val="0"/>
@@ -3831,7 +3831,7 @@
     </p:spTree>
     <p:extLst>
       <p:ext uri="{BB962C8B-B14F-4D97-AF65-F5344CB8AC3E}">
-        <p14:creationId xmlns:p14="http://schemas.microsoft.com/office/powerpoint/2010/main" val="1310403865"/>
+        <p14:creationId xmlns:p14="http://schemas.microsoft.com/office/powerpoint/2010/main" val="2657490857"/>
       </p:ext>
     </p:extLst>
   </p:cSld>
@@ -3863,7 +3863,7 @@
           <p:cNvPr id="3" name="Picture 2">
             <a:extLst>
               <a:ext uri="{FF2B5EF4-FFF2-40B4-BE49-F238E27FC236}">
-                <a16:creationId xmlns:a16="http://schemas.microsoft.com/office/drawing/2014/main" id="{F956DF2F-2166-FB39-383E-43F57062B859}"/>
+                <a16:creationId xmlns:a16="http://schemas.microsoft.com/office/drawing/2014/main" id="{381B0A2F-FAA7-D4C0-8DA5-F34F325B0A7F}"/>
               </a:ext>
             </a:extLst>
           </p:cNvPr>
@@ -3873,7 +3873,7 @@
           <p:nvPr/>
         </p:nvPicPr>
         <p:blipFill>
-          <a:blip r:embed="rId2" r:link="rId3">
+          <a:blip r:embed="rId2">
             <a:extLst>
               <a:ext uri="{28A0092B-C50C-407E-A947-70E740481C1C}">
                 <a14:useLocalDpi xmlns:a14="http://schemas.microsoft.com/office/drawing/2010/main" val="0"/>
@@ -3897,7 +3897,7 @@
     </p:spTree>
     <p:extLst>
       <p:ext uri="{BB962C8B-B14F-4D97-AF65-F5344CB8AC3E}">
-        <p14:creationId xmlns:p14="http://schemas.microsoft.com/office/powerpoint/2010/main" val="1637709363"/>
+        <p14:creationId xmlns:p14="http://schemas.microsoft.com/office/powerpoint/2010/main" val="2771205098"/>
       </p:ext>
     </p:extLst>
   </p:cSld>
@@ -3929,7 +3929,7 @@
           <p:cNvPr id="3" name="Picture 2">
             <a:extLst>
               <a:ext uri="{FF2B5EF4-FFF2-40B4-BE49-F238E27FC236}">
-                <a16:creationId xmlns:a16="http://schemas.microsoft.com/office/drawing/2014/main" id="{C2D214FE-249A-8F27-7DFF-EF485CE86F76}"/>
+                <a16:creationId xmlns:a16="http://schemas.microsoft.com/office/drawing/2014/main" id="{ED88D57D-4A0D-A616-3467-8DACC3A93E69}"/>
               </a:ext>
             </a:extLst>
           </p:cNvPr>
@@ -3939,7 +3939,7 @@
           <p:nvPr/>
         </p:nvPicPr>
         <p:blipFill>
-          <a:blip r:embed="rId2" r:link="rId3">
+          <a:blip r:embed="rId2">
             <a:extLst>
               <a:ext uri="{28A0092B-C50C-407E-A947-70E740481C1C}">
                 <a14:useLocalDpi xmlns:a14="http://schemas.microsoft.com/office/drawing/2010/main" val="0"/>
@@ -3963,7 +3963,7 @@
     </p:spTree>
     <p:extLst>
       <p:ext uri="{BB962C8B-B14F-4D97-AF65-F5344CB8AC3E}">
-        <p14:creationId xmlns:p14="http://schemas.microsoft.com/office/powerpoint/2010/main" val="723707127"/>
+        <p14:creationId xmlns:p14="http://schemas.microsoft.com/office/powerpoint/2010/main" val="2127499742"/>
       </p:ext>
     </p:extLst>
   </p:cSld>

</xml_diff>

<commit_message>
Capture deck surface for full-bleed slides
</commit_message>
<xml_diff>
--- a/CareerCloset_Pitch_2_Exact.pptx
+++ b/CareerCloset_Pitch_2_Exact.pptx
@@ -138,7 +138,7 @@
           <p:cNvPr id="2" name="Title 1">
             <a:extLst>
               <a:ext uri="{FF2B5EF4-FFF2-40B4-BE49-F238E27FC236}">
-                <a16:creationId xmlns:a16="http://schemas.microsoft.com/office/drawing/2014/main" id="{019B52D7-7753-F114-9ADF-8942CF97C907}"/>
+                <a16:creationId xmlns:a16="http://schemas.microsoft.com/office/drawing/2014/main" id="{471F5D1A-AB4F-2D25-96D3-A81450FD9D50}"/>
               </a:ext>
             </a:extLst>
           </p:cNvPr>
@@ -175,7 +175,7 @@
           <p:cNvPr id="3" name="Subtitle 2">
             <a:extLst>
               <a:ext uri="{FF2B5EF4-FFF2-40B4-BE49-F238E27FC236}">
-                <a16:creationId xmlns:a16="http://schemas.microsoft.com/office/drawing/2014/main" id="{BBA07F09-5BCB-437B-097C-19F4EE6605CE}"/>
+                <a16:creationId xmlns:a16="http://schemas.microsoft.com/office/drawing/2014/main" id="{7F3C7E2F-F6E6-1B99-9DEF-8B99A94A934D}"/>
               </a:ext>
             </a:extLst>
           </p:cNvPr>
@@ -245,7 +245,7 @@
           <p:cNvPr id="4" name="Date Placeholder 3">
             <a:extLst>
               <a:ext uri="{FF2B5EF4-FFF2-40B4-BE49-F238E27FC236}">
-                <a16:creationId xmlns:a16="http://schemas.microsoft.com/office/drawing/2014/main" id="{699C782B-4273-7C93-6CA6-C9CB83AC3025}"/>
+                <a16:creationId xmlns:a16="http://schemas.microsoft.com/office/drawing/2014/main" id="{10F3A812-98A7-9C96-5BFB-A336B6DBB0A0}"/>
               </a:ext>
             </a:extLst>
           </p:cNvPr>
@@ -261,7 +261,7 @@
           <a:bodyPr/>
           <a:lstStyle/>
           <a:p>
-            <a:fld id="{12B4DC5E-5CE6-4800-B105-948B020CE4D7}" type="datetimeFigureOut">
+            <a:fld id="{8B11D9D7-41B1-47D8-A1AC-A705D338CF64}" type="datetimeFigureOut">
               <a:rPr lang="en-US" smtClean="0"/>
               <a:t>9/23/2026</a:t>
             </a:fld>
@@ -274,7 +274,7 @@
           <p:cNvPr id="5" name="Footer Placeholder 4">
             <a:extLst>
               <a:ext uri="{FF2B5EF4-FFF2-40B4-BE49-F238E27FC236}">
-                <a16:creationId xmlns:a16="http://schemas.microsoft.com/office/drawing/2014/main" id="{8F49E5EE-8CD5-EDC0-9E02-8FED98C3D53F}"/>
+                <a16:creationId xmlns:a16="http://schemas.microsoft.com/office/drawing/2014/main" id="{1C9FEA98-4B6C-ECC8-19ED-AC70EDE45534}"/>
               </a:ext>
             </a:extLst>
           </p:cNvPr>
@@ -299,7 +299,7 @@
           <p:cNvPr id="6" name="Slide Number Placeholder 5">
             <a:extLst>
               <a:ext uri="{FF2B5EF4-FFF2-40B4-BE49-F238E27FC236}">
-                <a16:creationId xmlns:a16="http://schemas.microsoft.com/office/drawing/2014/main" id="{38717E14-F18B-5AF3-255E-4E41603BAE86}"/>
+                <a16:creationId xmlns:a16="http://schemas.microsoft.com/office/drawing/2014/main" id="{02467DAF-B62E-6AD9-AFD8-FC33892B461B}"/>
               </a:ext>
             </a:extLst>
           </p:cNvPr>
@@ -315,7 +315,7 @@
           <a:bodyPr/>
           <a:lstStyle/>
           <a:p>
-            <a:fld id="{9CC4AB40-24CE-403C-8D90-29F002F94F66}" type="slidenum">
+            <a:fld id="{C9D0E25E-EE5E-4862-8D73-ADE52E842283}" type="slidenum">
               <a:rPr lang="en-US" smtClean="0"/>
               <a:t>‹#›</a:t>
             </a:fld>
@@ -326,7 +326,7 @@
     </p:spTree>
     <p:extLst>
       <p:ext uri="{BB962C8B-B14F-4D97-AF65-F5344CB8AC3E}">
-        <p14:creationId xmlns:p14="http://schemas.microsoft.com/office/powerpoint/2010/main" val="1829127715"/>
+        <p14:creationId xmlns:p14="http://schemas.microsoft.com/office/powerpoint/2010/main" val="416651623"/>
       </p:ext>
     </p:extLst>
   </p:cSld>
@@ -358,7 +358,7 @@
           <p:cNvPr id="2" name="Title 1">
             <a:extLst>
               <a:ext uri="{FF2B5EF4-FFF2-40B4-BE49-F238E27FC236}">
-                <a16:creationId xmlns:a16="http://schemas.microsoft.com/office/drawing/2014/main" id="{D8EDA3C7-A0D8-E730-9E8F-C1764A871D6C}"/>
+                <a16:creationId xmlns:a16="http://schemas.microsoft.com/office/drawing/2014/main" id="{553E6EA8-A682-BB55-B2EF-FECFCF09FFB6}"/>
               </a:ext>
             </a:extLst>
           </p:cNvPr>
@@ -386,7 +386,7 @@
           <p:cNvPr id="3" name="Vertical Text Placeholder 2">
             <a:extLst>
               <a:ext uri="{FF2B5EF4-FFF2-40B4-BE49-F238E27FC236}">
-                <a16:creationId xmlns:a16="http://schemas.microsoft.com/office/drawing/2014/main" id="{10ED9D83-161F-979C-9343-94D1402A9A00}"/>
+                <a16:creationId xmlns:a16="http://schemas.microsoft.com/office/drawing/2014/main" id="{D1A56AE7-D161-47C4-41C7-42FA93528043}"/>
               </a:ext>
             </a:extLst>
           </p:cNvPr>
@@ -443,7 +443,7 @@
           <p:cNvPr id="4" name="Date Placeholder 3">
             <a:extLst>
               <a:ext uri="{FF2B5EF4-FFF2-40B4-BE49-F238E27FC236}">
-                <a16:creationId xmlns:a16="http://schemas.microsoft.com/office/drawing/2014/main" id="{6DE3163C-23B9-63E8-9BD1-A45C0E7179CA}"/>
+                <a16:creationId xmlns:a16="http://schemas.microsoft.com/office/drawing/2014/main" id="{EB4ABF1C-136B-7C84-5C0D-89C3705D3BC4}"/>
               </a:ext>
             </a:extLst>
           </p:cNvPr>
@@ -459,7 +459,7 @@
           <a:bodyPr/>
           <a:lstStyle/>
           <a:p>
-            <a:fld id="{12B4DC5E-5CE6-4800-B105-948B020CE4D7}" type="datetimeFigureOut">
+            <a:fld id="{8B11D9D7-41B1-47D8-A1AC-A705D338CF64}" type="datetimeFigureOut">
               <a:rPr lang="en-US" smtClean="0"/>
               <a:t>9/23/2026</a:t>
             </a:fld>
@@ -472,7 +472,7 @@
           <p:cNvPr id="5" name="Footer Placeholder 4">
             <a:extLst>
               <a:ext uri="{FF2B5EF4-FFF2-40B4-BE49-F238E27FC236}">
-                <a16:creationId xmlns:a16="http://schemas.microsoft.com/office/drawing/2014/main" id="{2B8196C3-FF30-55DC-8334-0C9300796AD7}"/>
+                <a16:creationId xmlns:a16="http://schemas.microsoft.com/office/drawing/2014/main" id="{D33C5843-D746-CBE8-9860-FA112696DF00}"/>
               </a:ext>
             </a:extLst>
           </p:cNvPr>
@@ -497,7 +497,7 @@
           <p:cNvPr id="6" name="Slide Number Placeholder 5">
             <a:extLst>
               <a:ext uri="{FF2B5EF4-FFF2-40B4-BE49-F238E27FC236}">
-                <a16:creationId xmlns:a16="http://schemas.microsoft.com/office/drawing/2014/main" id="{7A3FF470-4C0D-C73E-28F2-8E797BE3E781}"/>
+                <a16:creationId xmlns:a16="http://schemas.microsoft.com/office/drawing/2014/main" id="{4CED21F6-A311-D941-1D46-7B38D7DEC53D}"/>
               </a:ext>
             </a:extLst>
           </p:cNvPr>
@@ -513,7 +513,7 @@
           <a:bodyPr/>
           <a:lstStyle/>
           <a:p>
-            <a:fld id="{9CC4AB40-24CE-403C-8D90-29F002F94F66}" type="slidenum">
+            <a:fld id="{C9D0E25E-EE5E-4862-8D73-ADE52E842283}" type="slidenum">
               <a:rPr lang="en-US" smtClean="0"/>
               <a:t>‹#›</a:t>
             </a:fld>
@@ -524,7 +524,7 @@
     </p:spTree>
     <p:extLst>
       <p:ext uri="{BB962C8B-B14F-4D97-AF65-F5344CB8AC3E}">
-        <p14:creationId xmlns:p14="http://schemas.microsoft.com/office/powerpoint/2010/main" val="781541696"/>
+        <p14:creationId xmlns:p14="http://schemas.microsoft.com/office/powerpoint/2010/main" val="3651881598"/>
       </p:ext>
     </p:extLst>
   </p:cSld>
@@ -556,7 +556,7 @@
           <p:cNvPr id="2" name="Vertical Title 1">
             <a:extLst>
               <a:ext uri="{FF2B5EF4-FFF2-40B4-BE49-F238E27FC236}">
-                <a16:creationId xmlns:a16="http://schemas.microsoft.com/office/drawing/2014/main" id="{80119E77-5BA2-0816-30F7-28EFCFFF914C}"/>
+                <a16:creationId xmlns:a16="http://schemas.microsoft.com/office/drawing/2014/main" id="{4E0CE013-C98F-A41E-B404-18A3610F516F}"/>
               </a:ext>
             </a:extLst>
           </p:cNvPr>
@@ -589,7 +589,7 @@
           <p:cNvPr id="3" name="Vertical Text Placeholder 2">
             <a:extLst>
               <a:ext uri="{FF2B5EF4-FFF2-40B4-BE49-F238E27FC236}">
-                <a16:creationId xmlns:a16="http://schemas.microsoft.com/office/drawing/2014/main" id="{E17E956E-6BA0-5A67-9E20-44AF18871E4D}"/>
+                <a16:creationId xmlns:a16="http://schemas.microsoft.com/office/drawing/2014/main" id="{FD856CF0-0D88-2631-1B56-62534B448438}"/>
               </a:ext>
             </a:extLst>
           </p:cNvPr>
@@ -651,7 +651,7 @@
           <p:cNvPr id="4" name="Date Placeholder 3">
             <a:extLst>
               <a:ext uri="{FF2B5EF4-FFF2-40B4-BE49-F238E27FC236}">
-                <a16:creationId xmlns:a16="http://schemas.microsoft.com/office/drawing/2014/main" id="{2E88699B-3376-6E74-7EF1-4A15751F5C65}"/>
+                <a16:creationId xmlns:a16="http://schemas.microsoft.com/office/drawing/2014/main" id="{A278C717-CB2E-2098-1E4B-C9283E658CB6}"/>
               </a:ext>
             </a:extLst>
           </p:cNvPr>
@@ -667,7 +667,7 @@
           <a:bodyPr/>
           <a:lstStyle/>
           <a:p>
-            <a:fld id="{12B4DC5E-5CE6-4800-B105-948B020CE4D7}" type="datetimeFigureOut">
+            <a:fld id="{8B11D9D7-41B1-47D8-A1AC-A705D338CF64}" type="datetimeFigureOut">
               <a:rPr lang="en-US" smtClean="0"/>
               <a:t>9/23/2026</a:t>
             </a:fld>
@@ -680,7 +680,7 @@
           <p:cNvPr id="5" name="Footer Placeholder 4">
             <a:extLst>
               <a:ext uri="{FF2B5EF4-FFF2-40B4-BE49-F238E27FC236}">
-                <a16:creationId xmlns:a16="http://schemas.microsoft.com/office/drawing/2014/main" id="{DF0C42D8-E15B-491F-B3B2-A88514E700F0}"/>
+                <a16:creationId xmlns:a16="http://schemas.microsoft.com/office/drawing/2014/main" id="{23E05064-DBDD-6F23-EA89-F31261C1B0C9}"/>
               </a:ext>
             </a:extLst>
           </p:cNvPr>
@@ -705,7 +705,7 @@
           <p:cNvPr id="6" name="Slide Number Placeholder 5">
             <a:extLst>
               <a:ext uri="{FF2B5EF4-FFF2-40B4-BE49-F238E27FC236}">
-                <a16:creationId xmlns:a16="http://schemas.microsoft.com/office/drawing/2014/main" id="{EB9A6CC9-6325-1B27-E119-9D07B8425989}"/>
+                <a16:creationId xmlns:a16="http://schemas.microsoft.com/office/drawing/2014/main" id="{FF838BF9-A949-6908-D7AA-AC52C41B1B42}"/>
               </a:ext>
             </a:extLst>
           </p:cNvPr>
@@ -721,7 +721,7 @@
           <a:bodyPr/>
           <a:lstStyle/>
           <a:p>
-            <a:fld id="{9CC4AB40-24CE-403C-8D90-29F002F94F66}" type="slidenum">
+            <a:fld id="{C9D0E25E-EE5E-4862-8D73-ADE52E842283}" type="slidenum">
               <a:rPr lang="en-US" smtClean="0"/>
               <a:t>‹#›</a:t>
             </a:fld>
@@ -732,7 +732,7 @@
     </p:spTree>
     <p:extLst>
       <p:ext uri="{BB962C8B-B14F-4D97-AF65-F5344CB8AC3E}">
-        <p14:creationId xmlns:p14="http://schemas.microsoft.com/office/powerpoint/2010/main" val="440877757"/>
+        <p14:creationId xmlns:p14="http://schemas.microsoft.com/office/powerpoint/2010/main" val="333555674"/>
       </p:ext>
     </p:extLst>
   </p:cSld>
@@ -764,7 +764,7 @@
           <p:cNvPr id="2" name="Title 1">
             <a:extLst>
               <a:ext uri="{FF2B5EF4-FFF2-40B4-BE49-F238E27FC236}">
-                <a16:creationId xmlns:a16="http://schemas.microsoft.com/office/drawing/2014/main" id="{A241F7C5-0F01-19F9-3789-776B493CB948}"/>
+                <a16:creationId xmlns:a16="http://schemas.microsoft.com/office/drawing/2014/main" id="{5B1BE182-C723-8413-9EB4-60DF44F7C623}"/>
               </a:ext>
             </a:extLst>
           </p:cNvPr>
@@ -792,7 +792,7 @@
           <p:cNvPr id="3" name="Content Placeholder 2">
             <a:extLst>
               <a:ext uri="{FF2B5EF4-FFF2-40B4-BE49-F238E27FC236}">
-                <a16:creationId xmlns:a16="http://schemas.microsoft.com/office/drawing/2014/main" id="{DB1D17BB-F0A2-169C-431D-7259F798D2D5}"/>
+                <a16:creationId xmlns:a16="http://schemas.microsoft.com/office/drawing/2014/main" id="{877BD32A-BE6E-2892-A083-472CC2858A87}"/>
               </a:ext>
             </a:extLst>
           </p:cNvPr>
@@ -849,7 +849,7 @@
           <p:cNvPr id="4" name="Date Placeholder 3">
             <a:extLst>
               <a:ext uri="{FF2B5EF4-FFF2-40B4-BE49-F238E27FC236}">
-                <a16:creationId xmlns:a16="http://schemas.microsoft.com/office/drawing/2014/main" id="{412AED36-293E-D182-EFEB-47ED031FA9CB}"/>
+                <a16:creationId xmlns:a16="http://schemas.microsoft.com/office/drawing/2014/main" id="{88F605F9-92D7-D17F-A971-2CA47A3271C7}"/>
               </a:ext>
             </a:extLst>
           </p:cNvPr>
@@ -865,7 +865,7 @@
           <a:bodyPr/>
           <a:lstStyle/>
           <a:p>
-            <a:fld id="{12B4DC5E-5CE6-4800-B105-948B020CE4D7}" type="datetimeFigureOut">
+            <a:fld id="{8B11D9D7-41B1-47D8-A1AC-A705D338CF64}" type="datetimeFigureOut">
               <a:rPr lang="en-US" smtClean="0"/>
               <a:t>9/23/2026</a:t>
             </a:fld>
@@ -878,7 +878,7 @@
           <p:cNvPr id="5" name="Footer Placeholder 4">
             <a:extLst>
               <a:ext uri="{FF2B5EF4-FFF2-40B4-BE49-F238E27FC236}">
-                <a16:creationId xmlns:a16="http://schemas.microsoft.com/office/drawing/2014/main" id="{3CF9AC71-155D-F0C4-47C1-FD7050398069}"/>
+                <a16:creationId xmlns:a16="http://schemas.microsoft.com/office/drawing/2014/main" id="{082BC6C2-7719-FBF3-964E-2F3C4A8AE276}"/>
               </a:ext>
             </a:extLst>
           </p:cNvPr>
@@ -903,7 +903,7 @@
           <p:cNvPr id="6" name="Slide Number Placeholder 5">
             <a:extLst>
               <a:ext uri="{FF2B5EF4-FFF2-40B4-BE49-F238E27FC236}">
-                <a16:creationId xmlns:a16="http://schemas.microsoft.com/office/drawing/2014/main" id="{FF729E13-2070-E475-6E01-409815D03307}"/>
+                <a16:creationId xmlns:a16="http://schemas.microsoft.com/office/drawing/2014/main" id="{10E676C6-F291-91E7-F402-F6ED90B4D47A}"/>
               </a:ext>
             </a:extLst>
           </p:cNvPr>
@@ -919,7 +919,7 @@
           <a:bodyPr/>
           <a:lstStyle/>
           <a:p>
-            <a:fld id="{9CC4AB40-24CE-403C-8D90-29F002F94F66}" type="slidenum">
+            <a:fld id="{C9D0E25E-EE5E-4862-8D73-ADE52E842283}" type="slidenum">
               <a:rPr lang="en-US" smtClean="0"/>
               <a:t>‹#›</a:t>
             </a:fld>
@@ -930,7 +930,7 @@
     </p:spTree>
     <p:extLst>
       <p:ext uri="{BB962C8B-B14F-4D97-AF65-F5344CB8AC3E}">
-        <p14:creationId xmlns:p14="http://schemas.microsoft.com/office/powerpoint/2010/main" val="4090977967"/>
+        <p14:creationId xmlns:p14="http://schemas.microsoft.com/office/powerpoint/2010/main" val="3980404050"/>
       </p:ext>
     </p:extLst>
   </p:cSld>
@@ -962,7 +962,7 @@
           <p:cNvPr id="2" name="Title 1">
             <a:extLst>
               <a:ext uri="{FF2B5EF4-FFF2-40B4-BE49-F238E27FC236}">
-                <a16:creationId xmlns:a16="http://schemas.microsoft.com/office/drawing/2014/main" id="{F8213880-AF9A-47BA-8040-C5B3F94E19C8}"/>
+                <a16:creationId xmlns:a16="http://schemas.microsoft.com/office/drawing/2014/main" id="{95D100C6-E0A6-A703-EB30-BDBE2E805A97}"/>
               </a:ext>
             </a:extLst>
           </p:cNvPr>
@@ -999,7 +999,7 @@
           <p:cNvPr id="3" name="Text Placeholder 2">
             <a:extLst>
               <a:ext uri="{FF2B5EF4-FFF2-40B4-BE49-F238E27FC236}">
-                <a16:creationId xmlns:a16="http://schemas.microsoft.com/office/drawing/2014/main" id="{FE161C6C-2382-B8ED-2137-C42B9C24212E}"/>
+                <a16:creationId xmlns:a16="http://schemas.microsoft.com/office/drawing/2014/main" id="{1C3FDBF9-2ADF-6C61-9434-33E24543A462}"/>
               </a:ext>
             </a:extLst>
           </p:cNvPr>
@@ -1124,7 +1124,7 @@
           <p:cNvPr id="4" name="Date Placeholder 3">
             <a:extLst>
               <a:ext uri="{FF2B5EF4-FFF2-40B4-BE49-F238E27FC236}">
-                <a16:creationId xmlns:a16="http://schemas.microsoft.com/office/drawing/2014/main" id="{B37D9672-EB94-D0D6-A161-9E3812F0CB68}"/>
+                <a16:creationId xmlns:a16="http://schemas.microsoft.com/office/drawing/2014/main" id="{F8A3E47F-C5B1-2D2C-F543-69F2A39B308E}"/>
               </a:ext>
             </a:extLst>
           </p:cNvPr>
@@ -1140,7 +1140,7 @@
           <a:bodyPr/>
           <a:lstStyle/>
           <a:p>
-            <a:fld id="{12B4DC5E-5CE6-4800-B105-948B020CE4D7}" type="datetimeFigureOut">
+            <a:fld id="{8B11D9D7-41B1-47D8-A1AC-A705D338CF64}" type="datetimeFigureOut">
               <a:rPr lang="en-US" smtClean="0"/>
               <a:t>9/23/2026</a:t>
             </a:fld>
@@ -1153,7 +1153,7 @@
           <p:cNvPr id="5" name="Footer Placeholder 4">
             <a:extLst>
               <a:ext uri="{FF2B5EF4-FFF2-40B4-BE49-F238E27FC236}">
-                <a16:creationId xmlns:a16="http://schemas.microsoft.com/office/drawing/2014/main" id="{FE4BC55D-5CE1-D7FA-BBE9-79C067A0F6C8}"/>
+                <a16:creationId xmlns:a16="http://schemas.microsoft.com/office/drawing/2014/main" id="{39DDE541-3A7A-1F63-60FF-284FDAF9188F}"/>
               </a:ext>
             </a:extLst>
           </p:cNvPr>
@@ -1178,7 +1178,7 @@
           <p:cNvPr id="6" name="Slide Number Placeholder 5">
             <a:extLst>
               <a:ext uri="{FF2B5EF4-FFF2-40B4-BE49-F238E27FC236}">
-                <a16:creationId xmlns:a16="http://schemas.microsoft.com/office/drawing/2014/main" id="{858553CB-EA1E-F5F8-D5D4-45F0494E6C69}"/>
+                <a16:creationId xmlns:a16="http://schemas.microsoft.com/office/drawing/2014/main" id="{BAA4ADE7-ADC3-24C9-349E-33F8C9086193}"/>
               </a:ext>
             </a:extLst>
           </p:cNvPr>
@@ -1194,7 +1194,7 @@
           <a:bodyPr/>
           <a:lstStyle/>
           <a:p>
-            <a:fld id="{9CC4AB40-24CE-403C-8D90-29F002F94F66}" type="slidenum">
+            <a:fld id="{C9D0E25E-EE5E-4862-8D73-ADE52E842283}" type="slidenum">
               <a:rPr lang="en-US" smtClean="0"/>
               <a:t>‹#›</a:t>
             </a:fld>
@@ -1205,7 +1205,7 @@
     </p:spTree>
     <p:extLst>
       <p:ext uri="{BB962C8B-B14F-4D97-AF65-F5344CB8AC3E}">
-        <p14:creationId xmlns:p14="http://schemas.microsoft.com/office/powerpoint/2010/main" val="1000704955"/>
+        <p14:creationId xmlns:p14="http://schemas.microsoft.com/office/powerpoint/2010/main" val="3761479230"/>
       </p:ext>
     </p:extLst>
   </p:cSld>
@@ -1237,7 +1237,7 @@
           <p:cNvPr id="2" name="Title 1">
             <a:extLst>
               <a:ext uri="{FF2B5EF4-FFF2-40B4-BE49-F238E27FC236}">
-                <a16:creationId xmlns:a16="http://schemas.microsoft.com/office/drawing/2014/main" id="{71957049-FECA-3D5F-703A-688C9F7874D0}"/>
+                <a16:creationId xmlns:a16="http://schemas.microsoft.com/office/drawing/2014/main" id="{0715C64C-0199-E271-D4D3-E38BFCC85A11}"/>
               </a:ext>
             </a:extLst>
           </p:cNvPr>
@@ -1265,7 +1265,7 @@
           <p:cNvPr id="3" name="Content Placeholder 2">
             <a:extLst>
               <a:ext uri="{FF2B5EF4-FFF2-40B4-BE49-F238E27FC236}">
-                <a16:creationId xmlns:a16="http://schemas.microsoft.com/office/drawing/2014/main" id="{77BB2E2A-EA87-D1DB-2A60-71CA575FB255}"/>
+                <a16:creationId xmlns:a16="http://schemas.microsoft.com/office/drawing/2014/main" id="{8E15CC8C-0B06-8C88-AFE3-0E391078DCF6}"/>
               </a:ext>
             </a:extLst>
           </p:cNvPr>
@@ -1327,7 +1327,7 @@
           <p:cNvPr id="4" name="Content Placeholder 3">
             <a:extLst>
               <a:ext uri="{FF2B5EF4-FFF2-40B4-BE49-F238E27FC236}">
-                <a16:creationId xmlns:a16="http://schemas.microsoft.com/office/drawing/2014/main" id="{8779F318-7872-80CD-FD8B-A736D010171F}"/>
+                <a16:creationId xmlns:a16="http://schemas.microsoft.com/office/drawing/2014/main" id="{BB94D67E-6422-3494-F41E-C5CDF519548E}"/>
               </a:ext>
             </a:extLst>
           </p:cNvPr>
@@ -1389,7 +1389,7 @@
           <p:cNvPr id="5" name="Date Placeholder 4">
             <a:extLst>
               <a:ext uri="{FF2B5EF4-FFF2-40B4-BE49-F238E27FC236}">
-                <a16:creationId xmlns:a16="http://schemas.microsoft.com/office/drawing/2014/main" id="{3FF527F7-4D1D-04DC-A913-DC5EED8D266C}"/>
+                <a16:creationId xmlns:a16="http://schemas.microsoft.com/office/drawing/2014/main" id="{F06D7C23-E336-B373-2D8F-382A16C60A7F}"/>
               </a:ext>
             </a:extLst>
           </p:cNvPr>
@@ -1405,7 +1405,7 @@
           <a:bodyPr/>
           <a:lstStyle/>
           <a:p>
-            <a:fld id="{12B4DC5E-5CE6-4800-B105-948B020CE4D7}" type="datetimeFigureOut">
+            <a:fld id="{8B11D9D7-41B1-47D8-A1AC-A705D338CF64}" type="datetimeFigureOut">
               <a:rPr lang="en-US" smtClean="0"/>
               <a:t>9/23/2026</a:t>
             </a:fld>
@@ -1418,7 +1418,7 @@
           <p:cNvPr id="6" name="Footer Placeholder 5">
             <a:extLst>
               <a:ext uri="{FF2B5EF4-FFF2-40B4-BE49-F238E27FC236}">
-                <a16:creationId xmlns:a16="http://schemas.microsoft.com/office/drawing/2014/main" id="{50AC79E3-1681-491A-52CF-007661EDDF15}"/>
+                <a16:creationId xmlns:a16="http://schemas.microsoft.com/office/drawing/2014/main" id="{F73894BA-DFF4-5B73-E73B-76B8673E245D}"/>
               </a:ext>
             </a:extLst>
           </p:cNvPr>
@@ -1443,7 +1443,7 @@
           <p:cNvPr id="7" name="Slide Number Placeholder 6">
             <a:extLst>
               <a:ext uri="{FF2B5EF4-FFF2-40B4-BE49-F238E27FC236}">
-                <a16:creationId xmlns:a16="http://schemas.microsoft.com/office/drawing/2014/main" id="{42ADEBC1-59E3-36D2-35E1-6450D0083751}"/>
+                <a16:creationId xmlns:a16="http://schemas.microsoft.com/office/drawing/2014/main" id="{CFFCE29C-5972-5B4D-1E7F-DB3FE75EAE4A}"/>
               </a:ext>
             </a:extLst>
           </p:cNvPr>
@@ -1459,7 +1459,7 @@
           <a:bodyPr/>
           <a:lstStyle/>
           <a:p>
-            <a:fld id="{9CC4AB40-24CE-403C-8D90-29F002F94F66}" type="slidenum">
+            <a:fld id="{C9D0E25E-EE5E-4862-8D73-ADE52E842283}" type="slidenum">
               <a:rPr lang="en-US" smtClean="0"/>
               <a:t>‹#›</a:t>
             </a:fld>
@@ -1470,7 +1470,7 @@
     </p:spTree>
     <p:extLst>
       <p:ext uri="{BB962C8B-B14F-4D97-AF65-F5344CB8AC3E}">
-        <p14:creationId xmlns:p14="http://schemas.microsoft.com/office/powerpoint/2010/main" val="1292154299"/>
+        <p14:creationId xmlns:p14="http://schemas.microsoft.com/office/powerpoint/2010/main" val="3297319591"/>
       </p:ext>
     </p:extLst>
   </p:cSld>
@@ -1502,7 +1502,7 @@
           <p:cNvPr id="2" name="Title 1">
             <a:extLst>
               <a:ext uri="{FF2B5EF4-FFF2-40B4-BE49-F238E27FC236}">
-                <a16:creationId xmlns:a16="http://schemas.microsoft.com/office/drawing/2014/main" id="{ABA8F5A4-0F55-E868-7297-2452B0A9D5C8}"/>
+                <a16:creationId xmlns:a16="http://schemas.microsoft.com/office/drawing/2014/main" id="{BE0982C8-CAC9-2C27-ABD2-04DD84E43CFE}"/>
               </a:ext>
             </a:extLst>
           </p:cNvPr>
@@ -1535,7 +1535,7 @@
           <p:cNvPr id="3" name="Text Placeholder 2">
             <a:extLst>
               <a:ext uri="{FF2B5EF4-FFF2-40B4-BE49-F238E27FC236}">
-                <a16:creationId xmlns:a16="http://schemas.microsoft.com/office/drawing/2014/main" id="{1046BD37-B716-439B-9170-9938E26AB4A4}"/>
+                <a16:creationId xmlns:a16="http://schemas.microsoft.com/office/drawing/2014/main" id="{08033F8C-7277-6B10-29A2-4D259CC39C4E}"/>
               </a:ext>
             </a:extLst>
           </p:cNvPr>
@@ -1606,7 +1606,7 @@
           <p:cNvPr id="4" name="Content Placeholder 3">
             <a:extLst>
               <a:ext uri="{FF2B5EF4-FFF2-40B4-BE49-F238E27FC236}">
-                <a16:creationId xmlns:a16="http://schemas.microsoft.com/office/drawing/2014/main" id="{E8D8C83F-C98B-7718-1B07-4A6958A78114}"/>
+                <a16:creationId xmlns:a16="http://schemas.microsoft.com/office/drawing/2014/main" id="{CA840184-FDC9-E4E0-05B2-10B8060DDBC6}"/>
               </a:ext>
             </a:extLst>
           </p:cNvPr>
@@ -1668,7 +1668,7 @@
           <p:cNvPr id="5" name="Text Placeholder 4">
             <a:extLst>
               <a:ext uri="{FF2B5EF4-FFF2-40B4-BE49-F238E27FC236}">
-                <a16:creationId xmlns:a16="http://schemas.microsoft.com/office/drawing/2014/main" id="{9398472F-3C6D-2D28-582E-93C3A234CFFB}"/>
+                <a16:creationId xmlns:a16="http://schemas.microsoft.com/office/drawing/2014/main" id="{886C685E-25C4-1D30-7358-55B0A649C8E4}"/>
               </a:ext>
             </a:extLst>
           </p:cNvPr>
@@ -1739,7 +1739,7 @@
           <p:cNvPr id="6" name="Content Placeholder 5">
             <a:extLst>
               <a:ext uri="{FF2B5EF4-FFF2-40B4-BE49-F238E27FC236}">
-                <a16:creationId xmlns:a16="http://schemas.microsoft.com/office/drawing/2014/main" id="{0066C38F-974D-4224-9EBC-5A2A35E80FF8}"/>
+                <a16:creationId xmlns:a16="http://schemas.microsoft.com/office/drawing/2014/main" id="{D35B66E6-5319-5E81-32FB-34FA9C6F17E1}"/>
               </a:ext>
             </a:extLst>
           </p:cNvPr>
@@ -1801,7 +1801,7 @@
           <p:cNvPr id="7" name="Date Placeholder 6">
             <a:extLst>
               <a:ext uri="{FF2B5EF4-FFF2-40B4-BE49-F238E27FC236}">
-                <a16:creationId xmlns:a16="http://schemas.microsoft.com/office/drawing/2014/main" id="{B6A13591-8614-DBC5-5DF3-A04AB4CBC014}"/>
+                <a16:creationId xmlns:a16="http://schemas.microsoft.com/office/drawing/2014/main" id="{14A19FB6-4FFE-910E-D211-346D9F76A7A3}"/>
               </a:ext>
             </a:extLst>
           </p:cNvPr>
@@ -1817,7 +1817,7 @@
           <a:bodyPr/>
           <a:lstStyle/>
           <a:p>
-            <a:fld id="{12B4DC5E-5CE6-4800-B105-948B020CE4D7}" type="datetimeFigureOut">
+            <a:fld id="{8B11D9D7-41B1-47D8-A1AC-A705D338CF64}" type="datetimeFigureOut">
               <a:rPr lang="en-US" smtClean="0"/>
               <a:t>9/23/2026</a:t>
             </a:fld>
@@ -1830,7 +1830,7 @@
           <p:cNvPr id="8" name="Footer Placeholder 7">
             <a:extLst>
               <a:ext uri="{FF2B5EF4-FFF2-40B4-BE49-F238E27FC236}">
-                <a16:creationId xmlns:a16="http://schemas.microsoft.com/office/drawing/2014/main" id="{2ED98E24-9EDE-8E2C-4D3C-7108F58336A7}"/>
+                <a16:creationId xmlns:a16="http://schemas.microsoft.com/office/drawing/2014/main" id="{E801E59A-C58E-FE62-9E5D-39BC47B596C4}"/>
               </a:ext>
             </a:extLst>
           </p:cNvPr>
@@ -1855,7 +1855,7 @@
           <p:cNvPr id="9" name="Slide Number Placeholder 8">
             <a:extLst>
               <a:ext uri="{FF2B5EF4-FFF2-40B4-BE49-F238E27FC236}">
-                <a16:creationId xmlns:a16="http://schemas.microsoft.com/office/drawing/2014/main" id="{8450E2ED-F293-45F1-8932-934743F3C695}"/>
+                <a16:creationId xmlns:a16="http://schemas.microsoft.com/office/drawing/2014/main" id="{1C325A4F-B687-0BA9-0D3E-37DE87087FD1}"/>
               </a:ext>
             </a:extLst>
           </p:cNvPr>
@@ -1871,7 +1871,7 @@
           <a:bodyPr/>
           <a:lstStyle/>
           <a:p>
-            <a:fld id="{9CC4AB40-24CE-403C-8D90-29F002F94F66}" type="slidenum">
+            <a:fld id="{C9D0E25E-EE5E-4862-8D73-ADE52E842283}" type="slidenum">
               <a:rPr lang="en-US" smtClean="0"/>
               <a:t>‹#›</a:t>
             </a:fld>
@@ -1882,7 +1882,7 @@
     </p:spTree>
     <p:extLst>
       <p:ext uri="{BB962C8B-B14F-4D97-AF65-F5344CB8AC3E}">
-        <p14:creationId xmlns:p14="http://schemas.microsoft.com/office/powerpoint/2010/main" val="15757033"/>
+        <p14:creationId xmlns:p14="http://schemas.microsoft.com/office/powerpoint/2010/main" val="2807142489"/>
       </p:ext>
     </p:extLst>
   </p:cSld>
@@ -1914,7 +1914,7 @@
           <p:cNvPr id="2" name="Title 1">
             <a:extLst>
               <a:ext uri="{FF2B5EF4-FFF2-40B4-BE49-F238E27FC236}">
-                <a16:creationId xmlns:a16="http://schemas.microsoft.com/office/drawing/2014/main" id="{D4931840-4C78-BF90-92BA-E6F33FDCCF14}"/>
+                <a16:creationId xmlns:a16="http://schemas.microsoft.com/office/drawing/2014/main" id="{B161C61D-8181-1812-2F7B-831E57329FB5}"/>
               </a:ext>
             </a:extLst>
           </p:cNvPr>
@@ -1942,7 +1942,7 @@
           <p:cNvPr id="3" name="Date Placeholder 2">
             <a:extLst>
               <a:ext uri="{FF2B5EF4-FFF2-40B4-BE49-F238E27FC236}">
-                <a16:creationId xmlns:a16="http://schemas.microsoft.com/office/drawing/2014/main" id="{F0E58F0F-DB66-304F-0D96-FA2EE7956841}"/>
+                <a16:creationId xmlns:a16="http://schemas.microsoft.com/office/drawing/2014/main" id="{D11CEBB8-075F-0F8B-6722-12B4D4E11371}"/>
               </a:ext>
             </a:extLst>
           </p:cNvPr>
@@ -1958,7 +1958,7 @@
           <a:bodyPr/>
           <a:lstStyle/>
           <a:p>
-            <a:fld id="{12B4DC5E-5CE6-4800-B105-948B020CE4D7}" type="datetimeFigureOut">
+            <a:fld id="{8B11D9D7-41B1-47D8-A1AC-A705D338CF64}" type="datetimeFigureOut">
               <a:rPr lang="en-US" smtClean="0"/>
               <a:t>9/23/2026</a:t>
             </a:fld>
@@ -1971,7 +1971,7 @@
           <p:cNvPr id="4" name="Footer Placeholder 3">
             <a:extLst>
               <a:ext uri="{FF2B5EF4-FFF2-40B4-BE49-F238E27FC236}">
-                <a16:creationId xmlns:a16="http://schemas.microsoft.com/office/drawing/2014/main" id="{7D32F7B8-85F3-B58A-E506-180DA83C13CC}"/>
+                <a16:creationId xmlns:a16="http://schemas.microsoft.com/office/drawing/2014/main" id="{0FEA82C6-2AB2-0D1F-3859-DE60C9A2BBB2}"/>
               </a:ext>
             </a:extLst>
           </p:cNvPr>
@@ -1996,7 +1996,7 @@
           <p:cNvPr id="5" name="Slide Number Placeholder 4">
             <a:extLst>
               <a:ext uri="{FF2B5EF4-FFF2-40B4-BE49-F238E27FC236}">
-                <a16:creationId xmlns:a16="http://schemas.microsoft.com/office/drawing/2014/main" id="{474C6684-EF50-11D3-19F5-97D1FBFF9E46}"/>
+                <a16:creationId xmlns:a16="http://schemas.microsoft.com/office/drawing/2014/main" id="{BC044A05-04C2-4AAB-CA48-9689EA53D12F}"/>
               </a:ext>
             </a:extLst>
           </p:cNvPr>
@@ -2012,7 +2012,7 @@
           <a:bodyPr/>
           <a:lstStyle/>
           <a:p>
-            <a:fld id="{9CC4AB40-24CE-403C-8D90-29F002F94F66}" type="slidenum">
+            <a:fld id="{C9D0E25E-EE5E-4862-8D73-ADE52E842283}" type="slidenum">
               <a:rPr lang="en-US" smtClean="0"/>
               <a:t>‹#›</a:t>
             </a:fld>
@@ -2023,7 +2023,7 @@
     </p:spTree>
     <p:extLst>
       <p:ext uri="{BB962C8B-B14F-4D97-AF65-F5344CB8AC3E}">
-        <p14:creationId xmlns:p14="http://schemas.microsoft.com/office/powerpoint/2010/main" val="1359187602"/>
+        <p14:creationId xmlns:p14="http://schemas.microsoft.com/office/powerpoint/2010/main" val="958577469"/>
       </p:ext>
     </p:extLst>
   </p:cSld>
@@ -2055,7 +2055,7 @@
           <p:cNvPr id="2" name="Date Placeholder 1">
             <a:extLst>
               <a:ext uri="{FF2B5EF4-FFF2-40B4-BE49-F238E27FC236}">
-                <a16:creationId xmlns:a16="http://schemas.microsoft.com/office/drawing/2014/main" id="{98370DCE-3BCA-E3F5-23E1-685F96E35A7E}"/>
+                <a16:creationId xmlns:a16="http://schemas.microsoft.com/office/drawing/2014/main" id="{44758F21-F20C-4B70-04D2-EF2EC38ADFE4}"/>
               </a:ext>
             </a:extLst>
           </p:cNvPr>
@@ -2071,7 +2071,7 @@
           <a:bodyPr/>
           <a:lstStyle/>
           <a:p>
-            <a:fld id="{12B4DC5E-5CE6-4800-B105-948B020CE4D7}" type="datetimeFigureOut">
+            <a:fld id="{8B11D9D7-41B1-47D8-A1AC-A705D338CF64}" type="datetimeFigureOut">
               <a:rPr lang="en-US" smtClean="0"/>
               <a:t>9/23/2026</a:t>
             </a:fld>
@@ -2084,7 +2084,7 @@
           <p:cNvPr id="3" name="Footer Placeholder 2">
             <a:extLst>
               <a:ext uri="{FF2B5EF4-FFF2-40B4-BE49-F238E27FC236}">
-                <a16:creationId xmlns:a16="http://schemas.microsoft.com/office/drawing/2014/main" id="{13996654-84CE-DFEC-70AD-E76785DFB3DC}"/>
+                <a16:creationId xmlns:a16="http://schemas.microsoft.com/office/drawing/2014/main" id="{BD170230-6433-8F90-1BB4-98AA745D7AEE}"/>
               </a:ext>
             </a:extLst>
           </p:cNvPr>
@@ -2109,7 +2109,7 @@
           <p:cNvPr id="4" name="Slide Number Placeholder 3">
             <a:extLst>
               <a:ext uri="{FF2B5EF4-FFF2-40B4-BE49-F238E27FC236}">
-                <a16:creationId xmlns:a16="http://schemas.microsoft.com/office/drawing/2014/main" id="{88BA6BFA-D78D-719A-1FCD-3D3CAA1907DE}"/>
+                <a16:creationId xmlns:a16="http://schemas.microsoft.com/office/drawing/2014/main" id="{8FA0B5C3-2B4B-1195-DBF7-9B8FBA278670}"/>
               </a:ext>
             </a:extLst>
           </p:cNvPr>
@@ -2125,7 +2125,7 @@
           <a:bodyPr/>
           <a:lstStyle/>
           <a:p>
-            <a:fld id="{9CC4AB40-24CE-403C-8D90-29F002F94F66}" type="slidenum">
+            <a:fld id="{C9D0E25E-EE5E-4862-8D73-ADE52E842283}" type="slidenum">
               <a:rPr lang="en-US" smtClean="0"/>
               <a:t>‹#›</a:t>
             </a:fld>
@@ -2136,7 +2136,7 @@
     </p:spTree>
     <p:extLst>
       <p:ext uri="{BB962C8B-B14F-4D97-AF65-F5344CB8AC3E}">
-        <p14:creationId xmlns:p14="http://schemas.microsoft.com/office/powerpoint/2010/main" val="353146374"/>
+        <p14:creationId xmlns:p14="http://schemas.microsoft.com/office/powerpoint/2010/main" val="806829619"/>
       </p:ext>
     </p:extLst>
   </p:cSld>
@@ -2168,7 +2168,7 @@
           <p:cNvPr id="2" name="Title 1">
             <a:extLst>
               <a:ext uri="{FF2B5EF4-FFF2-40B4-BE49-F238E27FC236}">
-                <a16:creationId xmlns:a16="http://schemas.microsoft.com/office/drawing/2014/main" id="{A47557B5-6CE4-20B7-2C65-934FB15EC285}"/>
+                <a16:creationId xmlns:a16="http://schemas.microsoft.com/office/drawing/2014/main" id="{E8A41180-39EC-0DF7-4E04-FB804DDF0D29}"/>
               </a:ext>
             </a:extLst>
           </p:cNvPr>
@@ -2205,7 +2205,7 @@
           <p:cNvPr id="3" name="Content Placeholder 2">
             <a:extLst>
               <a:ext uri="{FF2B5EF4-FFF2-40B4-BE49-F238E27FC236}">
-                <a16:creationId xmlns:a16="http://schemas.microsoft.com/office/drawing/2014/main" id="{9E1A78AB-8EF7-3B26-53C8-0A82EC182C7C}"/>
+                <a16:creationId xmlns:a16="http://schemas.microsoft.com/office/drawing/2014/main" id="{8F691D25-881A-37DF-D8A0-D85493CE96F0}"/>
               </a:ext>
             </a:extLst>
           </p:cNvPr>
@@ -2295,7 +2295,7 @@
           <p:cNvPr id="4" name="Text Placeholder 3">
             <a:extLst>
               <a:ext uri="{FF2B5EF4-FFF2-40B4-BE49-F238E27FC236}">
-                <a16:creationId xmlns:a16="http://schemas.microsoft.com/office/drawing/2014/main" id="{54E8BF96-D1A4-DA8F-0BCD-E78729CD535D}"/>
+                <a16:creationId xmlns:a16="http://schemas.microsoft.com/office/drawing/2014/main" id="{8666E50B-1F25-724C-929A-2F3FD2096CDE}"/>
               </a:ext>
             </a:extLst>
           </p:cNvPr>
@@ -2366,7 +2366,7 @@
           <p:cNvPr id="5" name="Date Placeholder 4">
             <a:extLst>
               <a:ext uri="{FF2B5EF4-FFF2-40B4-BE49-F238E27FC236}">
-                <a16:creationId xmlns:a16="http://schemas.microsoft.com/office/drawing/2014/main" id="{0EC6C48D-D097-5A81-E130-28B5EFA082BD}"/>
+                <a16:creationId xmlns:a16="http://schemas.microsoft.com/office/drawing/2014/main" id="{C667BC53-F6CF-F7D0-C1F7-B8D2EB3D76CF}"/>
               </a:ext>
             </a:extLst>
           </p:cNvPr>
@@ -2382,7 +2382,7 @@
           <a:bodyPr/>
           <a:lstStyle/>
           <a:p>
-            <a:fld id="{12B4DC5E-5CE6-4800-B105-948B020CE4D7}" type="datetimeFigureOut">
+            <a:fld id="{8B11D9D7-41B1-47D8-A1AC-A705D338CF64}" type="datetimeFigureOut">
               <a:rPr lang="en-US" smtClean="0"/>
               <a:t>9/23/2026</a:t>
             </a:fld>
@@ -2395,7 +2395,7 @@
           <p:cNvPr id="6" name="Footer Placeholder 5">
             <a:extLst>
               <a:ext uri="{FF2B5EF4-FFF2-40B4-BE49-F238E27FC236}">
-                <a16:creationId xmlns:a16="http://schemas.microsoft.com/office/drawing/2014/main" id="{F2B4EE19-1992-EE41-AE37-5B1748C21015}"/>
+                <a16:creationId xmlns:a16="http://schemas.microsoft.com/office/drawing/2014/main" id="{9E07AA68-E3E3-FEBE-FB84-1043433778D7}"/>
               </a:ext>
             </a:extLst>
           </p:cNvPr>
@@ -2420,7 +2420,7 @@
           <p:cNvPr id="7" name="Slide Number Placeholder 6">
             <a:extLst>
               <a:ext uri="{FF2B5EF4-FFF2-40B4-BE49-F238E27FC236}">
-                <a16:creationId xmlns:a16="http://schemas.microsoft.com/office/drawing/2014/main" id="{52C8E0B4-A393-F7B4-EFEB-8BCB0C34DB0E}"/>
+                <a16:creationId xmlns:a16="http://schemas.microsoft.com/office/drawing/2014/main" id="{29CADB35-705F-DA3E-A956-074552624AFF}"/>
               </a:ext>
             </a:extLst>
           </p:cNvPr>
@@ -2436,7 +2436,7 @@
           <a:bodyPr/>
           <a:lstStyle/>
           <a:p>
-            <a:fld id="{9CC4AB40-24CE-403C-8D90-29F002F94F66}" type="slidenum">
+            <a:fld id="{C9D0E25E-EE5E-4862-8D73-ADE52E842283}" type="slidenum">
               <a:rPr lang="en-US" smtClean="0"/>
               <a:t>‹#›</a:t>
             </a:fld>
@@ -2447,7 +2447,7 @@
     </p:spTree>
     <p:extLst>
       <p:ext uri="{BB962C8B-B14F-4D97-AF65-F5344CB8AC3E}">
-        <p14:creationId xmlns:p14="http://schemas.microsoft.com/office/powerpoint/2010/main" val="876704844"/>
+        <p14:creationId xmlns:p14="http://schemas.microsoft.com/office/powerpoint/2010/main" val="2276895487"/>
       </p:ext>
     </p:extLst>
   </p:cSld>
@@ -2479,7 +2479,7 @@
           <p:cNvPr id="2" name="Title 1">
             <a:extLst>
               <a:ext uri="{FF2B5EF4-FFF2-40B4-BE49-F238E27FC236}">
-                <a16:creationId xmlns:a16="http://schemas.microsoft.com/office/drawing/2014/main" id="{187E4EA1-9336-9884-CFF3-BF05820B1FD2}"/>
+                <a16:creationId xmlns:a16="http://schemas.microsoft.com/office/drawing/2014/main" id="{3E330B2E-BB33-79F7-15AB-53659D0F369E}"/>
               </a:ext>
             </a:extLst>
           </p:cNvPr>
@@ -2516,7 +2516,7 @@
           <p:cNvPr id="3" name="Picture Placeholder 2">
             <a:extLst>
               <a:ext uri="{FF2B5EF4-FFF2-40B4-BE49-F238E27FC236}">
-                <a16:creationId xmlns:a16="http://schemas.microsoft.com/office/drawing/2014/main" id="{2FDB39D7-405E-32C5-7CBA-C5BFE4E511A2}"/>
+                <a16:creationId xmlns:a16="http://schemas.microsoft.com/office/drawing/2014/main" id="{1311314F-F29A-67A6-FD3A-E2168D09E572}"/>
               </a:ext>
             </a:extLst>
           </p:cNvPr>
@@ -2583,7 +2583,7 @@
           <p:cNvPr id="4" name="Text Placeholder 3">
             <a:extLst>
               <a:ext uri="{FF2B5EF4-FFF2-40B4-BE49-F238E27FC236}">
-                <a16:creationId xmlns:a16="http://schemas.microsoft.com/office/drawing/2014/main" id="{2157EFAB-6655-0FAE-3492-6209C002DF27}"/>
+                <a16:creationId xmlns:a16="http://schemas.microsoft.com/office/drawing/2014/main" id="{F3831BCE-211A-2814-10D8-DB01D8957B83}"/>
               </a:ext>
             </a:extLst>
           </p:cNvPr>
@@ -2654,7 +2654,7 @@
           <p:cNvPr id="5" name="Date Placeholder 4">
             <a:extLst>
               <a:ext uri="{FF2B5EF4-FFF2-40B4-BE49-F238E27FC236}">
-                <a16:creationId xmlns:a16="http://schemas.microsoft.com/office/drawing/2014/main" id="{69DBB76E-BFB5-C330-C148-7D15C88CACE7}"/>
+                <a16:creationId xmlns:a16="http://schemas.microsoft.com/office/drawing/2014/main" id="{48482EA8-663A-EFB4-80CF-99820D16150D}"/>
               </a:ext>
             </a:extLst>
           </p:cNvPr>
@@ -2670,7 +2670,7 @@
           <a:bodyPr/>
           <a:lstStyle/>
           <a:p>
-            <a:fld id="{12B4DC5E-5CE6-4800-B105-948B020CE4D7}" type="datetimeFigureOut">
+            <a:fld id="{8B11D9D7-41B1-47D8-A1AC-A705D338CF64}" type="datetimeFigureOut">
               <a:rPr lang="en-US" smtClean="0"/>
               <a:t>9/23/2026</a:t>
             </a:fld>
@@ -2683,7 +2683,7 @@
           <p:cNvPr id="6" name="Footer Placeholder 5">
             <a:extLst>
               <a:ext uri="{FF2B5EF4-FFF2-40B4-BE49-F238E27FC236}">
-                <a16:creationId xmlns:a16="http://schemas.microsoft.com/office/drawing/2014/main" id="{97D186D4-DAF9-942D-0DEC-DF9F5DACA078}"/>
+                <a16:creationId xmlns:a16="http://schemas.microsoft.com/office/drawing/2014/main" id="{8505294D-D541-286C-E799-9488F647A915}"/>
               </a:ext>
             </a:extLst>
           </p:cNvPr>
@@ -2708,7 +2708,7 @@
           <p:cNvPr id="7" name="Slide Number Placeholder 6">
             <a:extLst>
               <a:ext uri="{FF2B5EF4-FFF2-40B4-BE49-F238E27FC236}">
-                <a16:creationId xmlns:a16="http://schemas.microsoft.com/office/drawing/2014/main" id="{321F2760-13A4-BDB1-2E5F-AE6150EA65FC}"/>
+                <a16:creationId xmlns:a16="http://schemas.microsoft.com/office/drawing/2014/main" id="{55E3CCBE-E33B-EB55-29D9-52ECDC559676}"/>
               </a:ext>
             </a:extLst>
           </p:cNvPr>
@@ -2724,7 +2724,7 @@
           <a:bodyPr/>
           <a:lstStyle/>
           <a:p>
-            <a:fld id="{9CC4AB40-24CE-403C-8D90-29F002F94F66}" type="slidenum">
+            <a:fld id="{C9D0E25E-EE5E-4862-8D73-ADE52E842283}" type="slidenum">
               <a:rPr lang="en-US" smtClean="0"/>
               <a:t>‹#›</a:t>
             </a:fld>
@@ -2735,7 +2735,7 @@
     </p:spTree>
     <p:extLst>
       <p:ext uri="{BB962C8B-B14F-4D97-AF65-F5344CB8AC3E}">
-        <p14:creationId xmlns:p14="http://schemas.microsoft.com/office/powerpoint/2010/main" val="235145286"/>
+        <p14:creationId xmlns:p14="http://schemas.microsoft.com/office/powerpoint/2010/main" val="3317415083"/>
       </p:ext>
     </p:extLst>
   </p:cSld>
@@ -2772,7 +2772,7 @@
           <p:cNvPr id="2" name="Title Placeholder 1">
             <a:extLst>
               <a:ext uri="{FF2B5EF4-FFF2-40B4-BE49-F238E27FC236}">
-                <a16:creationId xmlns:a16="http://schemas.microsoft.com/office/drawing/2014/main" id="{38C79DC6-F5F9-B126-D31D-21E779E8FD29}"/>
+                <a16:creationId xmlns:a16="http://schemas.microsoft.com/office/drawing/2014/main" id="{EC3100CB-7820-61B2-F270-4AB8EC85BF5A}"/>
               </a:ext>
             </a:extLst>
           </p:cNvPr>
@@ -2810,7 +2810,7 @@
           <p:cNvPr id="3" name="Text Placeholder 2">
             <a:extLst>
               <a:ext uri="{FF2B5EF4-FFF2-40B4-BE49-F238E27FC236}">
-                <a16:creationId xmlns:a16="http://schemas.microsoft.com/office/drawing/2014/main" id="{BB94FC3F-9A4F-2ED3-2028-6DB8F9934700}"/>
+                <a16:creationId xmlns:a16="http://schemas.microsoft.com/office/drawing/2014/main" id="{A1A40DEE-2B5C-C3EA-024B-38491822D83C}"/>
               </a:ext>
             </a:extLst>
           </p:cNvPr>
@@ -2877,7 +2877,7 @@
           <p:cNvPr id="4" name="Date Placeholder 3">
             <a:extLst>
               <a:ext uri="{FF2B5EF4-FFF2-40B4-BE49-F238E27FC236}">
-                <a16:creationId xmlns:a16="http://schemas.microsoft.com/office/drawing/2014/main" id="{6C4737ED-1A47-BA84-5402-174E2D9C1223}"/>
+                <a16:creationId xmlns:a16="http://schemas.microsoft.com/office/drawing/2014/main" id="{472D01F2-73C1-ED6A-64F5-AF941143DE3A}"/>
               </a:ext>
             </a:extLst>
           </p:cNvPr>
@@ -2911,7 +2911,7 @@
             </a:lvl1pPr>
           </a:lstStyle>
           <a:p>
-            <a:fld id="{12B4DC5E-5CE6-4800-B105-948B020CE4D7}" type="datetimeFigureOut">
+            <a:fld id="{8B11D9D7-41B1-47D8-A1AC-A705D338CF64}" type="datetimeFigureOut">
               <a:rPr lang="en-US" smtClean="0"/>
               <a:t>9/23/2026</a:t>
             </a:fld>
@@ -2924,7 +2924,7 @@
           <p:cNvPr id="5" name="Footer Placeholder 4">
             <a:extLst>
               <a:ext uri="{FF2B5EF4-FFF2-40B4-BE49-F238E27FC236}">
-                <a16:creationId xmlns:a16="http://schemas.microsoft.com/office/drawing/2014/main" id="{16399068-2B6A-6BDC-E7BC-8DD56581698E}"/>
+                <a16:creationId xmlns:a16="http://schemas.microsoft.com/office/drawing/2014/main" id="{C11BC001-84D0-6465-DEA2-8D240A26A8B2}"/>
               </a:ext>
             </a:extLst>
           </p:cNvPr>
@@ -2967,7 +2967,7 @@
           <p:cNvPr id="6" name="Slide Number Placeholder 5">
             <a:extLst>
               <a:ext uri="{FF2B5EF4-FFF2-40B4-BE49-F238E27FC236}">
-                <a16:creationId xmlns:a16="http://schemas.microsoft.com/office/drawing/2014/main" id="{1ECBD50B-2E86-88F4-2FD4-A365A8B2825E}"/>
+                <a16:creationId xmlns:a16="http://schemas.microsoft.com/office/drawing/2014/main" id="{DA2718F4-F8B8-ADB8-AEB6-7B8BC4F292E7}"/>
               </a:ext>
             </a:extLst>
           </p:cNvPr>
@@ -3001,7 +3001,7 @@
             </a:lvl1pPr>
           </a:lstStyle>
           <a:p>
-            <a:fld id="{9CC4AB40-24CE-403C-8D90-29F002F94F66}" type="slidenum">
+            <a:fld id="{C9D0E25E-EE5E-4862-8D73-ADE52E842283}" type="slidenum">
               <a:rPr lang="en-US" smtClean="0"/>
               <a:t>‹#›</a:t>
             </a:fld>
@@ -3012,7 +3012,7 @@
     </p:spTree>
     <p:extLst>
       <p:ext uri="{BB962C8B-B14F-4D97-AF65-F5344CB8AC3E}">
-        <p14:creationId xmlns:p14="http://schemas.microsoft.com/office/powerpoint/2010/main" val="2642138674"/>
+        <p14:creationId xmlns:p14="http://schemas.microsoft.com/office/powerpoint/2010/main" val="778818737"/>
       </p:ext>
     </p:extLst>
   </p:cSld>
@@ -3335,7 +3335,7 @@
           <p:cNvPr id="3" name="Picture 2">
             <a:extLst>
               <a:ext uri="{FF2B5EF4-FFF2-40B4-BE49-F238E27FC236}">
-                <a16:creationId xmlns:a16="http://schemas.microsoft.com/office/drawing/2014/main" id="{FA6F3CE0-29C8-3B36-277E-E9644F5C8C9E}"/>
+                <a16:creationId xmlns:a16="http://schemas.microsoft.com/office/drawing/2014/main" id="{E30DDF8B-8C81-9A36-CE4D-2F7708F23B40}"/>
               </a:ext>
             </a:extLst>
           </p:cNvPr>
@@ -3369,7 +3369,7 @@
     </p:spTree>
     <p:extLst>
       <p:ext uri="{BB962C8B-B14F-4D97-AF65-F5344CB8AC3E}">
-        <p14:creationId xmlns:p14="http://schemas.microsoft.com/office/powerpoint/2010/main" val="56987129"/>
+        <p14:creationId xmlns:p14="http://schemas.microsoft.com/office/powerpoint/2010/main" val="1445477677"/>
       </p:ext>
     </p:extLst>
   </p:cSld>
@@ -3401,7 +3401,7 @@
           <p:cNvPr id="3" name="Picture 2">
             <a:extLst>
               <a:ext uri="{FF2B5EF4-FFF2-40B4-BE49-F238E27FC236}">
-                <a16:creationId xmlns:a16="http://schemas.microsoft.com/office/drawing/2014/main" id="{4790A3B4-A2F6-9CF9-EC36-B400A1EAB091}"/>
+                <a16:creationId xmlns:a16="http://schemas.microsoft.com/office/drawing/2014/main" id="{B22C4E25-AC7B-2D7E-7A3A-940715AED012}"/>
               </a:ext>
             </a:extLst>
           </p:cNvPr>
@@ -3435,7 +3435,7 @@
     </p:spTree>
     <p:extLst>
       <p:ext uri="{BB962C8B-B14F-4D97-AF65-F5344CB8AC3E}">
-        <p14:creationId xmlns:p14="http://schemas.microsoft.com/office/powerpoint/2010/main" val="155128323"/>
+        <p14:creationId xmlns:p14="http://schemas.microsoft.com/office/powerpoint/2010/main" val="4074281100"/>
       </p:ext>
     </p:extLst>
   </p:cSld>
@@ -3467,7 +3467,7 @@
           <p:cNvPr id="3" name="Picture 2">
             <a:extLst>
               <a:ext uri="{FF2B5EF4-FFF2-40B4-BE49-F238E27FC236}">
-                <a16:creationId xmlns:a16="http://schemas.microsoft.com/office/drawing/2014/main" id="{3F989DED-CB76-C1F9-20BE-FDA3FD5D90FF}"/>
+                <a16:creationId xmlns:a16="http://schemas.microsoft.com/office/drawing/2014/main" id="{4709AFB4-F813-01AC-FCA0-53415CAF5E23}"/>
               </a:ext>
             </a:extLst>
           </p:cNvPr>
@@ -3501,7 +3501,7 @@
     </p:spTree>
     <p:extLst>
       <p:ext uri="{BB962C8B-B14F-4D97-AF65-F5344CB8AC3E}">
-        <p14:creationId xmlns:p14="http://schemas.microsoft.com/office/powerpoint/2010/main" val="683179582"/>
+        <p14:creationId xmlns:p14="http://schemas.microsoft.com/office/powerpoint/2010/main" val="2092928007"/>
       </p:ext>
     </p:extLst>
   </p:cSld>
@@ -3533,7 +3533,7 @@
           <p:cNvPr id="3" name="Picture 2">
             <a:extLst>
               <a:ext uri="{FF2B5EF4-FFF2-40B4-BE49-F238E27FC236}">
-                <a16:creationId xmlns:a16="http://schemas.microsoft.com/office/drawing/2014/main" id="{1678F33D-75E8-FAB1-B028-53DF6DAB1404}"/>
+                <a16:creationId xmlns:a16="http://schemas.microsoft.com/office/drawing/2014/main" id="{81B15B77-7926-FF25-0E9B-E4E5A9091638}"/>
               </a:ext>
             </a:extLst>
           </p:cNvPr>
@@ -3567,7 +3567,7 @@
     </p:spTree>
     <p:extLst>
       <p:ext uri="{BB962C8B-B14F-4D97-AF65-F5344CB8AC3E}">
-        <p14:creationId xmlns:p14="http://schemas.microsoft.com/office/powerpoint/2010/main" val="1469216661"/>
+        <p14:creationId xmlns:p14="http://schemas.microsoft.com/office/powerpoint/2010/main" val="2987077736"/>
       </p:ext>
     </p:extLst>
   </p:cSld>
@@ -3599,7 +3599,7 @@
           <p:cNvPr id="3" name="Picture 2">
             <a:extLst>
               <a:ext uri="{FF2B5EF4-FFF2-40B4-BE49-F238E27FC236}">
-                <a16:creationId xmlns:a16="http://schemas.microsoft.com/office/drawing/2014/main" id="{4282BBF3-9D11-5149-E82B-16AFF2D3CDD4}"/>
+                <a16:creationId xmlns:a16="http://schemas.microsoft.com/office/drawing/2014/main" id="{50563130-081B-053C-A689-B642BC54E7C7}"/>
               </a:ext>
             </a:extLst>
           </p:cNvPr>
@@ -3633,7 +3633,7 @@
     </p:spTree>
     <p:extLst>
       <p:ext uri="{BB962C8B-B14F-4D97-AF65-F5344CB8AC3E}">
-        <p14:creationId xmlns:p14="http://schemas.microsoft.com/office/powerpoint/2010/main" val="1327550123"/>
+        <p14:creationId xmlns:p14="http://schemas.microsoft.com/office/powerpoint/2010/main" val="3595300914"/>
       </p:ext>
     </p:extLst>
   </p:cSld>
@@ -3665,7 +3665,7 @@
           <p:cNvPr id="3" name="Picture 2">
             <a:extLst>
               <a:ext uri="{FF2B5EF4-FFF2-40B4-BE49-F238E27FC236}">
-                <a16:creationId xmlns:a16="http://schemas.microsoft.com/office/drawing/2014/main" id="{42BB5201-B6CE-FD42-2AF6-71963CCB18A4}"/>
+                <a16:creationId xmlns:a16="http://schemas.microsoft.com/office/drawing/2014/main" id="{85D09B8D-F987-84DB-6687-66204C608C85}"/>
               </a:ext>
             </a:extLst>
           </p:cNvPr>
@@ -3699,7 +3699,7 @@
     </p:spTree>
     <p:extLst>
       <p:ext uri="{BB962C8B-B14F-4D97-AF65-F5344CB8AC3E}">
-        <p14:creationId xmlns:p14="http://schemas.microsoft.com/office/powerpoint/2010/main" val="1260412425"/>
+        <p14:creationId xmlns:p14="http://schemas.microsoft.com/office/powerpoint/2010/main" val="2551754931"/>
       </p:ext>
     </p:extLst>
   </p:cSld>
@@ -3731,7 +3731,7 @@
           <p:cNvPr id="3" name="Picture 2">
             <a:extLst>
               <a:ext uri="{FF2B5EF4-FFF2-40B4-BE49-F238E27FC236}">
-                <a16:creationId xmlns:a16="http://schemas.microsoft.com/office/drawing/2014/main" id="{A166576C-8549-7A4F-2619-0C2642575EEE}"/>
+                <a16:creationId xmlns:a16="http://schemas.microsoft.com/office/drawing/2014/main" id="{36111742-C75C-F253-4786-C378E8A55DFD}"/>
               </a:ext>
             </a:extLst>
           </p:cNvPr>
@@ -3765,7 +3765,7 @@
     </p:spTree>
     <p:extLst>
       <p:ext uri="{BB962C8B-B14F-4D97-AF65-F5344CB8AC3E}">
-        <p14:creationId xmlns:p14="http://schemas.microsoft.com/office/powerpoint/2010/main" val="3813632423"/>
+        <p14:creationId xmlns:p14="http://schemas.microsoft.com/office/powerpoint/2010/main" val="389325593"/>
       </p:ext>
     </p:extLst>
   </p:cSld>
@@ -3797,7 +3797,7 @@
           <p:cNvPr id="3" name="Picture 2">
             <a:extLst>
               <a:ext uri="{FF2B5EF4-FFF2-40B4-BE49-F238E27FC236}">
-                <a16:creationId xmlns:a16="http://schemas.microsoft.com/office/drawing/2014/main" id="{163CDBE0-917B-36F7-ED6C-891C050D7912}"/>
+                <a16:creationId xmlns:a16="http://schemas.microsoft.com/office/drawing/2014/main" id="{21120889-762D-EEFA-82B1-5E128784F29A}"/>
               </a:ext>
             </a:extLst>
           </p:cNvPr>
@@ -3831,7 +3831,7 @@
     </p:spTree>
     <p:extLst>
       <p:ext uri="{BB962C8B-B14F-4D97-AF65-F5344CB8AC3E}">
-        <p14:creationId xmlns:p14="http://schemas.microsoft.com/office/powerpoint/2010/main" val="2657490857"/>
+        <p14:creationId xmlns:p14="http://schemas.microsoft.com/office/powerpoint/2010/main" val="1931030547"/>
       </p:ext>
     </p:extLst>
   </p:cSld>
@@ -3863,7 +3863,7 @@
           <p:cNvPr id="3" name="Picture 2">
             <a:extLst>
               <a:ext uri="{FF2B5EF4-FFF2-40B4-BE49-F238E27FC236}">
-                <a16:creationId xmlns:a16="http://schemas.microsoft.com/office/drawing/2014/main" id="{381B0A2F-FAA7-D4C0-8DA5-F34F325B0A7F}"/>
+                <a16:creationId xmlns:a16="http://schemas.microsoft.com/office/drawing/2014/main" id="{01C0E88D-2EAE-148B-D510-FAF6331E57C7}"/>
               </a:ext>
             </a:extLst>
           </p:cNvPr>
@@ -3897,7 +3897,7 @@
     </p:spTree>
     <p:extLst>
       <p:ext uri="{BB962C8B-B14F-4D97-AF65-F5344CB8AC3E}">
-        <p14:creationId xmlns:p14="http://schemas.microsoft.com/office/powerpoint/2010/main" val="2771205098"/>
+        <p14:creationId xmlns:p14="http://schemas.microsoft.com/office/powerpoint/2010/main" val="1660681475"/>
       </p:ext>
     </p:extLst>
   </p:cSld>
@@ -3929,7 +3929,7 @@
           <p:cNvPr id="3" name="Picture 2">
             <a:extLst>
               <a:ext uri="{FF2B5EF4-FFF2-40B4-BE49-F238E27FC236}">
-                <a16:creationId xmlns:a16="http://schemas.microsoft.com/office/drawing/2014/main" id="{ED88D57D-4A0D-A616-3467-8DACC3A93E69}"/>
+                <a16:creationId xmlns:a16="http://schemas.microsoft.com/office/drawing/2014/main" id="{8358333B-9F5F-BD4F-297D-6F54E20C3EBD}"/>
               </a:ext>
             </a:extLst>
           </p:cNvPr>
@@ -3963,7 +3963,7 @@
     </p:spTree>
     <p:extLst>
       <p:ext uri="{BB962C8B-B14F-4D97-AF65-F5344CB8AC3E}">
-        <p14:creationId xmlns:p14="http://schemas.microsoft.com/office/powerpoint/2010/main" val="2127499742"/>
+        <p14:creationId xmlns:p14="http://schemas.microsoft.com/office/powerpoint/2010/main" val="3816704242"/>
       </p:ext>
     </p:extLst>
   </p:cSld>

</xml_diff>

<commit_message>
Use widescreen slide captures
</commit_message>
<xml_diff>
--- a/CareerCloset_Pitch_2_Exact.pptx
+++ b/CareerCloset_Pitch_2_Exact.pptx
@@ -138,7 +138,7 @@
           <p:cNvPr id="2" name="Title 1">
             <a:extLst>
               <a:ext uri="{FF2B5EF4-FFF2-40B4-BE49-F238E27FC236}">
-                <a16:creationId xmlns:a16="http://schemas.microsoft.com/office/drawing/2014/main" id="{471F5D1A-AB4F-2D25-96D3-A81450FD9D50}"/>
+                <a16:creationId xmlns:a16="http://schemas.microsoft.com/office/drawing/2014/main" id="{210B46F9-496D-F302-5B5C-F8DF9CEFA1FE}"/>
               </a:ext>
             </a:extLst>
           </p:cNvPr>
@@ -175,7 +175,7 @@
           <p:cNvPr id="3" name="Subtitle 2">
             <a:extLst>
               <a:ext uri="{FF2B5EF4-FFF2-40B4-BE49-F238E27FC236}">
-                <a16:creationId xmlns:a16="http://schemas.microsoft.com/office/drawing/2014/main" id="{7F3C7E2F-F6E6-1B99-9DEF-8B99A94A934D}"/>
+                <a16:creationId xmlns:a16="http://schemas.microsoft.com/office/drawing/2014/main" id="{E74281BA-2FD3-C44E-9879-78F19D5782FD}"/>
               </a:ext>
             </a:extLst>
           </p:cNvPr>
@@ -245,7 +245,7 @@
           <p:cNvPr id="4" name="Date Placeholder 3">
             <a:extLst>
               <a:ext uri="{FF2B5EF4-FFF2-40B4-BE49-F238E27FC236}">
-                <a16:creationId xmlns:a16="http://schemas.microsoft.com/office/drawing/2014/main" id="{10F3A812-98A7-9C96-5BFB-A336B6DBB0A0}"/>
+                <a16:creationId xmlns:a16="http://schemas.microsoft.com/office/drawing/2014/main" id="{12419C82-3CFC-31F8-A8E9-2727CAA94871}"/>
               </a:ext>
             </a:extLst>
           </p:cNvPr>
@@ -261,7 +261,7 @@
           <a:bodyPr/>
           <a:lstStyle/>
           <a:p>
-            <a:fld id="{8B11D9D7-41B1-47D8-A1AC-A705D338CF64}" type="datetimeFigureOut">
+            <a:fld id="{8800BFBD-5516-4F51-BD4A-58548AF96EAA}" type="datetimeFigureOut">
               <a:rPr lang="en-US" smtClean="0"/>
               <a:t>9/23/2026</a:t>
             </a:fld>
@@ -274,7 +274,7 @@
           <p:cNvPr id="5" name="Footer Placeholder 4">
             <a:extLst>
               <a:ext uri="{FF2B5EF4-FFF2-40B4-BE49-F238E27FC236}">
-                <a16:creationId xmlns:a16="http://schemas.microsoft.com/office/drawing/2014/main" id="{1C9FEA98-4B6C-ECC8-19ED-AC70EDE45534}"/>
+                <a16:creationId xmlns:a16="http://schemas.microsoft.com/office/drawing/2014/main" id="{32AA2653-0E3E-05AF-B9FA-75419DA6D69F}"/>
               </a:ext>
             </a:extLst>
           </p:cNvPr>
@@ -299,7 +299,7 @@
           <p:cNvPr id="6" name="Slide Number Placeholder 5">
             <a:extLst>
               <a:ext uri="{FF2B5EF4-FFF2-40B4-BE49-F238E27FC236}">
-                <a16:creationId xmlns:a16="http://schemas.microsoft.com/office/drawing/2014/main" id="{02467DAF-B62E-6AD9-AFD8-FC33892B461B}"/>
+                <a16:creationId xmlns:a16="http://schemas.microsoft.com/office/drawing/2014/main" id="{C2B3E4A4-7E01-A5E6-D9F8-91DA64BC4774}"/>
               </a:ext>
             </a:extLst>
           </p:cNvPr>
@@ -315,7 +315,7 @@
           <a:bodyPr/>
           <a:lstStyle/>
           <a:p>
-            <a:fld id="{C9D0E25E-EE5E-4862-8D73-ADE52E842283}" type="slidenum">
+            <a:fld id="{93D7449F-691E-409E-A0BD-4E82F2722AA0}" type="slidenum">
               <a:rPr lang="en-US" smtClean="0"/>
               <a:t>‹#›</a:t>
             </a:fld>
@@ -326,7 +326,7 @@
     </p:spTree>
     <p:extLst>
       <p:ext uri="{BB962C8B-B14F-4D97-AF65-F5344CB8AC3E}">
-        <p14:creationId xmlns:p14="http://schemas.microsoft.com/office/powerpoint/2010/main" val="416651623"/>
+        <p14:creationId xmlns:p14="http://schemas.microsoft.com/office/powerpoint/2010/main" val="348609193"/>
       </p:ext>
     </p:extLst>
   </p:cSld>
@@ -358,7 +358,7 @@
           <p:cNvPr id="2" name="Title 1">
             <a:extLst>
               <a:ext uri="{FF2B5EF4-FFF2-40B4-BE49-F238E27FC236}">
-                <a16:creationId xmlns:a16="http://schemas.microsoft.com/office/drawing/2014/main" id="{553E6EA8-A682-BB55-B2EF-FECFCF09FFB6}"/>
+                <a16:creationId xmlns:a16="http://schemas.microsoft.com/office/drawing/2014/main" id="{B04A700F-3659-E5A9-E6B2-86E5FED81CD8}"/>
               </a:ext>
             </a:extLst>
           </p:cNvPr>
@@ -386,7 +386,7 @@
           <p:cNvPr id="3" name="Vertical Text Placeholder 2">
             <a:extLst>
               <a:ext uri="{FF2B5EF4-FFF2-40B4-BE49-F238E27FC236}">
-                <a16:creationId xmlns:a16="http://schemas.microsoft.com/office/drawing/2014/main" id="{D1A56AE7-D161-47C4-41C7-42FA93528043}"/>
+                <a16:creationId xmlns:a16="http://schemas.microsoft.com/office/drawing/2014/main" id="{AA182387-90E2-8AF4-E26E-8A0F43C7A57A}"/>
               </a:ext>
             </a:extLst>
           </p:cNvPr>
@@ -443,7 +443,7 @@
           <p:cNvPr id="4" name="Date Placeholder 3">
             <a:extLst>
               <a:ext uri="{FF2B5EF4-FFF2-40B4-BE49-F238E27FC236}">
-                <a16:creationId xmlns:a16="http://schemas.microsoft.com/office/drawing/2014/main" id="{EB4ABF1C-136B-7C84-5C0D-89C3705D3BC4}"/>
+                <a16:creationId xmlns:a16="http://schemas.microsoft.com/office/drawing/2014/main" id="{7C9E4226-5A9F-5D78-238D-E5D5A5420C52}"/>
               </a:ext>
             </a:extLst>
           </p:cNvPr>
@@ -459,7 +459,7 @@
           <a:bodyPr/>
           <a:lstStyle/>
           <a:p>
-            <a:fld id="{8B11D9D7-41B1-47D8-A1AC-A705D338CF64}" type="datetimeFigureOut">
+            <a:fld id="{8800BFBD-5516-4F51-BD4A-58548AF96EAA}" type="datetimeFigureOut">
               <a:rPr lang="en-US" smtClean="0"/>
               <a:t>9/23/2026</a:t>
             </a:fld>
@@ -472,7 +472,7 @@
           <p:cNvPr id="5" name="Footer Placeholder 4">
             <a:extLst>
               <a:ext uri="{FF2B5EF4-FFF2-40B4-BE49-F238E27FC236}">
-                <a16:creationId xmlns:a16="http://schemas.microsoft.com/office/drawing/2014/main" id="{D33C5843-D746-CBE8-9860-FA112696DF00}"/>
+                <a16:creationId xmlns:a16="http://schemas.microsoft.com/office/drawing/2014/main" id="{A703F2BE-026B-9A18-50EC-848205BCB2DA}"/>
               </a:ext>
             </a:extLst>
           </p:cNvPr>
@@ -497,7 +497,7 @@
           <p:cNvPr id="6" name="Slide Number Placeholder 5">
             <a:extLst>
               <a:ext uri="{FF2B5EF4-FFF2-40B4-BE49-F238E27FC236}">
-                <a16:creationId xmlns:a16="http://schemas.microsoft.com/office/drawing/2014/main" id="{4CED21F6-A311-D941-1D46-7B38D7DEC53D}"/>
+                <a16:creationId xmlns:a16="http://schemas.microsoft.com/office/drawing/2014/main" id="{BF208FE7-2E12-CAD1-D313-A881608D666A}"/>
               </a:ext>
             </a:extLst>
           </p:cNvPr>
@@ -513,7 +513,7 @@
           <a:bodyPr/>
           <a:lstStyle/>
           <a:p>
-            <a:fld id="{C9D0E25E-EE5E-4862-8D73-ADE52E842283}" type="slidenum">
+            <a:fld id="{93D7449F-691E-409E-A0BD-4E82F2722AA0}" type="slidenum">
               <a:rPr lang="en-US" smtClean="0"/>
               <a:t>‹#›</a:t>
             </a:fld>
@@ -524,7 +524,7 @@
     </p:spTree>
     <p:extLst>
       <p:ext uri="{BB962C8B-B14F-4D97-AF65-F5344CB8AC3E}">
-        <p14:creationId xmlns:p14="http://schemas.microsoft.com/office/powerpoint/2010/main" val="3651881598"/>
+        <p14:creationId xmlns:p14="http://schemas.microsoft.com/office/powerpoint/2010/main" val="4032016024"/>
       </p:ext>
     </p:extLst>
   </p:cSld>
@@ -556,7 +556,7 @@
           <p:cNvPr id="2" name="Vertical Title 1">
             <a:extLst>
               <a:ext uri="{FF2B5EF4-FFF2-40B4-BE49-F238E27FC236}">
-                <a16:creationId xmlns:a16="http://schemas.microsoft.com/office/drawing/2014/main" id="{4E0CE013-C98F-A41E-B404-18A3610F516F}"/>
+                <a16:creationId xmlns:a16="http://schemas.microsoft.com/office/drawing/2014/main" id="{020F61F8-6157-19B1-97EE-036240EDA2F8}"/>
               </a:ext>
             </a:extLst>
           </p:cNvPr>
@@ -589,7 +589,7 @@
           <p:cNvPr id="3" name="Vertical Text Placeholder 2">
             <a:extLst>
               <a:ext uri="{FF2B5EF4-FFF2-40B4-BE49-F238E27FC236}">
-                <a16:creationId xmlns:a16="http://schemas.microsoft.com/office/drawing/2014/main" id="{FD856CF0-0D88-2631-1B56-62534B448438}"/>
+                <a16:creationId xmlns:a16="http://schemas.microsoft.com/office/drawing/2014/main" id="{D9F0D121-30A8-962B-C4A0-EDB79262B50F}"/>
               </a:ext>
             </a:extLst>
           </p:cNvPr>
@@ -651,7 +651,7 @@
           <p:cNvPr id="4" name="Date Placeholder 3">
             <a:extLst>
               <a:ext uri="{FF2B5EF4-FFF2-40B4-BE49-F238E27FC236}">
-                <a16:creationId xmlns:a16="http://schemas.microsoft.com/office/drawing/2014/main" id="{A278C717-CB2E-2098-1E4B-C9283E658CB6}"/>
+                <a16:creationId xmlns:a16="http://schemas.microsoft.com/office/drawing/2014/main" id="{84256FD0-46B3-483E-0E53-A0273A587C61}"/>
               </a:ext>
             </a:extLst>
           </p:cNvPr>
@@ -667,7 +667,7 @@
           <a:bodyPr/>
           <a:lstStyle/>
           <a:p>
-            <a:fld id="{8B11D9D7-41B1-47D8-A1AC-A705D338CF64}" type="datetimeFigureOut">
+            <a:fld id="{8800BFBD-5516-4F51-BD4A-58548AF96EAA}" type="datetimeFigureOut">
               <a:rPr lang="en-US" smtClean="0"/>
               <a:t>9/23/2026</a:t>
             </a:fld>
@@ -680,7 +680,7 @@
           <p:cNvPr id="5" name="Footer Placeholder 4">
             <a:extLst>
               <a:ext uri="{FF2B5EF4-FFF2-40B4-BE49-F238E27FC236}">
-                <a16:creationId xmlns:a16="http://schemas.microsoft.com/office/drawing/2014/main" id="{23E05064-DBDD-6F23-EA89-F31261C1B0C9}"/>
+                <a16:creationId xmlns:a16="http://schemas.microsoft.com/office/drawing/2014/main" id="{C150D664-40D5-5B30-0353-D405D2E6CE7C}"/>
               </a:ext>
             </a:extLst>
           </p:cNvPr>
@@ -705,7 +705,7 @@
           <p:cNvPr id="6" name="Slide Number Placeholder 5">
             <a:extLst>
               <a:ext uri="{FF2B5EF4-FFF2-40B4-BE49-F238E27FC236}">
-                <a16:creationId xmlns:a16="http://schemas.microsoft.com/office/drawing/2014/main" id="{FF838BF9-A949-6908-D7AA-AC52C41B1B42}"/>
+                <a16:creationId xmlns:a16="http://schemas.microsoft.com/office/drawing/2014/main" id="{D4AD50B5-A8B6-E6CC-2CE4-1581D77FD886}"/>
               </a:ext>
             </a:extLst>
           </p:cNvPr>
@@ -721,7 +721,7 @@
           <a:bodyPr/>
           <a:lstStyle/>
           <a:p>
-            <a:fld id="{C9D0E25E-EE5E-4862-8D73-ADE52E842283}" type="slidenum">
+            <a:fld id="{93D7449F-691E-409E-A0BD-4E82F2722AA0}" type="slidenum">
               <a:rPr lang="en-US" smtClean="0"/>
               <a:t>‹#›</a:t>
             </a:fld>
@@ -732,7 +732,7 @@
     </p:spTree>
     <p:extLst>
       <p:ext uri="{BB962C8B-B14F-4D97-AF65-F5344CB8AC3E}">
-        <p14:creationId xmlns:p14="http://schemas.microsoft.com/office/powerpoint/2010/main" val="333555674"/>
+        <p14:creationId xmlns:p14="http://schemas.microsoft.com/office/powerpoint/2010/main" val="3191924681"/>
       </p:ext>
     </p:extLst>
   </p:cSld>
@@ -764,7 +764,7 @@
           <p:cNvPr id="2" name="Title 1">
             <a:extLst>
               <a:ext uri="{FF2B5EF4-FFF2-40B4-BE49-F238E27FC236}">
-                <a16:creationId xmlns:a16="http://schemas.microsoft.com/office/drawing/2014/main" id="{5B1BE182-C723-8413-9EB4-60DF44F7C623}"/>
+                <a16:creationId xmlns:a16="http://schemas.microsoft.com/office/drawing/2014/main" id="{445B0A8E-7478-D043-F5F1-20720BA173D6}"/>
               </a:ext>
             </a:extLst>
           </p:cNvPr>
@@ -792,7 +792,7 @@
           <p:cNvPr id="3" name="Content Placeholder 2">
             <a:extLst>
               <a:ext uri="{FF2B5EF4-FFF2-40B4-BE49-F238E27FC236}">
-                <a16:creationId xmlns:a16="http://schemas.microsoft.com/office/drawing/2014/main" id="{877BD32A-BE6E-2892-A083-472CC2858A87}"/>
+                <a16:creationId xmlns:a16="http://schemas.microsoft.com/office/drawing/2014/main" id="{EBE31935-1D66-F513-E8D4-7916656DC474}"/>
               </a:ext>
             </a:extLst>
           </p:cNvPr>
@@ -849,7 +849,7 @@
           <p:cNvPr id="4" name="Date Placeholder 3">
             <a:extLst>
               <a:ext uri="{FF2B5EF4-FFF2-40B4-BE49-F238E27FC236}">
-                <a16:creationId xmlns:a16="http://schemas.microsoft.com/office/drawing/2014/main" id="{88F605F9-92D7-D17F-A971-2CA47A3271C7}"/>
+                <a16:creationId xmlns:a16="http://schemas.microsoft.com/office/drawing/2014/main" id="{E6252E43-5CF9-CC8B-E61E-EBCFA275678F}"/>
               </a:ext>
             </a:extLst>
           </p:cNvPr>
@@ -865,7 +865,7 @@
           <a:bodyPr/>
           <a:lstStyle/>
           <a:p>
-            <a:fld id="{8B11D9D7-41B1-47D8-A1AC-A705D338CF64}" type="datetimeFigureOut">
+            <a:fld id="{8800BFBD-5516-4F51-BD4A-58548AF96EAA}" type="datetimeFigureOut">
               <a:rPr lang="en-US" smtClean="0"/>
               <a:t>9/23/2026</a:t>
             </a:fld>
@@ -878,7 +878,7 @@
           <p:cNvPr id="5" name="Footer Placeholder 4">
             <a:extLst>
               <a:ext uri="{FF2B5EF4-FFF2-40B4-BE49-F238E27FC236}">
-                <a16:creationId xmlns:a16="http://schemas.microsoft.com/office/drawing/2014/main" id="{082BC6C2-7719-FBF3-964E-2F3C4A8AE276}"/>
+                <a16:creationId xmlns:a16="http://schemas.microsoft.com/office/drawing/2014/main" id="{F3707403-CA33-63AF-1C39-34F1903B0456}"/>
               </a:ext>
             </a:extLst>
           </p:cNvPr>
@@ -903,7 +903,7 @@
           <p:cNvPr id="6" name="Slide Number Placeholder 5">
             <a:extLst>
               <a:ext uri="{FF2B5EF4-FFF2-40B4-BE49-F238E27FC236}">
-                <a16:creationId xmlns:a16="http://schemas.microsoft.com/office/drawing/2014/main" id="{10E676C6-F291-91E7-F402-F6ED90B4D47A}"/>
+                <a16:creationId xmlns:a16="http://schemas.microsoft.com/office/drawing/2014/main" id="{F67B8BEA-B641-5393-7D55-4FDE511F7BF1}"/>
               </a:ext>
             </a:extLst>
           </p:cNvPr>
@@ -919,7 +919,7 @@
           <a:bodyPr/>
           <a:lstStyle/>
           <a:p>
-            <a:fld id="{C9D0E25E-EE5E-4862-8D73-ADE52E842283}" type="slidenum">
+            <a:fld id="{93D7449F-691E-409E-A0BD-4E82F2722AA0}" type="slidenum">
               <a:rPr lang="en-US" smtClean="0"/>
               <a:t>‹#›</a:t>
             </a:fld>
@@ -930,7 +930,7 @@
     </p:spTree>
     <p:extLst>
       <p:ext uri="{BB962C8B-B14F-4D97-AF65-F5344CB8AC3E}">
-        <p14:creationId xmlns:p14="http://schemas.microsoft.com/office/powerpoint/2010/main" val="3980404050"/>
+        <p14:creationId xmlns:p14="http://schemas.microsoft.com/office/powerpoint/2010/main" val="1865172923"/>
       </p:ext>
     </p:extLst>
   </p:cSld>
@@ -962,7 +962,7 @@
           <p:cNvPr id="2" name="Title 1">
             <a:extLst>
               <a:ext uri="{FF2B5EF4-FFF2-40B4-BE49-F238E27FC236}">
-                <a16:creationId xmlns:a16="http://schemas.microsoft.com/office/drawing/2014/main" id="{95D100C6-E0A6-A703-EB30-BDBE2E805A97}"/>
+                <a16:creationId xmlns:a16="http://schemas.microsoft.com/office/drawing/2014/main" id="{38A5546B-6F17-4876-707B-4E35FBBF803C}"/>
               </a:ext>
             </a:extLst>
           </p:cNvPr>
@@ -999,7 +999,7 @@
           <p:cNvPr id="3" name="Text Placeholder 2">
             <a:extLst>
               <a:ext uri="{FF2B5EF4-FFF2-40B4-BE49-F238E27FC236}">
-                <a16:creationId xmlns:a16="http://schemas.microsoft.com/office/drawing/2014/main" id="{1C3FDBF9-2ADF-6C61-9434-33E24543A462}"/>
+                <a16:creationId xmlns:a16="http://schemas.microsoft.com/office/drawing/2014/main" id="{32DBA6AE-DB46-27A7-8C91-6E95AD63377F}"/>
               </a:ext>
             </a:extLst>
           </p:cNvPr>
@@ -1124,7 +1124,7 @@
           <p:cNvPr id="4" name="Date Placeholder 3">
             <a:extLst>
               <a:ext uri="{FF2B5EF4-FFF2-40B4-BE49-F238E27FC236}">
-                <a16:creationId xmlns:a16="http://schemas.microsoft.com/office/drawing/2014/main" id="{F8A3E47F-C5B1-2D2C-F543-69F2A39B308E}"/>
+                <a16:creationId xmlns:a16="http://schemas.microsoft.com/office/drawing/2014/main" id="{75AED344-3818-F67F-CF21-8395988ABD73}"/>
               </a:ext>
             </a:extLst>
           </p:cNvPr>
@@ -1140,7 +1140,7 @@
           <a:bodyPr/>
           <a:lstStyle/>
           <a:p>
-            <a:fld id="{8B11D9D7-41B1-47D8-A1AC-A705D338CF64}" type="datetimeFigureOut">
+            <a:fld id="{8800BFBD-5516-4F51-BD4A-58548AF96EAA}" type="datetimeFigureOut">
               <a:rPr lang="en-US" smtClean="0"/>
               <a:t>9/23/2026</a:t>
             </a:fld>
@@ -1153,7 +1153,7 @@
           <p:cNvPr id="5" name="Footer Placeholder 4">
             <a:extLst>
               <a:ext uri="{FF2B5EF4-FFF2-40B4-BE49-F238E27FC236}">
-                <a16:creationId xmlns:a16="http://schemas.microsoft.com/office/drawing/2014/main" id="{39DDE541-3A7A-1F63-60FF-284FDAF9188F}"/>
+                <a16:creationId xmlns:a16="http://schemas.microsoft.com/office/drawing/2014/main" id="{C1396CC9-226C-E043-3F82-FB43DB536365}"/>
               </a:ext>
             </a:extLst>
           </p:cNvPr>
@@ -1178,7 +1178,7 @@
           <p:cNvPr id="6" name="Slide Number Placeholder 5">
             <a:extLst>
               <a:ext uri="{FF2B5EF4-FFF2-40B4-BE49-F238E27FC236}">
-                <a16:creationId xmlns:a16="http://schemas.microsoft.com/office/drawing/2014/main" id="{BAA4ADE7-ADC3-24C9-349E-33F8C9086193}"/>
+                <a16:creationId xmlns:a16="http://schemas.microsoft.com/office/drawing/2014/main" id="{65AD2002-3D2C-4AF7-6611-6EF2E9951A89}"/>
               </a:ext>
             </a:extLst>
           </p:cNvPr>
@@ -1194,7 +1194,7 @@
           <a:bodyPr/>
           <a:lstStyle/>
           <a:p>
-            <a:fld id="{C9D0E25E-EE5E-4862-8D73-ADE52E842283}" type="slidenum">
+            <a:fld id="{93D7449F-691E-409E-A0BD-4E82F2722AA0}" type="slidenum">
               <a:rPr lang="en-US" smtClean="0"/>
               <a:t>‹#›</a:t>
             </a:fld>
@@ -1205,7 +1205,7 @@
     </p:spTree>
     <p:extLst>
       <p:ext uri="{BB962C8B-B14F-4D97-AF65-F5344CB8AC3E}">
-        <p14:creationId xmlns:p14="http://schemas.microsoft.com/office/powerpoint/2010/main" val="3761479230"/>
+        <p14:creationId xmlns:p14="http://schemas.microsoft.com/office/powerpoint/2010/main" val="4229844725"/>
       </p:ext>
     </p:extLst>
   </p:cSld>
@@ -1237,7 +1237,7 @@
           <p:cNvPr id="2" name="Title 1">
             <a:extLst>
               <a:ext uri="{FF2B5EF4-FFF2-40B4-BE49-F238E27FC236}">
-                <a16:creationId xmlns:a16="http://schemas.microsoft.com/office/drawing/2014/main" id="{0715C64C-0199-E271-D4D3-E38BFCC85A11}"/>
+                <a16:creationId xmlns:a16="http://schemas.microsoft.com/office/drawing/2014/main" id="{9BA324BC-8AD6-B391-45A3-335077EDC9F5}"/>
               </a:ext>
             </a:extLst>
           </p:cNvPr>
@@ -1265,7 +1265,7 @@
           <p:cNvPr id="3" name="Content Placeholder 2">
             <a:extLst>
               <a:ext uri="{FF2B5EF4-FFF2-40B4-BE49-F238E27FC236}">
-                <a16:creationId xmlns:a16="http://schemas.microsoft.com/office/drawing/2014/main" id="{8E15CC8C-0B06-8C88-AFE3-0E391078DCF6}"/>
+                <a16:creationId xmlns:a16="http://schemas.microsoft.com/office/drawing/2014/main" id="{A54C2311-707D-783C-2BAA-69CC5DB9D0E0}"/>
               </a:ext>
             </a:extLst>
           </p:cNvPr>
@@ -1327,7 +1327,7 @@
           <p:cNvPr id="4" name="Content Placeholder 3">
             <a:extLst>
               <a:ext uri="{FF2B5EF4-FFF2-40B4-BE49-F238E27FC236}">
-                <a16:creationId xmlns:a16="http://schemas.microsoft.com/office/drawing/2014/main" id="{BB94D67E-6422-3494-F41E-C5CDF519548E}"/>
+                <a16:creationId xmlns:a16="http://schemas.microsoft.com/office/drawing/2014/main" id="{B655DA06-B9F6-D75B-6373-A5E7BCB3949B}"/>
               </a:ext>
             </a:extLst>
           </p:cNvPr>
@@ -1389,7 +1389,7 @@
           <p:cNvPr id="5" name="Date Placeholder 4">
             <a:extLst>
               <a:ext uri="{FF2B5EF4-FFF2-40B4-BE49-F238E27FC236}">
-                <a16:creationId xmlns:a16="http://schemas.microsoft.com/office/drawing/2014/main" id="{F06D7C23-E336-B373-2D8F-382A16C60A7F}"/>
+                <a16:creationId xmlns:a16="http://schemas.microsoft.com/office/drawing/2014/main" id="{952E3042-247A-3FCB-F359-353A3B7B9EEF}"/>
               </a:ext>
             </a:extLst>
           </p:cNvPr>
@@ -1405,7 +1405,7 @@
           <a:bodyPr/>
           <a:lstStyle/>
           <a:p>
-            <a:fld id="{8B11D9D7-41B1-47D8-A1AC-A705D338CF64}" type="datetimeFigureOut">
+            <a:fld id="{8800BFBD-5516-4F51-BD4A-58548AF96EAA}" type="datetimeFigureOut">
               <a:rPr lang="en-US" smtClean="0"/>
               <a:t>9/23/2026</a:t>
             </a:fld>
@@ -1418,7 +1418,7 @@
           <p:cNvPr id="6" name="Footer Placeholder 5">
             <a:extLst>
               <a:ext uri="{FF2B5EF4-FFF2-40B4-BE49-F238E27FC236}">
-                <a16:creationId xmlns:a16="http://schemas.microsoft.com/office/drawing/2014/main" id="{F73894BA-DFF4-5B73-E73B-76B8673E245D}"/>
+                <a16:creationId xmlns:a16="http://schemas.microsoft.com/office/drawing/2014/main" id="{EA898C70-B238-9C68-68C8-7E90D688BC9D}"/>
               </a:ext>
             </a:extLst>
           </p:cNvPr>
@@ -1443,7 +1443,7 @@
           <p:cNvPr id="7" name="Slide Number Placeholder 6">
             <a:extLst>
               <a:ext uri="{FF2B5EF4-FFF2-40B4-BE49-F238E27FC236}">
-                <a16:creationId xmlns:a16="http://schemas.microsoft.com/office/drawing/2014/main" id="{CFFCE29C-5972-5B4D-1E7F-DB3FE75EAE4A}"/>
+                <a16:creationId xmlns:a16="http://schemas.microsoft.com/office/drawing/2014/main" id="{1B343875-7D47-2DC2-63D5-77D45F46F8D3}"/>
               </a:ext>
             </a:extLst>
           </p:cNvPr>
@@ -1459,7 +1459,7 @@
           <a:bodyPr/>
           <a:lstStyle/>
           <a:p>
-            <a:fld id="{C9D0E25E-EE5E-4862-8D73-ADE52E842283}" type="slidenum">
+            <a:fld id="{93D7449F-691E-409E-A0BD-4E82F2722AA0}" type="slidenum">
               <a:rPr lang="en-US" smtClean="0"/>
               <a:t>‹#›</a:t>
             </a:fld>
@@ -1470,7 +1470,7 @@
     </p:spTree>
     <p:extLst>
       <p:ext uri="{BB962C8B-B14F-4D97-AF65-F5344CB8AC3E}">
-        <p14:creationId xmlns:p14="http://schemas.microsoft.com/office/powerpoint/2010/main" val="3297319591"/>
+        <p14:creationId xmlns:p14="http://schemas.microsoft.com/office/powerpoint/2010/main" val="3314901734"/>
       </p:ext>
     </p:extLst>
   </p:cSld>
@@ -1502,7 +1502,7 @@
           <p:cNvPr id="2" name="Title 1">
             <a:extLst>
               <a:ext uri="{FF2B5EF4-FFF2-40B4-BE49-F238E27FC236}">
-                <a16:creationId xmlns:a16="http://schemas.microsoft.com/office/drawing/2014/main" id="{BE0982C8-CAC9-2C27-ABD2-04DD84E43CFE}"/>
+                <a16:creationId xmlns:a16="http://schemas.microsoft.com/office/drawing/2014/main" id="{951C2D17-CCBD-B7E3-7C4A-A50B3B15E129}"/>
               </a:ext>
             </a:extLst>
           </p:cNvPr>
@@ -1535,7 +1535,7 @@
           <p:cNvPr id="3" name="Text Placeholder 2">
             <a:extLst>
               <a:ext uri="{FF2B5EF4-FFF2-40B4-BE49-F238E27FC236}">
-                <a16:creationId xmlns:a16="http://schemas.microsoft.com/office/drawing/2014/main" id="{08033F8C-7277-6B10-29A2-4D259CC39C4E}"/>
+                <a16:creationId xmlns:a16="http://schemas.microsoft.com/office/drawing/2014/main" id="{8048FE4C-903C-9A36-4536-BE5EB910F88B}"/>
               </a:ext>
             </a:extLst>
           </p:cNvPr>
@@ -1606,7 +1606,7 @@
           <p:cNvPr id="4" name="Content Placeholder 3">
             <a:extLst>
               <a:ext uri="{FF2B5EF4-FFF2-40B4-BE49-F238E27FC236}">
-                <a16:creationId xmlns:a16="http://schemas.microsoft.com/office/drawing/2014/main" id="{CA840184-FDC9-E4E0-05B2-10B8060DDBC6}"/>
+                <a16:creationId xmlns:a16="http://schemas.microsoft.com/office/drawing/2014/main" id="{01834598-861E-892D-B80E-4EB712298F7B}"/>
               </a:ext>
             </a:extLst>
           </p:cNvPr>
@@ -1668,7 +1668,7 @@
           <p:cNvPr id="5" name="Text Placeholder 4">
             <a:extLst>
               <a:ext uri="{FF2B5EF4-FFF2-40B4-BE49-F238E27FC236}">
-                <a16:creationId xmlns:a16="http://schemas.microsoft.com/office/drawing/2014/main" id="{886C685E-25C4-1D30-7358-55B0A649C8E4}"/>
+                <a16:creationId xmlns:a16="http://schemas.microsoft.com/office/drawing/2014/main" id="{72A38688-177C-2869-F3A0-C1F60F35E284}"/>
               </a:ext>
             </a:extLst>
           </p:cNvPr>
@@ -1739,7 +1739,7 @@
           <p:cNvPr id="6" name="Content Placeholder 5">
             <a:extLst>
               <a:ext uri="{FF2B5EF4-FFF2-40B4-BE49-F238E27FC236}">
-                <a16:creationId xmlns:a16="http://schemas.microsoft.com/office/drawing/2014/main" id="{D35B66E6-5319-5E81-32FB-34FA9C6F17E1}"/>
+                <a16:creationId xmlns:a16="http://schemas.microsoft.com/office/drawing/2014/main" id="{99BD3B63-6F88-7B7F-EADF-72F534EED3B2}"/>
               </a:ext>
             </a:extLst>
           </p:cNvPr>
@@ -1801,7 +1801,7 @@
           <p:cNvPr id="7" name="Date Placeholder 6">
             <a:extLst>
               <a:ext uri="{FF2B5EF4-FFF2-40B4-BE49-F238E27FC236}">
-                <a16:creationId xmlns:a16="http://schemas.microsoft.com/office/drawing/2014/main" id="{14A19FB6-4FFE-910E-D211-346D9F76A7A3}"/>
+                <a16:creationId xmlns:a16="http://schemas.microsoft.com/office/drawing/2014/main" id="{DA9D7288-FDB1-A6D5-E681-580519D7E9CF}"/>
               </a:ext>
             </a:extLst>
           </p:cNvPr>
@@ -1817,7 +1817,7 @@
           <a:bodyPr/>
           <a:lstStyle/>
           <a:p>
-            <a:fld id="{8B11D9D7-41B1-47D8-A1AC-A705D338CF64}" type="datetimeFigureOut">
+            <a:fld id="{8800BFBD-5516-4F51-BD4A-58548AF96EAA}" type="datetimeFigureOut">
               <a:rPr lang="en-US" smtClean="0"/>
               <a:t>9/23/2026</a:t>
             </a:fld>
@@ -1830,7 +1830,7 @@
           <p:cNvPr id="8" name="Footer Placeholder 7">
             <a:extLst>
               <a:ext uri="{FF2B5EF4-FFF2-40B4-BE49-F238E27FC236}">
-                <a16:creationId xmlns:a16="http://schemas.microsoft.com/office/drawing/2014/main" id="{E801E59A-C58E-FE62-9E5D-39BC47B596C4}"/>
+                <a16:creationId xmlns:a16="http://schemas.microsoft.com/office/drawing/2014/main" id="{C9B0E22E-108F-2D7B-0691-67042D2F9C81}"/>
               </a:ext>
             </a:extLst>
           </p:cNvPr>
@@ -1855,7 +1855,7 @@
           <p:cNvPr id="9" name="Slide Number Placeholder 8">
             <a:extLst>
               <a:ext uri="{FF2B5EF4-FFF2-40B4-BE49-F238E27FC236}">
-                <a16:creationId xmlns:a16="http://schemas.microsoft.com/office/drawing/2014/main" id="{1C325A4F-B687-0BA9-0D3E-37DE87087FD1}"/>
+                <a16:creationId xmlns:a16="http://schemas.microsoft.com/office/drawing/2014/main" id="{8E51775B-250E-2612-2A5B-B08387385143}"/>
               </a:ext>
             </a:extLst>
           </p:cNvPr>
@@ -1871,7 +1871,7 @@
           <a:bodyPr/>
           <a:lstStyle/>
           <a:p>
-            <a:fld id="{C9D0E25E-EE5E-4862-8D73-ADE52E842283}" type="slidenum">
+            <a:fld id="{93D7449F-691E-409E-A0BD-4E82F2722AA0}" type="slidenum">
               <a:rPr lang="en-US" smtClean="0"/>
               <a:t>‹#›</a:t>
             </a:fld>
@@ -1882,7 +1882,7 @@
     </p:spTree>
     <p:extLst>
       <p:ext uri="{BB962C8B-B14F-4D97-AF65-F5344CB8AC3E}">
-        <p14:creationId xmlns:p14="http://schemas.microsoft.com/office/powerpoint/2010/main" val="2807142489"/>
+        <p14:creationId xmlns:p14="http://schemas.microsoft.com/office/powerpoint/2010/main" val="737884729"/>
       </p:ext>
     </p:extLst>
   </p:cSld>
@@ -1914,7 +1914,7 @@
           <p:cNvPr id="2" name="Title 1">
             <a:extLst>
               <a:ext uri="{FF2B5EF4-FFF2-40B4-BE49-F238E27FC236}">
-                <a16:creationId xmlns:a16="http://schemas.microsoft.com/office/drawing/2014/main" id="{B161C61D-8181-1812-2F7B-831E57329FB5}"/>
+                <a16:creationId xmlns:a16="http://schemas.microsoft.com/office/drawing/2014/main" id="{678B8A45-BDBA-502B-8E97-7B0CAD437B14}"/>
               </a:ext>
             </a:extLst>
           </p:cNvPr>
@@ -1942,7 +1942,7 @@
           <p:cNvPr id="3" name="Date Placeholder 2">
             <a:extLst>
               <a:ext uri="{FF2B5EF4-FFF2-40B4-BE49-F238E27FC236}">
-                <a16:creationId xmlns:a16="http://schemas.microsoft.com/office/drawing/2014/main" id="{D11CEBB8-075F-0F8B-6722-12B4D4E11371}"/>
+                <a16:creationId xmlns:a16="http://schemas.microsoft.com/office/drawing/2014/main" id="{F28FF551-B926-CA3B-B76E-C2F6BB9C1D81}"/>
               </a:ext>
             </a:extLst>
           </p:cNvPr>
@@ -1958,7 +1958,7 @@
           <a:bodyPr/>
           <a:lstStyle/>
           <a:p>
-            <a:fld id="{8B11D9D7-41B1-47D8-A1AC-A705D338CF64}" type="datetimeFigureOut">
+            <a:fld id="{8800BFBD-5516-4F51-BD4A-58548AF96EAA}" type="datetimeFigureOut">
               <a:rPr lang="en-US" smtClean="0"/>
               <a:t>9/23/2026</a:t>
             </a:fld>
@@ -1971,7 +1971,7 @@
           <p:cNvPr id="4" name="Footer Placeholder 3">
             <a:extLst>
               <a:ext uri="{FF2B5EF4-FFF2-40B4-BE49-F238E27FC236}">
-                <a16:creationId xmlns:a16="http://schemas.microsoft.com/office/drawing/2014/main" id="{0FEA82C6-2AB2-0D1F-3859-DE60C9A2BBB2}"/>
+                <a16:creationId xmlns:a16="http://schemas.microsoft.com/office/drawing/2014/main" id="{6F39246A-906A-97F6-1F74-5445493A0892}"/>
               </a:ext>
             </a:extLst>
           </p:cNvPr>
@@ -1996,7 +1996,7 @@
           <p:cNvPr id="5" name="Slide Number Placeholder 4">
             <a:extLst>
               <a:ext uri="{FF2B5EF4-FFF2-40B4-BE49-F238E27FC236}">
-                <a16:creationId xmlns:a16="http://schemas.microsoft.com/office/drawing/2014/main" id="{BC044A05-04C2-4AAB-CA48-9689EA53D12F}"/>
+                <a16:creationId xmlns:a16="http://schemas.microsoft.com/office/drawing/2014/main" id="{27899946-B23F-CDEB-2987-68D7BDDD9E6E}"/>
               </a:ext>
             </a:extLst>
           </p:cNvPr>
@@ -2012,7 +2012,7 @@
           <a:bodyPr/>
           <a:lstStyle/>
           <a:p>
-            <a:fld id="{C9D0E25E-EE5E-4862-8D73-ADE52E842283}" type="slidenum">
+            <a:fld id="{93D7449F-691E-409E-A0BD-4E82F2722AA0}" type="slidenum">
               <a:rPr lang="en-US" smtClean="0"/>
               <a:t>‹#›</a:t>
             </a:fld>
@@ -2023,7 +2023,7 @@
     </p:spTree>
     <p:extLst>
       <p:ext uri="{BB962C8B-B14F-4D97-AF65-F5344CB8AC3E}">
-        <p14:creationId xmlns:p14="http://schemas.microsoft.com/office/powerpoint/2010/main" val="958577469"/>
+        <p14:creationId xmlns:p14="http://schemas.microsoft.com/office/powerpoint/2010/main" val="1937981950"/>
       </p:ext>
     </p:extLst>
   </p:cSld>
@@ -2055,7 +2055,7 @@
           <p:cNvPr id="2" name="Date Placeholder 1">
             <a:extLst>
               <a:ext uri="{FF2B5EF4-FFF2-40B4-BE49-F238E27FC236}">
-                <a16:creationId xmlns:a16="http://schemas.microsoft.com/office/drawing/2014/main" id="{44758F21-F20C-4B70-04D2-EF2EC38ADFE4}"/>
+                <a16:creationId xmlns:a16="http://schemas.microsoft.com/office/drawing/2014/main" id="{C6424F46-4CAE-9FAD-67E4-1C066624D74A}"/>
               </a:ext>
             </a:extLst>
           </p:cNvPr>
@@ -2071,7 +2071,7 @@
           <a:bodyPr/>
           <a:lstStyle/>
           <a:p>
-            <a:fld id="{8B11D9D7-41B1-47D8-A1AC-A705D338CF64}" type="datetimeFigureOut">
+            <a:fld id="{8800BFBD-5516-4F51-BD4A-58548AF96EAA}" type="datetimeFigureOut">
               <a:rPr lang="en-US" smtClean="0"/>
               <a:t>9/23/2026</a:t>
             </a:fld>
@@ -2084,7 +2084,7 @@
           <p:cNvPr id="3" name="Footer Placeholder 2">
             <a:extLst>
               <a:ext uri="{FF2B5EF4-FFF2-40B4-BE49-F238E27FC236}">
-                <a16:creationId xmlns:a16="http://schemas.microsoft.com/office/drawing/2014/main" id="{BD170230-6433-8F90-1BB4-98AA745D7AEE}"/>
+                <a16:creationId xmlns:a16="http://schemas.microsoft.com/office/drawing/2014/main" id="{8A028DA2-618B-157E-9AF3-13E007FEAB18}"/>
               </a:ext>
             </a:extLst>
           </p:cNvPr>
@@ -2109,7 +2109,7 @@
           <p:cNvPr id="4" name="Slide Number Placeholder 3">
             <a:extLst>
               <a:ext uri="{FF2B5EF4-FFF2-40B4-BE49-F238E27FC236}">
-                <a16:creationId xmlns:a16="http://schemas.microsoft.com/office/drawing/2014/main" id="{8FA0B5C3-2B4B-1195-DBF7-9B8FBA278670}"/>
+                <a16:creationId xmlns:a16="http://schemas.microsoft.com/office/drawing/2014/main" id="{76A052BB-7174-174F-43E1-21A78F7F7C3B}"/>
               </a:ext>
             </a:extLst>
           </p:cNvPr>
@@ -2125,7 +2125,7 @@
           <a:bodyPr/>
           <a:lstStyle/>
           <a:p>
-            <a:fld id="{C9D0E25E-EE5E-4862-8D73-ADE52E842283}" type="slidenum">
+            <a:fld id="{93D7449F-691E-409E-A0BD-4E82F2722AA0}" type="slidenum">
               <a:rPr lang="en-US" smtClean="0"/>
               <a:t>‹#›</a:t>
             </a:fld>
@@ -2136,7 +2136,7 @@
     </p:spTree>
     <p:extLst>
       <p:ext uri="{BB962C8B-B14F-4D97-AF65-F5344CB8AC3E}">
-        <p14:creationId xmlns:p14="http://schemas.microsoft.com/office/powerpoint/2010/main" val="806829619"/>
+        <p14:creationId xmlns:p14="http://schemas.microsoft.com/office/powerpoint/2010/main" val="3510144768"/>
       </p:ext>
     </p:extLst>
   </p:cSld>
@@ -2168,7 +2168,7 @@
           <p:cNvPr id="2" name="Title 1">
             <a:extLst>
               <a:ext uri="{FF2B5EF4-FFF2-40B4-BE49-F238E27FC236}">
-                <a16:creationId xmlns:a16="http://schemas.microsoft.com/office/drawing/2014/main" id="{E8A41180-39EC-0DF7-4E04-FB804DDF0D29}"/>
+                <a16:creationId xmlns:a16="http://schemas.microsoft.com/office/drawing/2014/main" id="{C237308E-A6C9-56F7-5582-CCE590074DC8}"/>
               </a:ext>
             </a:extLst>
           </p:cNvPr>
@@ -2205,7 +2205,7 @@
           <p:cNvPr id="3" name="Content Placeholder 2">
             <a:extLst>
               <a:ext uri="{FF2B5EF4-FFF2-40B4-BE49-F238E27FC236}">
-                <a16:creationId xmlns:a16="http://schemas.microsoft.com/office/drawing/2014/main" id="{8F691D25-881A-37DF-D8A0-D85493CE96F0}"/>
+                <a16:creationId xmlns:a16="http://schemas.microsoft.com/office/drawing/2014/main" id="{7B5EEE82-5CD0-A001-6712-D7F8835A4FA7}"/>
               </a:ext>
             </a:extLst>
           </p:cNvPr>
@@ -2295,7 +2295,7 @@
           <p:cNvPr id="4" name="Text Placeholder 3">
             <a:extLst>
               <a:ext uri="{FF2B5EF4-FFF2-40B4-BE49-F238E27FC236}">
-                <a16:creationId xmlns:a16="http://schemas.microsoft.com/office/drawing/2014/main" id="{8666E50B-1F25-724C-929A-2F3FD2096CDE}"/>
+                <a16:creationId xmlns:a16="http://schemas.microsoft.com/office/drawing/2014/main" id="{0D4F12B6-57EA-62D3-3402-9FFCD7A66D0E}"/>
               </a:ext>
             </a:extLst>
           </p:cNvPr>
@@ -2366,7 +2366,7 @@
           <p:cNvPr id="5" name="Date Placeholder 4">
             <a:extLst>
               <a:ext uri="{FF2B5EF4-FFF2-40B4-BE49-F238E27FC236}">
-                <a16:creationId xmlns:a16="http://schemas.microsoft.com/office/drawing/2014/main" id="{C667BC53-F6CF-F7D0-C1F7-B8D2EB3D76CF}"/>
+                <a16:creationId xmlns:a16="http://schemas.microsoft.com/office/drawing/2014/main" id="{1963CC5C-39B2-41D7-BC72-6E46C9B83115}"/>
               </a:ext>
             </a:extLst>
           </p:cNvPr>
@@ -2382,7 +2382,7 @@
           <a:bodyPr/>
           <a:lstStyle/>
           <a:p>
-            <a:fld id="{8B11D9D7-41B1-47D8-A1AC-A705D338CF64}" type="datetimeFigureOut">
+            <a:fld id="{8800BFBD-5516-4F51-BD4A-58548AF96EAA}" type="datetimeFigureOut">
               <a:rPr lang="en-US" smtClean="0"/>
               <a:t>9/23/2026</a:t>
             </a:fld>
@@ -2395,7 +2395,7 @@
           <p:cNvPr id="6" name="Footer Placeholder 5">
             <a:extLst>
               <a:ext uri="{FF2B5EF4-FFF2-40B4-BE49-F238E27FC236}">
-                <a16:creationId xmlns:a16="http://schemas.microsoft.com/office/drawing/2014/main" id="{9E07AA68-E3E3-FEBE-FB84-1043433778D7}"/>
+                <a16:creationId xmlns:a16="http://schemas.microsoft.com/office/drawing/2014/main" id="{5695C2DE-F06D-F5C3-0E2D-38C96E5307F9}"/>
               </a:ext>
             </a:extLst>
           </p:cNvPr>
@@ -2420,7 +2420,7 @@
           <p:cNvPr id="7" name="Slide Number Placeholder 6">
             <a:extLst>
               <a:ext uri="{FF2B5EF4-FFF2-40B4-BE49-F238E27FC236}">
-                <a16:creationId xmlns:a16="http://schemas.microsoft.com/office/drawing/2014/main" id="{29CADB35-705F-DA3E-A956-074552624AFF}"/>
+                <a16:creationId xmlns:a16="http://schemas.microsoft.com/office/drawing/2014/main" id="{4D89420C-CAAC-7C20-625E-883374120D4C}"/>
               </a:ext>
             </a:extLst>
           </p:cNvPr>
@@ -2436,7 +2436,7 @@
           <a:bodyPr/>
           <a:lstStyle/>
           <a:p>
-            <a:fld id="{C9D0E25E-EE5E-4862-8D73-ADE52E842283}" type="slidenum">
+            <a:fld id="{93D7449F-691E-409E-A0BD-4E82F2722AA0}" type="slidenum">
               <a:rPr lang="en-US" smtClean="0"/>
               <a:t>‹#›</a:t>
             </a:fld>
@@ -2447,7 +2447,7 @@
     </p:spTree>
     <p:extLst>
       <p:ext uri="{BB962C8B-B14F-4D97-AF65-F5344CB8AC3E}">
-        <p14:creationId xmlns:p14="http://schemas.microsoft.com/office/powerpoint/2010/main" val="2276895487"/>
+        <p14:creationId xmlns:p14="http://schemas.microsoft.com/office/powerpoint/2010/main" val="3462152770"/>
       </p:ext>
     </p:extLst>
   </p:cSld>
@@ -2479,7 +2479,7 @@
           <p:cNvPr id="2" name="Title 1">
             <a:extLst>
               <a:ext uri="{FF2B5EF4-FFF2-40B4-BE49-F238E27FC236}">
-                <a16:creationId xmlns:a16="http://schemas.microsoft.com/office/drawing/2014/main" id="{3E330B2E-BB33-79F7-15AB-53659D0F369E}"/>
+                <a16:creationId xmlns:a16="http://schemas.microsoft.com/office/drawing/2014/main" id="{A80B2FDC-7C30-C385-9A0B-D2E50E5DE6DE}"/>
               </a:ext>
             </a:extLst>
           </p:cNvPr>
@@ -2516,7 +2516,7 @@
           <p:cNvPr id="3" name="Picture Placeholder 2">
             <a:extLst>
               <a:ext uri="{FF2B5EF4-FFF2-40B4-BE49-F238E27FC236}">
-                <a16:creationId xmlns:a16="http://schemas.microsoft.com/office/drawing/2014/main" id="{1311314F-F29A-67A6-FD3A-E2168D09E572}"/>
+                <a16:creationId xmlns:a16="http://schemas.microsoft.com/office/drawing/2014/main" id="{5E55CC10-4ACE-4B63-2F1B-3B739E4EA09D}"/>
               </a:ext>
             </a:extLst>
           </p:cNvPr>
@@ -2583,7 +2583,7 @@
           <p:cNvPr id="4" name="Text Placeholder 3">
             <a:extLst>
               <a:ext uri="{FF2B5EF4-FFF2-40B4-BE49-F238E27FC236}">
-                <a16:creationId xmlns:a16="http://schemas.microsoft.com/office/drawing/2014/main" id="{F3831BCE-211A-2814-10D8-DB01D8957B83}"/>
+                <a16:creationId xmlns:a16="http://schemas.microsoft.com/office/drawing/2014/main" id="{74ED479E-71EF-0044-C717-BDAAF9A569C8}"/>
               </a:ext>
             </a:extLst>
           </p:cNvPr>
@@ -2654,7 +2654,7 @@
           <p:cNvPr id="5" name="Date Placeholder 4">
             <a:extLst>
               <a:ext uri="{FF2B5EF4-FFF2-40B4-BE49-F238E27FC236}">
-                <a16:creationId xmlns:a16="http://schemas.microsoft.com/office/drawing/2014/main" id="{48482EA8-663A-EFB4-80CF-99820D16150D}"/>
+                <a16:creationId xmlns:a16="http://schemas.microsoft.com/office/drawing/2014/main" id="{351448AB-4D63-3D67-CDC5-26268CEFED45}"/>
               </a:ext>
             </a:extLst>
           </p:cNvPr>
@@ -2670,7 +2670,7 @@
           <a:bodyPr/>
           <a:lstStyle/>
           <a:p>
-            <a:fld id="{8B11D9D7-41B1-47D8-A1AC-A705D338CF64}" type="datetimeFigureOut">
+            <a:fld id="{8800BFBD-5516-4F51-BD4A-58548AF96EAA}" type="datetimeFigureOut">
               <a:rPr lang="en-US" smtClean="0"/>
               <a:t>9/23/2026</a:t>
             </a:fld>
@@ -2683,7 +2683,7 @@
           <p:cNvPr id="6" name="Footer Placeholder 5">
             <a:extLst>
               <a:ext uri="{FF2B5EF4-FFF2-40B4-BE49-F238E27FC236}">
-                <a16:creationId xmlns:a16="http://schemas.microsoft.com/office/drawing/2014/main" id="{8505294D-D541-286C-E799-9488F647A915}"/>
+                <a16:creationId xmlns:a16="http://schemas.microsoft.com/office/drawing/2014/main" id="{1FB9927A-39C7-7CB5-79B5-B2A78EE66C86}"/>
               </a:ext>
             </a:extLst>
           </p:cNvPr>
@@ -2708,7 +2708,7 @@
           <p:cNvPr id="7" name="Slide Number Placeholder 6">
             <a:extLst>
               <a:ext uri="{FF2B5EF4-FFF2-40B4-BE49-F238E27FC236}">
-                <a16:creationId xmlns:a16="http://schemas.microsoft.com/office/drawing/2014/main" id="{55E3CCBE-E33B-EB55-29D9-52ECDC559676}"/>
+                <a16:creationId xmlns:a16="http://schemas.microsoft.com/office/drawing/2014/main" id="{3192110E-7262-2EF8-C203-7A3DAADECF0D}"/>
               </a:ext>
             </a:extLst>
           </p:cNvPr>
@@ -2724,7 +2724,7 @@
           <a:bodyPr/>
           <a:lstStyle/>
           <a:p>
-            <a:fld id="{C9D0E25E-EE5E-4862-8D73-ADE52E842283}" type="slidenum">
+            <a:fld id="{93D7449F-691E-409E-A0BD-4E82F2722AA0}" type="slidenum">
               <a:rPr lang="en-US" smtClean="0"/>
               <a:t>‹#›</a:t>
             </a:fld>
@@ -2735,7 +2735,7 @@
     </p:spTree>
     <p:extLst>
       <p:ext uri="{BB962C8B-B14F-4D97-AF65-F5344CB8AC3E}">
-        <p14:creationId xmlns:p14="http://schemas.microsoft.com/office/powerpoint/2010/main" val="3317415083"/>
+        <p14:creationId xmlns:p14="http://schemas.microsoft.com/office/powerpoint/2010/main" val="1484626268"/>
       </p:ext>
     </p:extLst>
   </p:cSld>
@@ -2772,7 +2772,7 @@
           <p:cNvPr id="2" name="Title Placeholder 1">
             <a:extLst>
               <a:ext uri="{FF2B5EF4-FFF2-40B4-BE49-F238E27FC236}">
-                <a16:creationId xmlns:a16="http://schemas.microsoft.com/office/drawing/2014/main" id="{EC3100CB-7820-61B2-F270-4AB8EC85BF5A}"/>
+                <a16:creationId xmlns:a16="http://schemas.microsoft.com/office/drawing/2014/main" id="{3FEC2AF7-D6AE-C2D1-81A1-3302D9888BFE}"/>
               </a:ext>
             </a:extLst>
           </p:cNvPr>
@@ -2810,7 +2810,7 @@
           <p:cNvPr id="3" name="Text Placeholder 2">
             <a:extLst>
               <a:ext uri="{FF2B5EF4-FFF2-40B4-BE49-F238E27FC236}">
-                <a16:creationId xmlns:a16="http://schemas.microsoft.com/office/drawing/2014/main" id="{A1A40DEE-2B5C-C3EA-024B-38491822D83C}"/>
+                <a16:creationId xmlns:a16="http://schemas.microsoft.com/office/drawing/2014/main" id="{F384E8BB-1E14-290E-6412-66B2F2DDBD37}"/>
               </a:ext>
             </a:extLst>
           </p:cNvPr>
@@ -2877,7 +2877,7 @@
           <p:cNvPr id="4" name="Date Placeholder 3">
             <a:extLst>
               <a:ext uri="{FF2B5EF4-FFF2-40B4-BE49-F238E27FC236}">
-                <a16:creationId xmlns:a16="http://schemas.microsoft.com/office/drawing/2014/main" id="{472D01F2-73C1-ED6A-64F5-AF941143DE3A}"/>
+                <a16:creationId xmlns:a16="http://schemas.microsoft.com/office/drawing/2014/main" id="{3E1A8254-01FC-45D6-C196-CBE94449EF39}"/>
               </a:ext>
             </a:extLst>
           </p:cNvPr>
@@ -2911,7 +2911,7 @@
             </a:lvl1pPr>
           </a:lstStyle>
           <a:p>
-            <a:fld id="{8B11D9D7-41B1-47D8-A1AC-A705D338CF64}" type="datetimeFigureOut">
+            <a:fld id="{8800BFBD-5516-4F51-BD4A-58548AF96EAA}" type="datetimeFigureOut">
               <a:rPr lang="en-US" smtClean="0"/>
               <a:t>9/23/2026</a:t>
             </a:fld>
@@ -2924,7 +2924,7 @@
           <p:cNvPr id="5" name="Footer Placeholder 4">
             <a:extLst>
               <a:ext uri="{FF2B5EF4-FFF2-40B4-BE49-F238E27FC236}">
-                <a16:creationId xmlns:a16="http://schemas.microsoft.com/office/drawing/2014/main" id="{C11BC001-84D0-6465-DEA2-8D240A26A8B2}"/>
+                <a16:creationId xmlns:a16="http://schemas.microsoft.com/office/drawing/2014/main" id="{72618C78-A0CC-F4F9-B9B5-D3AECE4887D6}"/>
               </a:ext>
             </a:extLst>
           </p:cNvPr>
@@ -2967,7 +2967,7 @@
           <p:cNvPr id="6" name="Slide Number Placeholder 5">
             <a:extLst>
               <a:ext uri="{FF2B5EF4-FFF2-40B4-BE49-F238E27FC236}">
-                <a16:creationId xmlns:a16="http://schemas.microsoft.com/office/drawing/2014/main" id="{DA2718F4-F8B8-ADB8-AEB6-7B8BC4F292E7}"/>
+                <a16:creationId xmlns:a16="http://schemas.microsoft.com/office/drawing/2014/main" id="{967FDFEB-E52B-5123-7818-74CCB900E052}"/>
               </a:ext>
             </a:extLst>
           </p:cNvPr>
@@ -3001,7 +3001,7 @@
             </a:lvl1pPr>
           </a:lstStyle>
           <a:p>
-            <a:fld id="{C9D0E25E-EE5E-4862-8D73-ADE52E842283}" type="slidenum">
+            <a:fld id="{93D7449F-691E-409E-A0BD-4E82F2722AA0}" type="slidenum">
               <a:rPr lang="en-US" smtClean="0"/>
               <a:t>‹#›</a:t>
             </a:fld>
@@ -3012,7 +3012,7 @@
     </p:spTree>
     <p:extLst>
       <p:ext uri="{BB962C8B-B14F-4D97-AF65-F5344CB8AC3E}">
-        <p14:creationId xmlns:p14="http://schemas.microsoft.com/office/powerpoint/2010/main" val="778818737"/>
+        <p14:creationId xmlns:p14="http://schemas.microsoft.com/office/powerpoint/2010/main" val="2771378778"/>
       </p:ext>
     </p:extLst>
   </p:cSld>
@@ -3335,7 +3335,7 @@
           <p:cNvPr id="3" name="Picture 2">
             <a:extLst>
               <a:ext uri="{FF2B5EF4-FFF2-40B4-BE49-F238E27FC236}">
-                <a16:creationId xmlns:a16="http://schemas.microsoft.com/office/drawing/2014/main" id="{E30DDF8B-8C81-9A36-CE4D-2F7708F23B40}"/>
+                <a16:creationId xmlns:a16="http://schemas.microsoft.com/office/drawing/2014/main" id="{70BC3642-5E9A-DBDB-A85C-ADA1EFE4FCCC}"/>
               </a:ext>
             </a:extLst>
           </p:cNvPr>
@@ -3369,7 +3369,7 @@
     </p:spTree>
     <p:extLst>
       <p:ext uri="{BB962C8B-B14F-4D97-AF65-F5344CB8AC3E}">
-        <p14:creationId xmlns:p14="http://schemas.microsoft.com/office/powerpoint/2010/main" val="1445477677"/>
+        <p14:creationId xmlns:p14="http://schemas.microsoft.com/office/powerpoint/2010/main" val="3855715464"/>
       </p:ext>
     </p:extLst>
   </p:cSld>
@@ -3401,7 +3401,7 @@
           <p:cNvPr id="3" name="Picture 2">
             <a:extLst>
               <a:ext uri="{FF2B5EF4-FFF2-40B4-BE49-F238E27FC236}">
-                <a16:creationId xmlns:a16="http://schemas.microsoft.com/office/drawing/2014/main" id="{B22C4E25-AC7B-2D7E-7A3A-940715AED012}"/>
+                <a16:creationId xmlns:a16="http://schemas.microsoft.com/office/drawing/2014/main" id="{3E5FB276-A32E-BD13-7545-143CD63149B1}"/>
               </a:ext>
             </a:extLst>
           </p:cNvPr>
@@ -3435,7 +3435,7 @@
     </p:spTree>
     <p:extLst>
       <p:ext uri="{BB962C8B-B14F-4D97-AF65-F5344CB8AC3E}">
-        <p14:creationId xmlns:p14="http://schemas.microsoft.com/office/powerpoint/2010/main" val="4074281100"/>
+        <p14:creationId xmlns:p14="http://schemas.microsoft.com/office/powerpoint/2010/main" val="1407150197"/>
       </p:ext>
     </p:extLst>
   </p:cSld>
@@ -3467,7 +3467,7 @@
           <p:cNvPr id="3" name="Picture 2">
             <a:extLst>
               <a:ext uri="{FF2B5EF4-FFF2-40B4-BE49-F238E27FC236}">
-                <a16:creationId xmlns:a16="http://schemas.microsoft.com/office/drawing/2014/main" id="{4709AFB4-F813-01AC-FCA0-53415CAF5E23}"/>
+                <a16:creationId xmlns:a16="http://schemas.microsoft.com/office/drawing/2014/main" id="{5D9E8808-595C-8CF7-5F56-AAC1B4AF4016}"/>
               </a:ext>
             </a:extLst>
           </p:cNvPr>
@@ -3501,7 +3501,7 @@
     </p:spTree>
     <p:extLst>
       <p:ext uri="{BB962C8B-B14F-4D97-AF65-F5344CB8AC3E}">
-        <p14:creationId xmlns:p14="http://schemas.microsoft.com/office/powerpoint/2010/main" val="2092928007"/>
+        <p14:creationId xmlns:p14="http://schemas.microsoft.com/office/powerpoint/2010/main" val="3342126637"/>
       </p:ext>
     </p:extLst>
   </p:cSld>
@@ -3533,7 +3533,7 @@
           <p:cNvPr id="3" name="Picture 2">
             <a:extLst>
               <a:ext uri="{FF2B5EF4-FFF2-40B4-BE49-F238E27FC236}">
-                <a16:creationId xmlns:a16="http://schemas.microsoft.com/office/drawing/2014/main" id="{81B15B77-7926-FF25-0E9B-E4E5A9091638}"/>
+                <a16:creationId xmlns:a16="http://schemas.microsoft.com/office/drawing/2014/main" id="{5B0082F5-1012-12DB-39D6-67387147A388}"/>
               </a:ext>
             </a:extLst>
           </p:cNvPr>
@@ -3567,7 +3567,7 @@
     </p:spTree>
     <p:extLst>
       <p:ext uri="{BB962C8B-B14F-4D97-AF65-F5344CB8AC3E}">
-        <p14:creationId xmlns:p14="http://schemas.microsoft.com/office/powerpoint/2010/main" val="2987077736"/>
+        <p14:creationId xmlns:p14="http://schemas.microsoft.com/office/powerpoint/2010/main" val="2001547687"/>
       </p:ext>
     </p:extLst>
   </p:cSld>
@@ -3599,7 +3599,7 @@
           <p:cNvPr id="3" name="Picture 2">
             <a:extLst>
               <a:ext uri="{FF2B5EF4-FFF2-40B4-BE49-F238E27FC236}">
-                <a16:creationId xmlns:a16="http://schemas.microsoft.com/office/drawing/2014/main" id="{50563130-081B-053C-A689-B642BC54E7C7}"/>
+                <a16:creationId xmlns:a16="http://schemas.microsoft.com/office/drawing/2014/main" id="{05F4B252-B91B-CF6C-5474-C89842EBC5F8}"/>
               </a:ext>
             </a:extLst>
           </p:cNvPr>
@@ -3633,7 +3633,7 @@
     </p:spTree>
     <p:extLst>
       <p:ext uri="{BB962C8B-B14F-4D97-AF65-F5344CB8AC3E}">
-        <p14:creationId xmlns:p14="http://schemas.microsoft.com/office/powerpoint/2010/main" val="3595300914"/>
+        <p14:creationId xmlns:p14="http://schemas.microsoft.com/office/powerpoint/2010/main" val="1584515112"/>
       </p:ext>
     </p:extLst>
   </p:cSld>
@@ -3665,7 +3665,7 @@
           <p:cNvPr id="3" name="Picture 2">
             <a:extLst>
               <a:ext uri="{FF2B5EF4-FFF2-40B4-BE49-F238E27FC236}">
-                <a16:creationId xmlns:a16="http://schemas.microsoft.com/office/drawing/2014/main" id="{85D09B8D-F987-84DB-6687-66204C608C85}"/>
+                <a16:creationId xmlns:a16="http://schemas.microsoft.com/office/drawing/2014/main" id="{698E13E1-8968-F63F-30FB-B8BB490BAD28}"/>
               </a:ext>
             </a:extLst>
           </p:cNvPr>
@@ -3699,7 +3699,7 @@
     </p:spTree>
     <p:extLst>
       <p:ext uri="{BB962C8B-B14F-4D97-AF65-F5344CB8AC3E}">
-        <p14:creationId xmlns:p14="http://schemas.microsoft.com/office/powerpoint/2010/main" val="2551754931"/>
+        <p14:creationId xmlns:p14="http://schemas.microsoft.com/office/powerpoint/2010/main" val="3738295432"/>
       </p:ext>
     </p:extLst>
   </p:cSld>
@@ -3731,7 +3731,7 @@
           <p:cNvPr id="3" name="Picture 2">
             <a:extLst>
               <a:ext uri="{FF2B5EF4-FFF2-40B4-BE49-F238E27FC236}">
-                <a16:creationId xmlns:a16="http://schemas.microsoft.com/office/drawing/2014/main" id="{36111742-C75C-F253-4786-C378E8A55DFD}"/>
+                <a16:creationId xmlns:a16="http://schemas.microsoft.com/office/drawing/2014/main" id="{50792781-5FAF-0A94-F7EA-8EBDAEF8519B}"/>
               </a:ext>
             </a:extLst>
           </p:cNvPr>
@@ -3765,7 +3765,7 @@
     </p:spTree>
     <p:extLst>
       <p:ext uri="{BB962C8B-B14F-4D97-AF65-F5344CB8AC3E}">
-        <p14:creationId xmlns:p14="http://schemas.microsoft.com/office/powerpoint/2010/main" val="389325593"/>
+        <p14:creationId xmlns:p14="http://schemas.microsoft.com/office/powerpoint/2010/main" val="3226802407"/>
       </p:ext>
     </p:extLst>
   </p:cSld>
@@ -3797,7 +3797,7 @@
           <p:cNvPr id="3" name="Picture 2">
             <a:extLst>
               <a:ext uri="{FF2B5EF4-FFF2-40B4-BE49-F238E27FC236}">
-                <a16:creationId xmlns:a16="http://schemas.microsoft.com/office/drawing/2014/main" id="{21120889-762D-EEFA-82B1-5E128784F29A}"/>
+                <a16:creationId xmlns:a16="http://schemas.microsoft.com/office/drawing/2014/main" id="{F583BEB9-3692-81BF-F95C-3983161803DC}"/>
               </a:ext>
             </a:extLst>
           </p:cNvPr>
@@ -3831,7 +3831,7 @@
     </p:spTree>
     <p:extLst>
       <p:ext uri="{BB962C8B-B14F-4D97-AF65-F5344CB8AC3E}">
-        <p14:creationId xmlns:p14="http://schemas.microsoft.com/office/powerpoint/2010/main" val="1931030547"/>
+        <p14:creationId xmlns:p14="http://schemas.microsoft.com/office/powerpoint/2010/main" val="1533139377"/>
       </p:ext>
     </p:extLst>
   </p:cSld>
@@ -3863,7 +3863,7 @@
           <p:cNvPr id="3" name="Picture 2">
             <a:extLst>
               <a:ext uri="{FF2B5EF4-FFF2-40B4-BE49-F238E27FC236}">
-                <a16:creationId xmlns:a16="http://schemas.microsoft.com/office/drawing/2014/main" id="{01C0E88D-2EAE-148B-D510-FAF6331E57C7}"/>
+                <a16:creationId xmlns:a16="http://schemas.microsoft.com/office/drawing/2014/main" id="{EEA53EBA-737B-9D21-E067-BC36D1D8C997}"/>
               </a:ext>
             </a:extLst>
           </p:cNvPr>
@@ -3897,7 +3897,7 @@
     </p:spTree>
     <p:extLst>
       <p:ext uri="{BB962C8B-B14F-4D97-AF65-F5344CB8AC3E}">
-        <p14:creationId xmlns:p14="http://schemas.microsoft.com/office/powerpoint/2010/main" val="1660681475"/>
+        <p14:creationId xmlns:p14="http://schemas.microsoft.com/office/powerpoint/2010/main" val="1401584878"/>
       </p:ext>
     </p:extLst>
   </p:cSld>
@@ -3929,7 +3929,7 @@
           <p:cNvPr id="3" name="Picture 2">
             <a:extLst>
               <a:ext uri="{FF2B5EF4-FFF2-40B4-BE49-F238E27FC236}">
-                <a16:creationId xmlns:a16="http://schemas.microsoft.com/office/drawing/2014/main" id="{8358333B-9F5F-BD4F-297D-6F54E20C3EBD}"/>
+                <a16:creationId xmlns:a16="http://schemas.microsoft.com/office/drawing/2014/main" id="{041FFFFB-6C6A-097B-0466-81C576EC869A}"/>
               </a:ext>
             </a:extLst>
           </p:cNvPr>
@@ -3963,7 +3963,7 @@
     </p:spTree>
     <p:extLst>
       <p:ext uri="{BB962C8B-B14F-4D97-AF65-F5344CB8AC3E}">
-        <p14:creationId xmlns:p14="http://schemas.microsoft.com/office/powerpoint/2010/main" val="3816704242"/>
+        <p14:creationId xmlns:p14="http://schemas.microsoft.com/office/powerpoint/2010/main" val="2725382868"/>
       </p:ext>
     </p:extLst>
   </p:cSld>

</xml_diff>

<commit_message>
Fill widescreen slides with deck content
</commit_message>
<xml_diff>
--- a/CareerCloset_Pitch_2_Exact.pptx
+++ b/CareerCloset_Pitch_2_Exact.pptx
@@ -138,7 +138,7 @@
           <p:cNvPr id="2" name="Title 1">
             <a:extLst>
               <a:ext uri="{FF2B5EF4-FFF2-40B4-BE49-F238E27FC236}">
-                <a16:creationId xmlns:a16="http://schemas.microsoft.com/office/drawing/2014/main" id="{210B46F9-496D-F302-5B5C-F8DF9CEFA1FE}"/>
+                <a16:creationId xmlns:a16="http://schemas.microsoft.com/office/drawing/2014/main" id="{B635B442-3FD8-562E-6078-54D95222A7F1}"/>
               </a:ext>
             </a:extLst>
           </p:cNvPr>
@@ -175,7 +175,7 @@
           <p:cNvPr id="3" name="Subtitle 2">
             <a:extLst>
               <a:ext uri="{FF2B5EF4-FFF2-40B4-BE49-F238E27FC236}">
-                <a16:creationId xmlns:a16="http://schemas.microsoft.com/office/drawing/2014/main" id="{E74281BA-2FD3-C44E-9879-78F19D5782FD}"/>
+                <a16:creationId xmlns:a16="http://schemas.microsoft.com/office/drawing/2014/main" id="{09F0CCF5-01F1-969D-387E-490ABBE83A4A}"/>
               </a:ext>
             </a:extLst>
           </p:cNvPr>
@@ -245,7 +245,7 @@
           <p:cNvPr id="4" name="Date Placeholder 3">
             <a:extLst>
               <a:ext uri="{FF2B5EF4-FFF2-40B4-BE49-F238E27FC236}">
-                <a16:creationId xmlns:a16="http://schemas.microsoft.com/office/drawing/2014/main" id="{12419C82-3CFC-31F8-A8E9-2727CAA94871}"/>
+                <a16:creationId xmlns:a16="http://schemas.microsoft.com/office/drawing/2014/main" id="{39F26718-7E45-C7A5-719F-ECF74527E190}"/>
               </a:ext>
             </a:extLst>
           </p:cNvPr>
@@ -261,7 +261,7 @@
           <a:bodyPr/>
           <a:lstStyle/>
           <a:p>
-            <a:fld id="{8800BFBD-5516-4F51-BD4A-58548AF96EAA}" type="datetimeFigureOut">
+            <a:fld id="{1E409AE1-23A2-4790-B645-6D81C555906F}" type="datetimeFigureOut">
               <a:rPr lang="en-US" smtClean="0"/>
               <a:t>9/23/2026</a:t>
             </a:fld>
@@ -274,7 +274,7 @@
           <p:cNvPr id="5" name="Footer Placeholder 4">
             <a:extLst>
               <a:ext uri="{FF2B5EF4-FFF2-40B4-BE49-F238E27FC236}">
-                <a16:creationId xmlns:a16="http://schemas.microsoft.com/office/drawing/2014/main" id="{32AA2653-0E3E-05AF-B9FA-75419DA6D69F}"/>
+                <a16:creationId xmlns:a16="http://schemas.microsoft.com/office/drawing/2014/main" id="{661D1F2F-EFD1-BA99-DECD-A994FECED8EA}"/>
               </a:ext>
             </a:extLst>
           </p:cNvPr>
@@ -299,7 +299,7 @@
           <p:cNvPr id="6" name="Slide Number Placeholder 5">
             <a:extLst>
               <a:ext uri="{FF2B5EF4-FFF2-40B4-BE49-F238E27FC236}">
-                <a16:creationId xmlns:a16="http://schemas.microsoft.com/office/drawing/2014/main" id="{C2B3E4A4-7E01-A5E6-D9F8-91DA64BC4774}"/>
+                <a16:creationId xmlns:a16="http://schemas.microsoft.com/office/drawing/2014/main" id="{1FEA25AE-6C3A-2589-E5CB-AB2EA382EC58}"/>
               </a:ext>
             </a:extLst>
           </p:cNvPr>
@@ -315,7 +315,7 @@
           <a:bodyPr/>
           <a:lstStyle/>
           <a:p>
-            <a:fld id="{93D7449F-691E-409E-A0BD-4E82F2722AA0}" type="slidenum">
+            <a:fld id="{DC132AD5-8E34-4489-B8A1-19829E9AF12A}" type="slidenum">
               <a:rPr lang="en-US" smtClean="0"/>
               <a:t>‹#›</a:t>
             </a:fld>
@@ -326,7 +326,7 @@
     </p:spTree>
     <p:extLst>
       <p:ext uri="{BB962C8B-B14F-4D97-AF65-F5344CB8AC3E}">
-        <p14:creationId xmlns:p14="http://schemas.microsoft.com/office/powerpoint/2010/main" val="348609193"/>
+        <p14:creationId xmlns:p14="http://schemas.microsoft.com/office/powerpoint/2010/main" val="1845390731"/>
       </p:ext>
     </p:extLst>
   </p:cSld>
@@ -358,7 +358,7 @@
           <p:cNvPr id="2" name="Title 1">
             <a:extLst>
               <a:ext uri="{FF2B5EF4-FFF2-40B4-BE49-F238E27FC236}">
-                <a16:creationId xmlns:a16="http://schemas.microsoft.com/office/drawing/2014/main" id="{B04A700F-3659-E5A9-E6B2-86E5FED81CD8}"/>
+                <a16:creationId xmlns:a16="http://schemas.microsoft.com/office/drawing/2014/main" id="{C3125EFD-A78D-87F8-6FBC-415F2484F7CA}"/>
               </a:ext>
             </a:extLst>
           </p:cNvPr>
@@ -386,7 +386,7 @@
           <p:cNvPr id="3" name="Vertical Text Placeholder 2">
             <a:extLst>
               <a:ext uri="{FF2B5EF4-FFF2-40B4-BE49-F238E27FC236}">
-                <a16:creationId xmlns:a16="http://schemas.microsoft.com/office/drawing/2014/main" id="{AA182387-90E2-8AF4-E26E-8A0F43C7A57A}"/>
+                <a16:creationId xmlns:a16="http://schemas.microsoft.com/office/drawing/2014/main" id="{CFEE1363-FCAC-7262-3957-14A92913144E}"/>
               </a:ext>
             </a:extLst>
           </p:cNvPr>
@@ -443,7 +443,7 @@
           <p:cNvPr id="4" name="Date Placeholder 3">
             <a:extLst>
               <a:ext uri="{FF2B5EF4-FFF2-40B4-BE49-F238E27FC236}">
-                <a16:creationId xmlns:a16="http://schemas.microsoft.com/office/drawing/2014/main" id="{7C9E4226-5A9F-5D78-238D-E5D5A5420C52}"/>
+                <a16:creationId xmlns:a16="http://schemas.microsoft.com/office/drawing/2014/main" id="{EF28E4F9-BF30-6BF7-6C1B-BAC8F4FE6DE2}"/>
               </a:ext>
             </a:extLst>
           </p:cNvPr>
@@ -459,7 +459,7 @@
           <a:bodyPr/>
           <a:lstStyle/>
           <a:p>
-            <a:fld id="{8800BFBD-5516-4F51-BD4A-58548AF96EAA}" type="datetimeFigureOut">
+            <a:fld id="{1E409AE1-23A2-4790-B645-6D81C555906F}" type="datetimeFigureOut">
               <a:rPr lang="en-US" smtClean="0"/>
               <a:t>9/23/2026</a:t>
             </a:fld>
@@ -472,7 +472,7 @@
           <p:cNvPr id="5" name="Footer Placeholder 4">
             <a:extLst>
               <a:ext uri="{FF2B5EF4-FFF2-40B4-BE49-F238E27FC236}">
-                <a16:creationId xmlns:a16="http://schemas.microsoft.com/office/drawing/2014/main" id="{A703F2BE-026B-9A18-50EC-848205BCB2DA}"/>
+                <a16:creationId xmlns:a16="http://schemas.microsoft.com/office/drawing/2014/main" id="{EB052A37-EBAC-8468-69AE-375DD2C06237}"/>
               </a:ext>
             </a:extLst>
           </p:cNvPr>
@@ -497,7 +497,7 @@
           <p:cNvPr id="6" name="Slide Number Placeholder 5">
             <a:extLst>
               <a:ext uri="{FF2B5EF4-FFF2-40B4-BE49-F238E27FC236}">
-                <a16:creationId xmlns:a16="http://schemas.microsoft.com/office/drawing/2014/main" id="{BF208FE7-2E12-CAD1-D313-A881608D666A}"/>
+                <a16:creationId xmlns:a16="http://schemas.microsoft.com/office/drawing/2014/main" id="{45F0528B-95CB-DA49-FB5C-064E7DFDA45E}"/>
               </a:ext>
             </a:extLst>
           </p:cNvPr>
@@ -513,7 +513,7 @@
           <a:bodyPr/>
           <a:lstStyle/>
           <a:p>
-            <a:fld id="{93D7449F-691E-409E-A0BD-4E82F2722AA0}" type="slidenum">
+            <a:fld id="{DC132AD5-8E34-4489-B8A1-19829E9AF12A}" type="slidenum">
               <a:rPr lang="en-US" smtClean="0"/>
               <a:t>‹#›</a:t>
             </a:fld>
@@ -524,7 +524,7 @@
     </p:spTree>
     <p:extLst>
       <p:ext uri="{BB962C8B-B14F-4D97-AF65-F5344CB8AC3E}">
-        <p14:creationId xmlns:p14="http://schemas.microsoft.com/office/powerpoint/2010/main" val="4032016024"/>
+        <p14:creationId xmlns:p14="http://schemas.microsoft.com/office/powerpoint/2010/main" val="2458316084"/>
       </p:ext>
     </p:extLst>
   </p:cSld>
@@ -556,7 +556,7 @@
           <p:cNvPr id="2" name="Vertical Title 1">
             <a:extLst>
               <a:ext uri="{FF2B5EF4-FFF2-40B4-BE49-F238E27FC236}">
-                <a16:creationId xmlns:a16="http://schemas.microsoft.com/office/drawing/2014/main" id="{020F61F8-6157-19B1-97EE-036240EDA2F8}"/>
+                <a16:creationId xmlns:a16="http://schemas.microsoft.com/office/drawing/2014/main" id="{CAA82021-C6ED-E521-D745-56C439B40251}"/>
               </a:ext>
             </a:extLst>
           </p:cNvPr>
@@ -589,7 +589,7 @@
           <p:cNvPr id="3" name="Vertical Text Placeholder 2">
             <a:extLst>
               <a:ext uri="{FF2B5EF4-FFF2-40B4-BE49-F238E27FC236}">
-                <a16:creationId xmlns:a16="http://schemas.microsoft.com/office/drawing/2014/main" id="{D9F0D121-30A8-962B-C4A0-EDB79262B50F}"/>
+                <a16:creationId xmlns:a16="http://schemas.microsoft.com/office/drawing/2014/main" id="{A0817DA7-1419-186F-B3CF-2F4EEA116DC1}"/>
               </a:ext>
             </a:extLst>
           </p:cNvPr>
@@ -651,7 +651,7 @@
           <p:cNvPr id="4" name="Date Placeholder 3">
             <a:extLst>
               <a:ext uri="{FF2B5EF4-FFF2-40B4-BE49-F238E27FC236}">
-                <a16:creationId xmlns:a16="http://schemas.microsoft.com/office/drawing/2014/main" id="{84256FD0-46B3-483E-0E53-A0273A587C61}"/>
+                <a16:creationId xmlns:a16="http://schemas.microsoft.com/office/drawing/2014/main" id="{94531A18-359A-2DF4-C85D-D91D7BF96C2B}"/>
               </a:ext>
             </a:extLst>
           </p:cNvPr>
@@ -667,7 +667,7 @@
           <a:bodyPr/>
           <a:lstStyle/>
           <a:p>
-            <a:fld id="{8800BFBD-5516-4F51-BD4A-58548AF96EAA}" type="datetimeFigureOut">
+            <a:fld id="{1E409AE1-23A2-4790-B645-6D81C555906F}" type="datetimeFigureOut">
               <a:rPr lang="en-US" smtClean="0"/>
               <a:t>9/23/2026</a:t>
             </a:fld>
@@ -680,7 +680,7 @@
           <p:cNvPr id="5" name="Footer Placeholder 4">
             <a:extLst>
               <a:ext uri="{FF2B5EF4-FFF2-40B4-BE49-F238E27FC236}">
-                <a16:creationId xmlns:a16="http://schemas.microsoft.com/office/drawing/2014/main" id="{C150D664-40D5-5B30-0353-D405D2E6CE7C}"/>
+                <a16:creationId xmlns:a16="http://schemas.microsoft.com/office/drawing/2014/main" id="{0C33F392-9B51-F628-0904-868F31B80F92}"/>
               </a:ext>
             </a:extLst>
           </p:cNvPr>
@@ -705,7 +705,7 @@
           <p:cNvPr id="6" name="Slide Number Placeholder 5">
             <a:extLst>
               <a:ext uri="{FF2B5EF4-FFF2-40B4-BE49-F238E27FC236}">
-                <a16:creationId xmlns:a16="http://schemas.microsoft.com/office/drawing/2014/main" id="{D4AD50B5-A8B6-E6CC-2CE4-1581D77FD886}"/>
+                <a16:creationId xmlns:a16="http://schemas.microsoft.com/office/drawing/2014/main" id="{EE3A3248-48A1-04AC-2EF0-BA56576BBFCF}"/>
               </a:ext>
             </a:extLst>
           </p:cNvPr>
@@ -721,7 +721,7 @@
           <a:bodyPr/>
           <a:lstStyle/>
           <a:p>
-            <a:fld id="{93D7449F-691E-409E-A0BD-4E82F2722AA0}" type="slidenum">
+            <a:fld id="{DC132AD5-8E34-4489-B8A1-19829E9AF12A}" type="slidenum">
               <a:rPr lang="en-US" smtClean="0"/>
               <a:t>‹#›</a:t>
             </a:fld>
@@ -732,7 +732,7 @@
     </p:spTree>
     <p:extLst>
       <p:ext uri="{BB962C8B-B14F-4D97-AF65-F5344CB8AC3E}">
-        <p14:creationId xmlns:p14="http://schemas.microsoft.com/office/powerpoint/2010/main" val="3191924681"/>
+        <p14:creationId xmlns:p14="http://schemas.microsoft.com/office/powerpoint/2010/main" val="1413564330"/>
       </p:ext>
     </p:extLst>
   </p:cSld>
@@ -764,7 +764,7 @@
           <p:cNvPr id="2" name="Title 1">
             <a:extLst>
               <a:ext uri="{FF2B5EF4-FFF2-40B4-BE49-F238E27FC236}">
-                <a16:creationId xmlns:a16="http://schemas.microsoft.com/office/drawing/2014/main" id="{445B0A8E-7478-D043-F5F1-20720BA173D6}"/>
+                <a16:creationId xmlns:a16="http://schemas.microsoft.com/office/drawing/2014/main" id="{3FF659D5-8AE1-ED08-5835-329F58A0319E}"/>
               </a:ext>
             </a:extLst>
           </p:cNvPr>
@@ -792,7 +792,7 @@
           <p:cNvPr id="3" name="Content Placeholder 2">
             <a:extLst>
               <a:ext uri="{FF2B5EF4-FFF2-40B4-BE49-F238E27FC236}">
-                <a16:creationId xmlns:a16="http://schemas.microsoft.com/office/drawing/2014/main" id="{EBE31935-1D66-F513-E8D4-7916656DC474}"/>
+                <a16:creationId xmlns:a16="http://schemas.microsoft.com/office/drawing/2014/main" id="{6A384586-B934-D7EF-398D-6F656532C5DA}"/>
               </a:ext>
             </a:extLst>
           </p:cNvPr>
@@ -849,7 +849,7 @@
           <p:cNvPr id="4" name="Date Placeholder 3">
             <a:extLst>
               <a:ext uri="{FF2B5EF4-FFF2-40B4-BE49-F238E27FC236}">
-                <a16:creationId xmlns:a16="http://schemas.microsoft.com/office/drawing/2014/main" id="{E6252E43-5CF9-CC8B-E61E-EBCFA275678F}"/>
+                <a16:creationId xmlns:a16="http://schemas.microsoft.com/office/drawing/2014/main" id="{B8FD223C-1BBA-3E97-24C7-FE31E268106C}"/>
               </a:ext>
             </a:extLst>
           </p:cNvPr>
@@ -865,7 +865,7 @@
           <a:bodyPr/>
           <a:lstStyle/>
           <a:p>
-            <a:fld id="{8800BFBD-5516-4F51-BD4A-58548AF96EAA}" type="datetimeFigureOut">
+            <a:fld id="{1E409AE1-23A2-4790-B645-6D81C555906F}" type="datetimeFigureOut">
               <a:rPr lang="en-US" smtClean="0"/>
               <a:t>9/23/2026</a:t>
             </a:fld>
@@ -878,7 +878,7 @@
           <p:cNvPr id="5" name="Footer Placeholder 4">
             <a:extLst>
               <a:ext uri="{FF2B5EF4-FFF2-40B4-BE49-F238E27FC236}">
-                <a16:creationId xmlns:a16="http://schemas.microsoft.com/office/drawing/2014/main" id="{F3707403-CA33-63AF-1C39-34F1903B0456}"/>
+                <a16:creationId xmlns:a16="http://schemas.microsoft.com/office/drawing/2014/main" id="{0BF26DD6-CD5C-2E2B-06FF-55772F362E62}"/>
               </a:ext>
             </a:extLst>
           </p:cNvPr>
@@ -903,7 +903,7 @@
           <p:cNvPr id="6" name="Slide Number Placeholder 5">
             <a:extLst>
               <a:ext uri="{FF2B5EF4-FFF2-40B4-BE49-F238E27FC236}">
-                <a16:creationId xmlns:a16="http://schemas.microsoft.com/office/drawing/2014/main" id="{F67B8BEA-B641-5393-7D55-4FDE511F7BF1}"/>
+                <a16:creationId xmlns:a16="http://schemas.microsoft.com/office/drawing/2014/main" id="{C773373A-C98C-3616-CA3E-B87F76FDD7D9}"/>
               </a:ext>
             </a:extLst>
           </p:cNvPr>
@@ -919,7 +919,7 @@
           <a:bodyPr/>
           <a:lstStyle/>
           <a:p>
-            <a:fld id="{93D7449F-691E-409E-A0BD-4E82F2722AA0}" type="slidenum">
+            <a:fld id="{DC132AD5-8E34-4489-B8A1-19829E9AF12A}" type="slidenum">
               <a:rPr lang="en-US" smtClean="0"/>
               <a:t>‹#›</a:t>
             </a:fld>
@@ -930,7 +930,7 @@
     </p:spTree>
     <p:extLst>
       <p:ext uri="{BB962C8B-B14F-4D97-AF65-F5344CB8AC3E}">
-        <p14:creationId xmlns:p14="http://schemas.microsoft.com/office/powerpoint/2010/main" val="1865172923"/>
+        <p14:creationId xmlns:p14="http://schemas.microsoft.com/office/powerpoint/2010/main" val="1566094334"/>
       </p:ext>
     </p:extLst>
   </p:cSld>
@@ -962,7 +962,7 @@
           <p:cNvPr id="2" name="Title 1">
             <a:extLst>
               <a:ext uri="{FF2B5EF4-FFF2-40B4-BE49-F238E27FC236}">
-                <a16:creationId xmlns:a16="http://schemas.microsoft.com/office/drawing/2014/main" id="{38A5546B-6F17-4876-707B-4E35FBBF803C}"/>
+                <a16:creationId xmlns:a16="http://schemas.microsoft.com/office/drawing/2014/main" id="{B1E3A193-FC87-8B92-BFC2-35D383B802BE}"/>
               </a:ext>
             </a:extLst>
           </p:cNvPr>
@@ -999,7 +999,7 @@
           <p:cNvPr id="3" name="Text Placeholder 2">
             <a:extLst>
               <a:ext uri="{FF2B5EF4-FFF2-40B4-BE49-F238E27FC236}">
-                <a16:creationId xmlns:a16="http://schemas.microsoft.com/office/drawing/2014/main" id="{32DBA6AE-DB46-27A7-8C91-6E95AD63377F}"/>
+                <a16:creationId xmlns:a16="http://schemas.microsoft.com/office/drawing/2014/main" id="{7664D527-C667-51BF-ED1E-6DEFE7460B2B}"/>
               </a:ext>
             </a:extLst>
           </p:cNvPr>
@@ -1124,7 +1124,7 @@
           <p:cNvPr id="4" name="Date Placeholder 3">
             <a:extLst>
               <a:ext uri="{FF2B5EF4-FFF2-40B4-BE49-F238E27FC236}">
-                <a16:creationId xmlns:a16="http://schemas.microsoft.com/office/drawing/2014/main" id="{75AED344-3818-F67F-CF21-8395988ABD73}"/>
+                <a16:creationId xmlns:a16="http://schemas.microsoft.com/office/drawing/2014/main" id="{238F33F1-B8BE-8057-B6A8-D12B24BCD9AA}"/>
               </a:ext>
             </a:extLst>
           </p:cNvPr>
@@ -1140,7 +1140,7 @@
           <a:bodyPr/>
           <a:lstStyle/>
           <a:p>
-            <a:fld id="{8800BFBD-5516-4F51-BD4A-58548AF96EAA}" type="datetimeFigureOut">
+            <a:fld id="{1E409AE1-23A2-4790-B645-6D81C555906F}" type="datetimeFigureOut">
               <a:rPr lang="en-US" smtClean="0"/>
               <a:t>9/23/2026</a:t>
             </a:fld>
@@ -1153,7 +1153,7 @@
           <p:cNvPr id="5" name="Footer Placeholder 4">
             <a:extLst>
               <a:ext uri="{FF2B5EF4-FFF2-40B4-BE49-F238E27FC236}">
-                <a16:creationId xmlns:a16="http://schemas.microsoft.com/office/drawing/2014/main" id="{C1396CC9-226C-E043-3F82-FB43DB536365}"/>
+                <a16:creationId xmlns:a16="http://schemas.microsoft.com/office/drawing/2014/main" id="{6E63EA54-76B4-8A3A-9A40-6CEF9D2DA039}"/>
               </a:ext>
             </a:extLst>
           </p:cNvPr>
@@ -1178,7 +1178,7 @@
           <p:cNvPr id="6" name="Slide Number Placeholder 5">
             <a:extLst>
               <a:ext uri="{FF2B5EF4-FFF2-40B4-BE49-F238E27FC236}">
-                <a16:creationId xmlns:a16="http://schemas.microsoft.com/office/drawing/2014/main" id="{65AD2002-3D2C-4AF7-6611-6EF2E9951A89}"/>
+                <a16:creationId xmlns:a16="http://schemas.microsoft.com/office/drawing/2014/main" id="{F1EC6444-149A-C81D-7D43-4F00A622340A}"/>
               </a:ext>
             </a:extLst>
           </p:cNvPr>
@@ -1194,7 +1194,7 @@
           <a:bodyPr/>
           <a:lstStyle/>
           <a:p>
-            <a:fld id="{93D7449F-691E-409E-A0BD-4E82F2722AA0}" type="slidenum">
+            <a:fld id="{DC132AD5-8E34-4489-B8A1-19829E9AF12A}" type="slidenum">
               <a:rPr lang="en-US" smtClean="0"/>
               <a:t>‹#›</a:t>
             </a:fld>
@@ -1205,7 +1205,7 @@
     </p:spTree>
     <p:extLst>
       <p:ext uri="{BB962C8B-B14F-4D97-AF65-F5344CB8AC3E}">
-        <p14:creationId xmlns:p14="http://schemas.microsoft.com/office/powerpoint/2010/main" val="4229844725"/>
+        <p14:creationId xmlns:p14="http://schemas.microsoft.com/office/powerpoint/2010/main" val="3636863568"/>
       </p:ext>
     </p:extLst>
   </p:cSld>
@@ -1237,7 +1237,7 @@
           <p:cNvPr id="2" name="Title 1">
             <a:extLst>
               <a:ext uri="{FF2B5EF4-FFF2-40B4-BE49-F238E27FC236}">
-                <a16:creationId xmlns:a16="http://schemas.microsoft.com/office/drawing/2014/main" id="{9BA324BC-8AD6-B391-45A3-335077EDC9F5}"/>
+                <a16:creationId xmlns:a16="http://schemas.microsoft.com/office/drawing/2014/main" id="{0E14DDA1-4076-64C5-D7B2-1F981D7704BE}"/>
               </a:ext>
             </a:extLst>
           </p:cNvPr>
@@ -1265,7 +1265,7 @@
           <p:cNvPr id="3" name="Content Placeholder 2">
             <a:extLst>
               <a:ext uri="{FF2B5EF4-FFF2-40B4-BE49-F238E27FC236}">
-                <a16:creationId xmlns:a16="http://schemas.microsoft.com/office/drawing/2014/main" id="{A54C2311-707D-783C-2BAA-69CC5DB9D0E0}"/>
+                <a16:creationId xmlns:a16="http://schemas.microsoft.com/office/drawing/2014/main" id="{C6E9596D-D386-F498-B415-1428A8603D38}"/>
               </a:ext>
             </a:extLst>
           </p:cNvPr>
@@ -1327,7 +1327,7 @@
           <p:cNvPr id="4" name="Content Placeholder 3">
             <a:extLst>
               <a:ext uri="{FF2B5EF4-FFF2-40B4-BE49-F238E27FC236}">
-                <a16:creationId xmlns:a16="http://schemas.microsoft.com/office/drawing/2014/main" id="{B655DA06-B9F6-D75B-6373-A5E7BCB3949B}"/>
+                <a16:creationId xmlns:a16="http://schemas.microsoft.com/office/drawing/2014/main" id="{AE190C89-3EDB-72C0-F9EE-3433E8E252C6}"/>
               </a:ext>
             </a:extLst>
           </p:cNvPr>
@@ -1389,7 +1389,7 @@
           <p:cNvPr id="5" name="Date Placeholder 4">
             <a:extLst>
               <a:ext uri="{FF2B5EF4-FFF2-40B4-BE49-F238E27FC236}">
-                <a16:creationId xmlns:a16="http://schemas.microsoft.com/office/drawing/2014/main" id="{952E3042-247A-3FCB-F359-353A3B7B9EEF}"/>
+                <a16:creationId xmlns:a16="http://schemas.microsoft.com/office/drawing/2014/main" id="{AAF57575-764C-1A4A-4E33-6C2ACB7A6C78}"/>
               </a:ext>
             </a:extLst>
           </p:cNvPr>
@@ -1405,7 +1405,7 @@
           <a:bodyPr/>
           <a:lstStyle/>
           <a:p>
-            <a:fld id="{8800BFBD-5516-4F51-BD4A-58548AF96EAA}" type="datetimeFigureOut">
+            <a:fld id="{1E409AE1-23A2-4790-B645-6D81C555906F}" type="datetimeFigureOut">
               <a:rPr lang="en-US" smtClean="0"/>
               <a:t>9/23/2026</a:t>
             </a:fld>
@@ -1418,7 +1418,7 @@
           <p:cNvPr id="6" name="Footer Placeholder 5">
             <a:extLst>
               <a:ext uri="{FF2B5EF4-FFF2-40B4-BE49-F238E27FC236}">
-                <a16:creationId xmlns:a16="http://schemas.microsoft.com/office/drawing/2014/main" id="{EA898C70-B238-9C68-68C8-7E90D688BC9D}"/>
+                <a16:creationId xmlns:a16="http://schemas.microsoft.com/office/drawing/2014/main" id="{8278DDF8-9F9D-6C6C-FED6-E80FA415190D}"/>
               </a:ext>
             </a:extLst>
           </p:cNvPr>
@@ -1443,7 +1443,7 @@
           <p:cNvPr id="7" name="Slide Number Placeholder 6">
             <a:extLst>
               <a:ext uri="{FF2B5EF4-FFF2-40B4-BE49-F238E27FC236}">
-                <a16:creationId xmlns:a16="http://schemas.microsoft.com/office/drawing/2014/main" id="{1B343875-7D47-2DC2-63D5-77D45F46F8D3}"/>
+                <a16:creationId xmlns:a16="http://schemas.microsoft.com/office/drawing/2014/main" id="{9BCD3F8B-CD32-EA69-9E5A-7E2B844FEC14}"/>
               </a:ext>
             </a:extLst>
           </p:cNvPr>
@@ -1459,7 +1459,7 @@
           <a:bodyPr/>
           <a:lstStyle/>
           <a:p>
-            <a:fld id="{93D7449F-691E-409E-A0BD-4E82F2722AA0}" type="slidenum">
+            <a:fld id="{DC132AD5-8E34-4489-B8A1-19829E9AF12A}" type="slidenum">
               <a:rPr lang="en-US" smtClean="0"/>
               <a:t>‹#›</a:t>
             </a:fld>
@@ -1470,7 +1470,7 @@
     </p:spTree>
     <p:extLst>
       <p:ext uri="{BB962C8B-B14F-4D97-AF65-F5344CB8AC3E}">
-        <p14:creationId xmlns:p14="http://schemas.microsoft.com/office/powerpoint/2010/main" val="3314901734"/>
+        <p14:creationId xmlns:p14="http://schemas.microsoft.com/office/powerpoint/2010/main" val="4021241785"/>
       </p:ext>
     </p:extLst>
   </p:cSld>
@@ -1502,7 +1502,7 @@
           <p:cNvPr id="2" name="Title 1">
             <a:extLst>
               <a:ext uri="{FF2B5EF4-FFF2-40B4-BE49-F238E27FC236}">
-                <a16:creationId xmlns:a16="http://schemas.microsoft.com/office/drawing/2014/main" id="{951C2D17-CCBD-B7E3-7C4A-A50B3B15E129}"/>
+                <a16:creationId xmlns:a16="http://schemas.microsoft.com/office/drawing/2014/main" id="{0D2EDC8B-C95F-358D-5723-DCBEFEB48909}"/>
               </a:ext>
             </a:extLst>
           </p:cNvPr>
@@ -1535,7 +1535,7 @@
           <p:cNvPr id="3" name="Text Placeholder 2">
             <a:extLst>
               <a:ext uri="{FF2B5EF4-FFF2-40B4-BE49-F238E27FC236}">
-                <a16:creationId xmlns:a16="http://schemas.microsoft.com/office/drawing/2014/main" id="{8048FE4C-903C-9A36-4536-BE5EB910F88B}"/>
+                <a16:creationId xmlns:a16="http://schemas.microsoft.com/office/drawing/2014/main" id="{F19AEA81-22CC-CC69-8BC5-F039227524FE}"/>
               </a:ext>
             </a:extLst>
           </p:cNvPr>
@@ -1606,7 +1606,7 @@
           <p:cNvPr id="4" name="Content Placeholder 3">
             <a:extLst>
               <a:ext uri="{FF2B5EF4-FFF2-40B4-BE49-F238E27FC236}">
-                <a16:creationId xmlns:a16="http://schemas.microsoft.com/office/drawing/2014/main" id="{01834598-861E-892D-B80E-4EB712298F7B}"/>
+                <a16:creationId xmlns:a16="http://schemas.microsoft.com/office/drawing/2014/main" id="{544DAE12-5493-4849-8457-51141372953B}"/>
               </a:ext>
             </a:extLst>
           </p:cNvPr>
@@ -1668,7 +1668,7 @@
           <p:cNvPr id="5" name="Text Placeholder 4">
             <a:extLst>
               <a:ext uri="{FF2B5EF4-FFF2-40B4-BE49-F238E27FC236}">
-                <a16:creationId xmlns:a16="http://schemas.microsoft.com/office/drawing/2014/main" id="{72A38688-177C-2869-F3A0-C1F60F35E284}"/>
+                <a16:creationId xmlns:a16="http://schemas.microsoft.com/office/drawing/2014/main" id="{7C1C5C73-448C-E4B0-BBC1-B105D1121F96}"/>
               </a:ext>
             </a:extLst>
           </p:cNvPr>
@@ -1739,7 +1739,7 @@
           <p:cNvPr id="6" name="Content Placeholder 5">
             <a:extLst>
               <a:ext uri="{FF2B5EF4-FFF2-40B4-BE49-F238E27FC236}">
-                <a16:creationId xmlns:a16="http://schemas.microsoft.com/office/drawing/2014/main" id="{99BD3B63-6F88-7B7F-EADF-72F534EED3B2}"/>
+                <a16:creationId xmlns:a16="http://schemas.microsoft.com/office/drawing/2014/main" id="{FF147D97-CAB7-026D-24A1-E63615DA554D}"/>
               </a:ext>
             </a:extLst>
           </p:cNvPr>
@@ -1801,7 +1801,7 @@
           <p:cNvPr id="7" name="Date Placeholder 6">
             <a:extLst>
               <a:ext uri="{FF2B5EF4-FFF2-40B4-BE49-F238E27FC236}">
-                <a16:creationId xmlns:a16="http://schemas.microsoft.com/office/drawing/2014/main" id="{DA9D7288-FDB1-A6D5-E681-580519D7E9CF}"/>
+                <a16:creationId xmlns:a16="http://schemas.microsoft.com/office/drawing/2014/main" id="{27E4624B-282B-43CE-0FED-A75CA5A29649}"/>
               </a:ext>
             </a:extLst>
           </p:cNvPr>
@@ -1817,7 +1817,7 @@
           <a:bodyPr/>
           <a:lstStyle/>
           <a:p>
-            <a:fld id="{8800BFBD-5516-4F51-BD4A-58548AF96EAA}" type="datetimeFigureOut">
+            <a:fld id="{1E409AE1-23A2-4790-B645-6D81C555906F}" type="datetimeFigureOut">
               <a:rPr lang="en-US" smtClean="0"/>
               <a:t>9/23/2026</a:t>
             </a:fld>
@@ -1830,7 +1830,7 @@
           <p:cNvPr id="8" name="Footer Placeholder 7">
             <a:extLst>
               <a:ext uri="{FF2B5EF4-FFF2-40B4-BE49-F238E27FC236}">
-                <a16:creationId xmlns:a16="http://schemas.microsoft.com/office/drawing/2014/main" id="{C9B0E22E-108F-2D7B-0691-67042D2F9C81}"/>
+                <a16:creationId xmlns:a16="http://schemas.microsoft.com/office/drawing/2014/main" id="{6F3ADC21-FDD1-D793-2227-EBFF3224BE41}"/>
               </a:ext>
             </a:extLst>
           </p:cNvPr>
@@ -1855,7 +1855,7 @@
           <p:cNvPr id="9" name="Slide Number Placeholder 8">
             <a:extLst>
               <a:ext uri="{FF2B5EF4-FFF2-40B4-BE49-F238E27FC236}">
-                <a16:creationId xmlns:a16="http://schemas.microsoft.com/office/drawing/2014/main" id="{8E51775B-250E-2612-2A5B-B08387385143}"/>
+                <a16:creationId xmlns:a16="http://schemas.microsoft.com/office/drawing/2014/main" id="{DC0AA37F-A2D9-65D1-3A41-00E2641CA827}"/>
               </a:ext>
             </a:extLst>
           </p:cNvPr>
@@ -1871,7 +1871,7 @@
           <a:bodyPr/>
           <a:lstStyle/>
           <a:p>
-            <a:fld id="{93D7449F-691E-409E-A0BD-4E82F2722AA0}" type="slidenum">
+            <a:fld id="{DC132AD5-8E34-4489-B8A1-19829E9AF12A}" type="slidenum">
               <a:rPr lang="en-US" smtClean="0"/>
               <a:t>‹#›</a:t>
             </a:fld>
@@ -1882,7 +1882,7 @@
     </p:spTree>
     <p:extLst>
       <p:ext uri="{BB962C8B-B14F-4D97-AF65-F5344CB8AC3E}">
-        <p14:creationId xmlns:p14="http://schemas.microsoft.com/office/powerpoint/2010/main" val="737884729"/>
+        <p14:creationId xmlns:p14="http://schemas.microsoft.com/office/powerpoint/2010/main" val="2845613243"/>
       </p:ext>
     </p:extLst>
   </p:cSld>
@@ -1914,7 +1914,7 @@
           <p:cNvPr id="2" name="Title 1">
             <a:extLst>
               <a:ext uri="{FF2B5EF4-FFF2-40B4-BE49-F238E27FC236}">
-                <a16:creationId xmlns:a16="http://schemas.microsoft.com/office/drawing/2014/main" id="{678B8A45-BDBA-502B-8E97-7B0CAD437B14}"/>
+                <a16:creationId xmlns:a16="http://schemas.microsoft.com/office/drawing/2014/main" id="{D47705F7-EB44-A764-FF85-ACB4A9287B6E}"/>
               </a:ext>
             </a:extLst>
           </p:cNvPr>
@@ -1942,7 +1942,7 @@
           <p:cNvPr id="3" name="Date Placeholder 2">
             <a:extLst>
               <a:ext uri="{FF2B5EF4-FFF2-40B4-BE49-F238E27FC236}">
-                <a16:creationId xmlns:a16="http://schemas.microsoft.com/office/drawing/2014/main" id="{F28FF551-B926-CA3B-B76E-C2F6BB9C1D81}"/>
+                <a16:creationId xmlns:a16="http://schemas.microsoft.com/office/drawing/2014/main" id="{A8051611-66EC-4012-FD59-4B07970059ED}"/>
               </a:ext>
             </a:extLst>
           </p:cNvPr>
@@ -1958,7 +1958,7 @@
           <a:bodyPr/>
           <a:lstStyle/>
           <a:p>
-            <a:fld id="{8800BFBD-5516-4F51-BD4A-58548AF96EAA}" type="datetimeFigureOut">
+            <a:fld id="{1E409AE1-23A2-4790-B645-6D81C555906F}" type="datetimeFigureOut">
               <a:rPr lang="en-US" smtClean="0"/>
               <a:t>9/23/2026</a:t>
             </a:fld>
@@ -1971,7 +1971,7 @@
           <p:cNvPr id="4" name="Footer Placeholder 3">
             <a:extLst>
               <a:ext uri="{FF2B5EF4-FFF2-40B4-BE49-F238E27FC236}">
-                <a16:creationId xmlns:a16="http://schemas.microsoft.com/office/drawing/2014/main" id="{6F39246A-906A-97F6-1F74-5445493A0892}"/>
+                <a16:creationId xmlns:a16="http://schemas.microsoft.com/office/drawing/2014/main" id="{520F12F8-D134-B26E-4A8C-C3CFBD594431}"/>
               </a:ext>
             </a:extLst>
           </p:cNvPr>
@@ -1996,7 +1996,7 @@
           <p:cNvPr id="5" name="Slide Number Placeholder 4">
             <a:extLst>
               <a:ext uri="{FF2B5EF4-FFF2-40B4-BE49-F238E27FC236}">
-                <a16:creationId xmlns:a16="http://schemas.microsoft.com/office/drawing/2014/main" id="{27899946-B23F-CDEB-2987-68D7BDDD9E6E}"/>
+                <a16:creationId xmlns:a16="http://schemas.microsoft.com/office/drawing/2014/main" id="{9A17A161-5B7B-1211-8DC6-0AB7B93A449D}"/>
               </a:ext>
             </a:extLst>
           </p:cNvPr>
@@ -2012,7 +2012,7 @@
           <a:bodyPr/>
           <a:lstStyle/>
           <a:p>
-            <a:fld id="{93D7449F-691E-409E-A0BD-4E82F2722AA0}" type="slidenum">
+            <a:fld id="{DC132AD5-8E34-4489-B8A1-19829E9AF12A}" type="slidenum">
               <a:rPr lang="en-US" smtClean="0"/>
               <a:t>‹#›</a:t>
             </a:fld>
@@ -2023,7 +2023,7 @@
     </p:spTree>
     <p:extLst>
       <p:ext uri="{BB962C8B-B14F-4D97-AF65-F5344CB8AC3E}">
-        <p14:creationId xmlns:p14="http://schemas.microsoft.com/office/powerpoint/2010/main" val="1937981950"/>
+        <p14:creationId xmlns:p14="http://schemas.microsoft.com/office/powerpoint/2010/main" val="2255107192"/>
       </p:ext>
     </p:extLst>
   </p:cSld>
@@ -2055,7 +2055,7 @@
           <p:cNvPr id="2" name="Date Placeholder 1">
             <a:extLst>
               <a:ext uri="{FF2B5EF4-FFF2-40B4-BE49-F238E27FC236}">
-                <a16:creationId xmlns:a16="http://schemas.microsoft.com/office/drawing/2014/main" id="{C6424F46-4CAE-9FAD-67E4-1C066624D74A}"/>
+                <a16:creationId xmlns:a16="http://schemas.microsoft.com/office/drawing/2014/main" id="{9B254B6A-9E81-1DA4-E4D6-7522CF761BA5}"/>
               </a:ext>
             </a:extLst>
           </p:cNvPr>
@@ -2071,7 +2071,7 @@
           <a:bodyPr/>
           <a:lstStyle/>
           <a:p>
-            <a:fld id="{8800BFBD-5516-4F51-BD4A-58548AF96EAA}" type="datetimeFigureOut">
+            <a:fld id="{1E409AE1-23A2-4790-B645-6D81C555906F}" type="datetimeFigureOut">
               <a:rPr lang="en-US" smtClean="0"/>
               <a:t>9/23/2026</a:t>
             </a:fld>
@@ -2084,7 +2084,7 @@
           <p:cNvPr id="3" name="Footer Placeholder 2">
             <a:extLst>
               <a:ext uri="{FF2B5EF4-FFF2-40B4-BE49-F238E27FC236}">
-                <a16:creationId xmlns:a16="http://schemas.microsoft.com/office/drawing/2014/main" id="{8A028DA2-618B-157E-9AF3-13E007FEAB18}"/>
+                <a16:creationId xmlns:a16="http://schemas.microsoft.com/office/drawing/2014/main" id="{3666ADF6-C7C1-A50A-8A84-702747FF0D6E}"/>
               </a:ext>
             </a:extLst>
           </p:cNvPr>
@@ -2109,7 +2109,7 @@
           <p:cNvPr id="4" name="Slide Number Placeholder 3">
             <a:extLst>
               <a:ext uri="{FF2B5EF4-FFF2-40B4-BE49-F238E27FC236}">
-                <a16:creationId xmlns:a16="http://schemas.microsoft.com/office/drawing/2014/main" id="{76A052BB-7174-174F-43E1-21A78F7F7C3B}"/>
+                <a16:creationId xmlns:a16="http://schemas.microsoft.com/office/drawing/2014/main" id="{EB28AF37-8B43-B5CC-2AAA-8364CA79B63D}"/>
               </a:ext>
             </a:extLst>
           </p:cNvPr>
@@ -2125,7 +2125,7 @@
           <a:bodyPr/>
           <a:lstStyle/>
           <a:p>
-            <a:fld id="{93D7449F-691E-409E-A0BD-4E82F2722AA0}" type="slidenum">
+            <a:fld id="{DC132AD5-8E34-4489-B8A1-19829E9AF12A}" type="slidenum">
               <a:rPr lang="en-US" smtClean="0"/>
               <a:t>‹#›</a:t>
             </a:fld>
@@ -2136,7 +2136,7 @@
     </p:spTree>
     <p:extLst>
       <p:ext uri="{BB962C8B-B14F-4D97-AF65-F5344CB8AC3E}">
-        <p14:creationId xmlns:p14="http://schemas.microsoft.com/office/powerpoint/2010/main" val="3510144768"/>
+        <p14:creationId xmlns:p14="http://schemas.microsoft.com/office/powerpoint/2010/main" val="2409522619"/>
       </p:ext>
     </p:extLst>
   </p:cSld>
@@ -2168,7 +2168,7 @@
           <p:cNvPr id="2" name="Title 1">
             <a:extLst>
               <a:ext uri="{FF2B5EF4-FFF2-40B4-BE49-F238E27FC236}">
-                <a16:creationId xmlns:a16="http://schemas.microsoft.com/office/drawing/2014/main" id="{C237308E-A6C9-56F7-5582-CCE590074DC8}"/>
+                <a16:creationId xmlns:a16="http://schemas.microsoft.com/office/drawing/2014/main" id="{D5D7C0D2-9BC6-EABC-1CA7-0CEBC35A98DA}"/>
               </a:ext>
             </a:extLst>
           </p:cNvPr>
@@ -2205,7 +2205,7 @@
           <p:cNvPr id="3" name="Content Placeholder 2">
             <a:extLst>
               <a:ext uri="{FF2B5EF4-FFF2-40B4-BE49-F238E27FC236}">
-                <a16:creationId xmlns:a16="http://schemas.microsoft.com/office/drawing/2014/main" id="{7B5EEE82-5CD0-A001-6712-D7F8835A4FA7}"/>
+                <a16:creationId xmlns:a16="http://schemas.microsoft.com/office/drawing/2014/main" id="{E17A6AD8-D194-BE7A-C7A6-7787DFF2D046}"/>
               </a:ext>
             </a:extLst>
           </p:cNvPr>
@@ -2295,7 +2295,7 @@
           <p:cNvPr id="4" name="Text Placeholder 3">
             <a:extLst>
               <a:ext uri="{FF2B5EF4-FFF2-40B4-BE49-F238E27FC236}">
-                <a16:creationId xmlns:a16="http://schemas.microsoft.com/office/drawing/2014/main" id="{0D4F12B6-57EA-62D3-3402-9FFCD7A66D0E}"/>
+                <a16:creationId xmlns:a16="http://schemas.microsoft.com/office/drawing/2014/main" id="{4E42153D-BFA1-B081-FF03-A532CF6A59A9}"/>
               </a:ext>
             </a:extLst>
           </p:cNvPr>
@@ -2366,7 +2366,7 @@
           <p:cNvPr id="5" name="Date Placeholder 4">
             <a:extLst>
               <a:ext uri="{FF2B5EF4-FFF2-40B4-BE49-F238E27FC236}">
-                <a16:creationId xmlns:a16="http://schemas.microsoft.com/office/drawing/2014/main" id="{1963CC5C-39B2-41D7-BC72-6E46C9B83115}"/>
+                <a16:creationId xmlns:a16="http://schemas.microsoft.com/office/drawing/2014/main" id="{D78B29D4-7CE1-4302-70C8-3CA1052B1F31}"/>
               </a:ext>
             </a:extLst>
           </p:cNvPr>
@@ -2382,7 +2382,7 @@
           <a:bodyPr/>
           <a:lstStyle/>
           <a:p>
-            <a:fld id="{8800BFBD-5516-4F51-BD4A-58548AF96EAA}" type="datetimeFigureOut">
+            <a:fld id="{1E409AE1-23A2-4790-B645-6D81C555906F}" type="datetimeFigureOut">
               <a:rPr lang="en-US" smtClean="0"/>
               <a:t>9/23/2026</a:t>
             </a:fld>
@@ -2395,7 +2395,7 @@
           <p:cNvPr id="6" name="Footer Placeholder 5">
             <a:extLst>
               <a:ext uri="{FF2B5EF4-FFF2-40B4-BE49-F238E27FC236}">
-                <a16:creationId xmlns:a16="http://schemas.microsoft.com/office/drawing/2014/main" id="{5695C2DE-F06D-F5C3-0E2D-38C96E5307F9}"/>
+                <a16:creationId xmlns:a16="http://schemas.microsoft.com/office/drawing/2014/main" id="{F2864FFF-7242-9414-838C-56C01C8863D3}"/>
               </a:ext>
             </a:extLst>
           </p:cNvPr>
@@ -2420,7 +2420,7 @@
           <p:cNvPr id="7" name="Slide Number Placeholder 6">
             <a:extLst>
               <a:ext uri="{FF2B5EF4-FFF2-40B4-BE49-F238E27FC236}">
-                <a16:creationId xmlns:a16="http://schemas.microsoft.com/office/drawing/2014/main" id="{4D89420C-CAAC-7C20-625E-883374120D4C}"/>
+                <a16:creationId xmlns:a16="http://schemas.microsoft.com/office/drawing/2014/main" id="{35E66626-02B7-0A73-D57B-BC08E832E96A}"/>
               </a:ext>
             </a:extLst>
           </p:cNvPr>
@@ -2436,7 +2436,7 @@
           <a:bodyPr/>
           <a:lstStyle/>
           <a:p>
-            <a:fld id="{93D7449F-691E-409E-A0BD-4E82F2722AA0}" type="slidenum">
+            <a:fld id="{DC132AD5-8E34-4489-B8A1-19829E9AF12A}" type="slidenum">
               <a:rPr lang="en-US" smtClean="0"/>
               <a:t>‹#›</a:t>
             </a:fld>
@@ -2447,7 +2447,7 @@
     </p:spTree>
     <p:extLst>
       <p:ext uri="{BB962C8B-B14F-4D97-AF65-F5344CB8AC3E}">
-        <p14:creationId xmlns:p14="http://schemas.microsoft.com/office/powerpoint/2010/main" val="3462152770"/>
+        <p14:creationId xmlns:p14="http://schemas.microsoft.com/office/powerpoint/2010/main" val="2235000084"/>
       </p:ext>
     </p:extLst>
   </p:cSld>
@@ -2479,7 +2479,7 @@
           <p:cNvPr id="2" name="Title 1">
             <a:extLst>
               <a:ext uri="{FF2B5EF4-FFF2-40B4-BE49-F238E27FC236}">
-                <a16:creationId xmlns:a16="http://schemas.microsoft.com/office/drawing/2014/main" id="{A80B2FDC-7C30-C385-9A0B-D2E50E5DE6DE}"/>
+                <a16:creationId xmlns:a16="http://schemas.microsoft.com/office/drawing/2014/main" id="{815C945D-9E09-2D58-D14B-6CB052F20184}"/>
               </a:ext>
             </a:extLst>
           </p:cNvPr>
@@ -2516,7 +2516,7 @@
           <p:cNvPr id="3" name="Picture Placeholder 2">
             <a:extLst>
               <a:ext uri="{FF2B5EF4-FFF2-40B4-BE49-F238E27FC236}">
-                <a16:creationId xmlns:a16="http://schemas.microsoft.com/office/drawing/2014/main" id="{5E55CC10-4ACE-4B63-2F1B-3B739E4EA09D}"/>
+                <a16:creationId xmlns:a16="http://schemas.microsoft.com/office/drawing/2014/main" id="{0693EBBC-B185-ED89-B11A-114902303325}"/>
               </a:ext>
             </a:extLst>
           </p:cNvPr>
@@ -2583,7 +2583,7 @@
           <p:cNvPr id="4" name="Text Placeholder 3">
             <a:extLst>
               <a:ext uri="{FF2B5EF4-FFF2-40B4-BE49-F238E27FC236}">
-                <a16:creationId xmlns:a16="http://schemas.microsoft.com/office/drawing/2014/main" id="{74ED479E-71EF-0044-C717-BDAAF9A569C8}"/>
+                <a16:creationId xmlns:a16="http://schemas.microsoft.com/office/drawing/2014/main" id="{02C17E53-412B-271D-1E61-E1283263D957}"/>
               </a:ext>
             </a:extLst>
           </p:cNvPr>
@@ -2654,7 +2654,7 @@
           <p:cNvPr id="5" name="Date Placeholder 4">
             <a:extLst>
               <a:ext uri="{FF2B5EF4-FFF2-40B4-BE49-F238E27FC236}">
-                <a16:creationId xmlns:a16="http://schemas.microsoft.com/office/drawing/2014/main" id="{351448AB-4D63-3D67-CDC5-26268CEFED45}"/>
+                <a16:creationId xmlns:a16="http://schemas.microsoft.com/office/drawing/2014/main" id="{7D8DB936-8BBF-6B03-8A73-BBF2DE8A8BA1}"/>
               </a:ext>
             </a:extLst>
           </p:cNvPr>
@@ -2670,7 +2670,7 @@
           <a:bodyPr/>
           <a:lstStyle/>
           <a:p>
-            <a:fld id="{8800BFBD-5516-4F51-BD4A-58548AF96EAA}" type="datetimeFigureOut">
+            <a:fld id="{1E409AE1-23A2-4790-B645-6D81C555906F}" type="datetimeFigureOut">
               <a:rPr lang="en-US" smtClean="0"/>
               <a:t>9/23/2026</a:t>
             </a:fld>
@@ -2683,7 +2683,7 @@
           <p:cNvPr id="6" name="Footer Placeholder 5">
             <a:extLst>
               <a:ext uri="{FF2B5EF4-FFF2-40B4-BE49-F238E27FC236}">
-                <a16:creationId xmlns:a16="http://schemas.microsoft.com/office/drawing/2014/main" id="{1FB9927A-39C7-7CB5-79B5-B2A78EE66C86}"/>
+                <a16:creationId xmlns:a16="http://schemas.microsoft.com/office/drawing/2014/main" id="{3622FFBF-1723-EAC3-A9D0-D9AF4195A425}"/>
               </a:ext>
             </a:extLst>
           </p:cNvPr>
@@ -2708,7 +2708,7 @@
           <p:cNvPr id="7" name="Slide Number Placeholder 6">
             <a:extLst>
               <a:ext uri="{FF2B5EF4-FFF2-40B4-BE49-F238E27FC236}">
-                <a16:creationId xmlns:a16="http://schemas.microsoft.com/office/drawing/2014/main" id="{3192110E-7262-2EF8-C203-7A3DAADECF0D}"/>
+                <a16:creationId xmlns:a16="http://schemas.microsoft.com/office/drawing/2014/main" id="{75DA6126-2F59-B626-4ABD-A47EE060CBB8}"/>
               </a:ext>
             </a:extLst>
           </p:cNvPr>
@@ -2724,7 +2724,7 @@
           <a:bodyPr/>
           <a:lstStyle/>
           <a:p>
-            <a:fld id="{93D7449F-691E-409E-A0BD-4E82F2722AA0}" type="slidenum">
+            <a:fld id="{DC132AD5-8E34-4489-B8A1-19829E9AF12A}" type="slidenum">
               <a:rPr lang="en-US" smtClean="0"/>
               <a:t>‹#›</a:t>
             </a:fld>
@@ -2735,7 +2735,7 @@
     </p:spTree>
     <p:extLst>
       <p:ext uri="{BB962C8B-B14F-4D97-AF65-F5344CB8AC3E}">
-        <p14:creationId xmlns:p14="http://schemas.microsoft.com/office/powerpoint/2010/main" val="1484626268"/>
+        <p14:creationId xmlns:p14="http://schemas.microsoft.com/office/powerpoint/2010/main" val="2266318750"/>
       </p:ext>
     </p:extLst>
   </p:cSld>
@@ -2772,7 +2772,7 @@
           <p:cNvPr id="2" name="Title Placeholder 1">
             <a:extLst>
               <a:ext uri="{FF2B5EF4-FFF2-40B4-BE49-F238E27FC236}">
-                <a16:creationId xmlns:a16="http://schemas.microsoft.com/office/drawing/2014/main" id="{3FEC2AF7-D6AE-C2D1-81A1-3302D9888BFE}"/>
+                <a16:creationId xmlns:a16="http://schemas.microsoft.com/office/drawing/2014/main" id="{7ECDC81E-E7E2-B4DE-6C71-0F907C4B17F1}"/>
               </a:ext>
             </a:extLst>
           </p:cNvPr>
@@ -2810,7 +2810,7 @@
           <p:cNvPr id="3" name="Text Placeholder 2">
             <a:extLst>
               <a:ext uri="{FF2B5EF4-FFF2-40B4-BE49-F238E27FC236}">
-                <a16:creationId xmlns:a16="http://schemas.microsoft.com/office/drawing/2014/main" id="{F384E8BB-1E14-290E-6412-66B2F2DDBD37}"/>
+                <a16:creationId xmlns:a16="http://schemas.microsoft.com/office/drawing/2014/main" id="{A2E884BA-BC47-6443-AF5A-48F295B0DAE2}"/>
               </a:ext>
             </a:extLst>
           </p:cNvPr>
@@ -2877,7 +2877,7 @@
           <p:cNvPr id="4" name="Date Placeholder 3">
             <a:extLst>
               <a:ext uri="{FF2B5EF4-FFF2-40B4-BE49-F238E27FC236}">
-                <a16:creationId xmlns:a16="http://schemas.microsoft.com/office/drawing/2014/main" id="{3E1A8254-01FC-45D6-C196-CBE94449EF39}"/>
+                <a16:creationId xmlns:a16="http://schemas.microsoft.com/office/drawing/2014/main" id="{E19B45B1-0384-9B85-E432-67D9A393B7DE}"/>
               </a:ext>
             </a:extLst>
           </p:cNvPr>
@@ -2911,7 +2911,7 @@
             </a:lvl1pPr>
           </a:lstStyle>
           <a:p>
-            <a:fld id="{8800BFBD-5516-4F51-BD4A-58548AF96EAA}" type="datetimeFigureOut">
+            <a:fld id="{1E409AE1-23A2-4790-B645-6D81C555906F}" type="datetimeFigureOut">
               <a:rPr lang="en-US" smtClean="0"/>
               <a:t>9/23/2026</a:t>
             </a:fld>
@@ -2924,7 +2924,7 @@
           <p:cNvPr id="5" name="Footer Placeholder 4">
             <a:extLst>
               <a:ext uri="{FF2B5EF4-FFF2-40B4-BE49-F238E27FC236}">
-                <a16:creationId xmlns:a16="http://schemas.microsoft.com/office/drawing/2014/main" id="{72618C78-A0CC-F4F9-B9B5-D3AECE4887D6}"/>
+                <a16:creationId xmlns:a16="http://schemas.microsoft.com/office/drawing/2014/main" id="{3100A900-38B7-7153-0A17-52EA84CD8B7A}"/>
               </a:ext>
             </a:extLst>
           </p:cNvPr>
@@ -2967,7 +2967,7 @@
           <p:cNvPr id="6" name="Slide Number Placeholder 5">
             <a:extLst>
               <a:ext uri="{FF2B5EF4-FFF2-40B4-BE49-F238E27FC236}">
-                <a16:creationId xmlns:a16="http://schemas.microsoft.com/office/drawing/2014/main" id="{967FDFEB-E52B-5123-7818-74CCB900E052}"/>
+                <a16:creationId xmlns:a16="http://schemas.microsoft.com/office/drawing/2014/main" id="{13DFCC44-B81B-3477-57AD-D3B0E354904A}"/>
               </a:ext>
             </a:extLst>
           </p:cNvPr>
@@ -3001,7 +3001,7 @@
             </a:lvl1pPr>
           </a:lstStyle>
           <a:p>
-            <a:fld id="{93D7449F-691E-409E-A0BD-4E82F2722AA0}" type="slidenum">
+            <a:fld id="{DC132AD5-8E34-4489-B8A1-19829E9AF12A}" type="slidenum">
               <a:rPr lang="en-US" smtClean="0"/>
               <a:t>‹#›</a:t>
             </a:fld>
@@ -3012,7 +3012,7 @@
     </p:spTree>
     <p:extLst>
       <p:ext uri="{BB962C8B-B14F-4D97-AF65-F5344CB8AC3E}">
-        <p14:creationId xmlns:p14="http://schemas.microsoft.com/office/powerpoint/2010/main" val="2771378778"/>
+        <p14:creationId xmlns:p14="http://schemas.microsoft.com/office/powerpoint/2010/main" val="3584852483"/>
       </p:ext>
     </p:extLst>
   </p:cSld>
@@ -3335,7 +3335,7 @@
           <p:cNvPr id="3" name="Picture 2">
             <a:extLst>
               <a:ext uri="{FF2B5EF4-FFF2-40B4-BE49-F238E27FC236}">
-                <a16:creationId xmlns:a16="http://schemas.microsoft.com/office/drawing/2014/main" id="{70BC3642-5E9A-DBDB-A85C-ADA1EFE4FCCC}"/>
+                <a16:creationId xmlns:a16="http://schemas.microsoft.com/office/drawing/2014/main" id="{2E47EDB6-3747-B3CD-14CB-C84D062D67EC}"/>
               </a:ext>
             </a:extLst>
           </p:cNvPr>
@@ -3369,7 +3369,7 @@
     </p:spTree>
     <p:extLst>
       <p:ext uri="{BB962C8B-B14F-4D97-AF65-F5344CB8AC3E}">
-        <p14:creationId xmlns:p14="http://schemas.microsoft.com/office/powerpoint/2010/main" val="3855715464"/>
+        <p14:creationId xmlns:p14="http://schemas.microsoft.com/office/powerpoint/2010/main" val="3559060475"/>
       </p:ext>
     </p:extLst>
   </p:cSld>
@@ -3401,7 +3401,7 @@
           <p:cNvPr id="3" name="Picture 2">
             <a:extLst>
               <a:ext uri="{FF2B5EF4-FFF2-40B4-BE49-F238E27FC236}">
-                <a16:creationId xmlns:a16="http://schemas.microsoft.com/office/drawing/2014/main" id="{3E5FB276-A32E-BD13-7545-143CD63149B1}"/>
+                <a16:creationId xmlns:a16="http://schemas.microsoft.com/office/drawing/2014/main" id="{BF6EE2A5-8E56-4EAA-E49F-996ABDAF542F}"/>
               </a:ext>
             </a:extLst>
           </p:cNvPr>
@@ -3435,7 +3435,7 @@
     </p:spTree>
     <p:extLst>
       <p:ext uri="{BB962C8B-B14F-4D97-AF65-F5344CB8AC3E}">
-        <p14:creationId xmlns:p14="http://schemas.microsoft.com/office/powerpoint/2010/main" val="1407150197"/>
+        <p14:creationId xmlns:p14="http://schemas.microsoft.com/office/powerpoint/2010/main" val="2761281643"/>
       </p:ext>
     </p:extLst>
   </p:cSld>
@@ -3467,7 +3467,7 @@
           <p:cNvPr id="3" name="Picture 2">
             <a:extLst>
               <a:ext uri="{FF2B5EF4-FFF2-40B4-BE49-F238E27FC236}">
-                <a16:creationId xmlns:a16="http://schemas.microsoft.com/office/drawing/2014/main" id="{5D9E8808-595C-8CF7-5F56-AAC1B4AF4016}"/>
+                <a16:creationId xmlns:a16="http://schemas.microsoft.com/office/drawing/2014/main" id="{07EE7240-1500-267C-26DB-0D810FD6B04B}"/>
               </a:ext>
             </a:extLst>
           </p:cNvPr>
@@ -3501,7 +3501,7 @@
     </p:spTree>
     <p:extLst>
       <p:ext uri="{BB962C8B-B14F-4D97-AF65-F5344CB8AC3E}">
-        <p14:creationId xmlns:p14="http://schemas.microsoft.com/office/powerpoint/2010/main" val="3342126637"/>
+        <p14:creationId xmlns:p14="http://schemas.microsoft.com/office/powerpoint/2010/main" val="592597354"/>
       </p:ext>
     </p:extLst>
   </p:cSld>
@@ -3533,7 +3533,7 @@
           <p:cNvPr id="3" name="Picture 2">
             <a:extLst>
               <a:ext uri="{FF2B5EF4-FFF2-40B4-BE49-F238E27FC236}">
-                <a16:creationId xmlns:a16="http://schemas.microsoft.com/office/drawing/2014/main" id="{5B0082F5-1012-12DB-39D6-67387147A388}"/>
+                <a16:creationId xmlns:a16="http://schemas.microsoft.com/office/drawing/2014/main" id="{D9131A03-E543-22F9-5DA8-C049BF7A0FD6}"/>
               </a:ext>
             </a:extLst>
           </p:cNvPr>
@@ -3567,7 +3567,7 @@
     </p:spTree>
     <p:extLst>
       <p:ext uri="{BB962C8B-B14F-4D97-AF65-F5344CB8AC3E}">
-        <p14:creationId xmlns:p14="http://schemas.microsoft.com/office/powerpoint/2010/main" val="2001547687"/>
+        <p14:creationId xmlns:p14="http://schemas.microsoft.com/office/powerpoint/2010/main" val="2942501507"/>
       </p:ext>
     </p:extLst>
   </p:cSld>
@@ -3599,7 +3599,7 @@
           <p:cNvPr id="3" name="Picture 2">
             <a:extLst>
               <a:ext uri="{FF2B5EF4-FFF2-40B4-BE49-F238E27FC236}">
-                <a16:creationId xmlns:a16="http://schemas.microsoft.com/office/drawing/2014/main" id="{05F4B252-B91B-CF6C-5474-C89842EBC5F8}"/>
+                <a16:creationId xmlns:a16="http://schemas.microsoft.com/office/drawing/2014/main" id="{90E179A1-BD8E-F1D2-5ECC-672CD6DB0684}"/>
               </a:ext>
             </a:extLst>
           </p:cNvPr>
@@ -3633,7 +3633,7 @@
     </p:spTree>
     <p:extLst>
       <p:ext uri="{BB962C8B-B14F-4D97-AF65-F5344CB8AC3E}">
-        <p14:creationId xmlns:p14="http://schemas.microsoft.com/office/powerpoint/2010/main" val="1584515112"/>
+        <p14:creationId xmlns:p14="http://schemas.microsoft.com/office/powerpoint/2010/main" val="1766736560"/>
       </p:ext>
     </p:extLst>
   </p:cSld>
@@ -3665,7 +3665,7 @@
           <p:cNvPr id="3" name="Picture 2">
             <a:extLst>
               <a:ext uri="{FF2B5EF4-FFF2-40B4-BE49-F238E27FC236}">
-                <a16:creationId xmlns:a16="http://schemas.microsoft.com/office/drawing/2014/main" id="{698E13E1-8968-F63F-30FB-B8BB490BAD28}"/>
+                <a16:creationId xmlns:a16="http://schemas.microsoft.com/office/drawing/2014/main" id="{3E886DA0-09AD-96C2-C87D-82F8CA041C5A}"/>
               </a:ext>
             </a:extLst>
           </p:cNvPr>
@@ -3699,7 +3699,7 @@
     </p:spTree>
     <p:extLst>
       <p:ext uri="{BB962C8B-B14F-4D97-AF65-F5344CB8AC3E}">
-        <p14:creationId xmlns:p14="http://schemas.microsoft.com/office/powerpoint/2010/main" val="3738295432"/>
+        <p14:creationId xmlns:p14="http://schemas.microsoft.com/office/powerpoint/2010/main" val="2021667692"/>
       </p:ext>
     </p:extLst>
   </p:cSld>
@@ -3731,7 +3731,7 @@
           <p:cNvPr id="3" name="Picture 2">
             <a:extLst>
               <a:ext uri="{FF2B5EF4-FFF2-40B4-BE49-F238E27FC236}">
-                <a16:creationId xmlns:a16="http://schemas.microsoft.com/office/drawing/2014/main" id="{50792781-5FAF-0A94-F7EA-8EBDAEF8519B}"/>
+                <a16:creationId xmlns:a16="http://schemas.microsoft.com/office/drawing/2014/main" id="{8D10C3E9-7DAC-45BC-BF54-51630ED5DFCB}"/>
               </a:ext>
             </a:extLst>
           </p:cNvPr>
@@ -3765,7 +3765,7 @@
     </p:spTree>
     <p:extLst>
       <p:ext uri="{BB962C8B-B14F-4D97-AF65-F5344CB8AC3E}">
-        <p14:creationId xmlns:p14="http://schemas.microsoft.com/office/powerpoint/2010/main" val="3226802407"/>
+        <p14:creationId xmlns:p14="http://schemas.microsoft.com/office/powerpoint/2010/main" val="1725935990"/>
       </p:ext>
     </p:extLst>
   </p:cSld>
@@ -3797,7 +3797,7 @@
           <p:cNvPr id="3" name="Picture 2">
             <a:extLst>
               <a:ext uri="{FF2B5EF4-FFF2-40B4-BE49-F238E27FC236}">
-                <a16:creationId xmlns:a16="http://schemas.microsoft.com/office/drawing/2014/main" id="{F583BEB9-3692-81BF-F95C-3983161803DC}"/>
+                <a16:creationId xmlns:a16="http://schemas.microsoft.com/office/drawing/2014/main" id="{FB3BECDC-C833-E46F-36BC-656859E7F491}"/>
               </a:ext>
             </a:extLst>
           </p:cNvPr>
@@ -3831,7 +3831,7 @@
     </p:spTree>
     <p:extLst>
       <p:ext uri="{BB962C8B-B14F-4D97-AF65-F5344CB8AC3E}">
-        <p14:creationId xmlns:p14="http://schemas.microsoft.com/office/powerpoint/2010/main" val="1533139377"/>
+        <p14:creationId xmlns:p14="http://schemas.microsoft.com/office/powerpoint/2010/main" val="1409561132"/>
       </p:ext>
     </p:extLst>
   </p:cSld>
@@ -3863,7 +3863,7 @@
           <p:cNvPr id="3" name="Picture 2">
             <a:extLst>
               <a:ext uri="{FF2B5EF4-FFF2-40B4-BE49-F238E27FC236}">
-                <a16:creationId xmlns:a16="http://schemas.microsoft.com/office/drawing/2014/main" id="{EEA53EBA-737B-9D21-E067-BC36D1D8C997}"/>
+                <a16:creationId xmlns:a16="http://schemas.microsoft.com/office/drawing/2014/main" id="{67A02218-D938-C144-8B17-EDC1184A5E85}"/>
               </a:ext>
             </a:extLst>
           </p:cNvPr>
@@ -3897,7 +3897,7 @@
     </p:spTree>
     <p:extLst>
       <p:ext uri="{BB962C8B-B14F-4D97-AF65-F5344CB8AC3E}">
-        <p14:creationId xmlns:p14="http://schemas.microsoft.com/office/powerpoint/2010/main" val="1401584878"/>
+        <p14:creationId xmlns:p14="http://schemas.microsoft.com/office/powerpoint/2010/main" val="23583993"/>
       </p:ext>
     </p:extLst>
   </p:cSld>
@@ -3929,7 +3929,7 @@
           <p:cNvPr id="3" name="Picture 2">
             <a:extLst>
               <a:ext uri="{FF2B5EF4-FFF2-40B4-BE49-F238E27FC236}">
-                <a16:creationId xmlns:a16="http://schemas.microsoft.com/office/drawing/2014/main" id="{041FFFFB-6C6A-097B-0466-81C576EC869A}"/>
+                <a16:creationId xmlns:a16="http://schemas.microsoft.com/office/drawing/2014/main" id="{102E74CC-DA54-CB0E-0925-33188F060322}"/>
               </a:ext>
             </a:extLst>
           </p:cNvPr>
@@ -3963,7 +3963,7 @@
     </p:spTree>
     <p:extLst>
       <p:ext uri="{BB962C8B-B14F-4D97-AF65-F5344CB8AC3E}">
-        <p14:creationId xmlns:p14="http://schemas.microsoft.com/office/powerpoint/2010/main" val="2725382868"/>
+        <p14:creationId xmlns:p14="http://schemas.microsoft.com/office/powerpoint/2010/main" val="2392723270"/>
       </p:ext>
     </p:extLst>
   </p:cSld>

</xml_diff>